<commit_message>
chore: regenerate business deck with fixed table layouts
</commit_message>
<xml_diff>
--- a/output/OAC_to_Fabric_Business_Deck.pptx
+++ b/output/OAC_to_Fabric_Business_Deck.pptx
@@ -9021,7 +9021,7 @@
         </p:nvGraphicFramePr>
         <p:xfrm>
           <a:off x="457200" y="2103120"/>
-          <a:ext cx="7132320" cy="5120640"/>
+          <a:ext cx="7132320" cy="3456432"/>
         </p:xfrm>
         <a:graphic>
           <a:graphicData uri="http://schemas.openxmlformats.org/drawingml/2006/table">
@@ -9037,14 +9037,14 @@
                 <a:gridCol w="822960"/>
                 <a:gridCol w="640080"/>
               </a:tblGrid>
-              <a:tr h="365760">
-                <a:tc>
-                  <a:txBody>
-                    <a:bodyPr/>
-                    <a:lstStyle/>
-                    <a:p>
-                      <a:pPr algn="ctr">
-                        <a:defRPr sz="1200" b="1">
+              <a:tr h="246888">
+                <a:tc>
+                  <a:txBody>
+                    <a:bodyPr/>
+                    <a:lstStyle/>
+                    <a:p>
+                      <a:pPr algn="ctr">
+                        <a:defRPr sz="1000" b="1">
                           <a:solidFill>
                             <a:srgbClr val="FFFFFF"/>
                           </a:solidFill>
@@ -9068,7 +9068,7 @@
                     <a:lstStyle/>
                     <a:p>
                       <a:pPr algn="ctr">
-                        <a:defRPr sz="1200" b="1">
+                        <a:defRPr sz="1000" b="1">
                           <a:solidFill>
                             <a:srgbClr val="FFFFFF"/>
                           </a:solidFill>
@@ -9092,7 +9092,7 @@
                     <a:lstStyle/>
                     <a:p>
                       <a:pPr algn="ctr">
-                        <a:defRPr sz="1200" b="1">
+                        <a:defRPr sz="1000" b="1">
                           <a:solidFill>
                             <a:srgbClr val="FFFFFF"/>
                           </a:solidFill>
@@ -9116,7 +9116,7 @@
                     <a:lstStyle/>
                     <a:p>
                       <a:pPr algn="ctr">
-                        <a:defRPr sz="1200" b="1">
+                        <a:defRPr sz="1000" b="1">
                           <a:solidFill>
                             <a:srgbClr val="FFFFFF"/>
                           </a:solidFill>
@@ -9140,7 +9140,7 @@
                     <a:lstStyle/>
                     <a:p>
                       <a:pPr algn="ctr">
-                        <a:defRPr sz="1200" b="1">
+                        <a:defRPr sz="1000" b="1">
                           <a:solidFill>
                             <a:srgbClr val="FFFFFF"/>
                           </a:solidFill>
@@ -9164,7 +9164,7 @@
                     <a:lstStyle/>
                     <a:p>
                       <a:pPr algn="ctr">
-                        <a:defRPr sz="1200" b="1">
+                        <a:defRPr sz="1000" b="1">
                           <a:solidFill>
                             <a:srgbClr val="FFFFFF"/>
                           </a:solidFill>
@@ -9183,14 +9183,14 @@
                   </a:tcPr>
                 </a:tc>
               </a:tr>
-              <a:tr h="365760">
-                <a:tc>
-                  <a:txBody>
-                    <a:bodyPr/>
-                    <a:lstStyle/>
-                    <a:p>
-                      <a:pPr algn="ctr">
-                        <a:defRPr sz="1200">
+              <a:tr h="246888">
+                <a:tc>
+                  <a:txBody>
+                    <a:bodyPr/>
+                    <a:lstStyle/>
+                    <a:p>
+                      <a:pPr algn="ctr">
+                        <a:defRPr sz="1000">
                           <a:solidFill>
                             <a:srgbClr val="000000"/>
                           </a:solidFill>
@@ -9214,7 +9214,7 @@
                     <a:lstStyle/>
                     <a:p>
                       <a:pPr algn="ctr">
-                        <a:defRPr sz="1200">
+                        <a:defRPr sz="1000">
                           <a:solidFill>
                             <a:srgbClr val="000000"/>
                           </a:solidFill>
@@ -9238,7 +9238,7 @@
                     <a:lstStyle/>
                     <a:p>
                       <a:pPr algn="ctr">
-                        <a:defRPr sz="1200" b="1">
+                        <a:defRPr sz="1000" b="1">
                           <a:solidFill>
                             <a:srgbClr val="107C10"/>
                           </a:solidFill>
@@ -9262,7 +9262,7 @@
                     <a:lstStyle/>
                     <a:p>
                       <a:pPr algn="ctr">
-                        <a:defRPr sz="1200" b="1">
+                        <a:defRPr sz="1000" b="1">
                           <a:solidFill>
                             <a:srgbClr val="FF8C00"/>
                           </a:solidFill>
@@ -9286,7 +9286,7 @@
                     <a:lstStyle/>
                     <a:p>
                       <a:pPr algn="ctr">
-                        <a:defRPr sz="1200">
+                        <a:defRPr sz="1000">
                           <a:solidFill>
                             <a:srgbClr val="000000"/>
                           </a:solidFill>
@@ -9310,7 +9310,7 @@
                     <a:lstStyle/>
                     <a:p>
                       <a:pPr algn="ctr">
-                        <a:defRPr sz="1200">
+                        <a:defRPr sz="1000">
                           <a:solidFill>
                             <a:srgbClr val="000000"/>
                           </a:solidFill>
@@ -9329,14 +9329,14 @@
                   </a:tcPr>
                 </a:tc>
               </a:tr>
-              <a:tr h="365760">
-                <a:tc>
-                  <a:txBody>
-                    <a:bodyPr/>
-                    <a:lstStyle/>
-                    <a:p>
-                      <a:pPr algn="ctr">
-                        <a:defRPr sz="1200">
+              <a:tr h="246888">
+                <a:tc>
+                  <a:txBody>
+                    <a:bodyPr/>
+                    <a:lstStyle/>
+                    <a:p>
+                      <a:pPr algn="ctr">
+                        <a:defRPr sz="1000">
                           <a:solidFill>
                             <a:srgbClr val="000000"/>
                           </a:solidFill>
@@ -9360,7 +9360,7 @@
                     <a:lstStyle/>
                     <a:p>
                       <a:pPr algn="ctr">
-                        <a:defRPr sz="1200">
+                        <a:defRPr sz="1000">
                           <a:solidFill>
                             <a:srgbClr val="000000"/>
                           </a:solidFill>
@@ -9384,7 +9384,7 @@
                     <a:lstStyle/>
                     <a:p>
                       <a:pPr algn="ctr">
-                        <a:defRPr sz="1200" b="1">
+                        <a:defRPr sz="1000" b="1">
                           <a:solidFill>
                             <a:srgbClr val="107C10"/>
                           </a:solidFill>
@@ -9408,7 +9408,7 @@
                     <a:lstStyle/>
                     <a:p>
                       <a:pPr algn="ctr">
-                        <a:defRPr sz="1200" b="1">
+                        <a:defRPr sz="1000" b="1">
                           <a:solidFill>
                             <a:srgbClr val="FF8C00"/>
                           </a:solidFill>
@@ -9432,7 +9432,7 @@
                     <a:lstStyle/>
                     <a:p>
                       <a:pPr algn="ctr">
-                        <a:defRPr sz="1200">
+                        <a:defRPr sz="1000">
                           <a:solidFill>
                             <a:srgbClr val="000000"/>
                           </a:solidFill>
@@ -9456,7 +9456,7 @@
                     <a:lstStyle/>
                     <a:p>
                       <a:pPr algn="ctr">
-                        <a:defRPr sz="1200">
+                        <a:defRPr sz="1000">
                           <a:solidFill>
                             <a:srgbClr val="000000"/>
                           </a:solidFill>
@@ -9475,14 +9475,14 @@
                   </a:tcPr>
                 </a:tc>
               </a:tr>
-              <a:tr h="365760">
-                <a:tc>
-                  <a:txBody>
-                    <a:bodyPr/>
-                    <a:lstStyle/>
-                    <a:p>
-                      <a:pPr algn="ctr">
-                        <a:defRPr sz="1200">
+              <a:tr h="246888">
+                <a:tc>
+                  <a:txBody>
+                    <a:bodyPr/>
+                    <a:lstStyle/>
+                    <a:p>
+                      <a:pPr algn="ctr">
+                        <a:defRPr sz="1000">
                           <a:solidFill>
                             <a:srgbClr val="000000"/>
                           </a:solidFill>
@@ -9506,7 +9506,7 @@
                     <a:lstStyle/>
                     <a:p>
                       <a:pPr algn="ctr">
-                        <a:defRPr sz="1200">
+                        <a:defRPr sz="1000">
                           <a:solidFill>
                             <a:srgbClr val="000000"/>
                           </a:solidFill>
@@ -9530,7 +9530,7 @@
                     <a:lstStyle/>
                     <a:p>
                       <a:pPr algn="ctr">
-                        <a:defRPr sz="1200" b="1">
+                        <a:defRPr sz="1000" b="1">
                           <a:solidFill>
                             <a:srgbClr val="107C10"/>
                           </a:solidFill>
@@ -9554,7 +9554,7 @@
                     <a:lstStyle/>
                     <a:p>
                       <a:pPr algn="ctr">
-                        <a:defRPr sz="1200">
+                        <a:defRPr sz="1000">
                           <a:solidFill>
                             <a:srgbClr val="000000"/>
                           </a:solidFill>
@@ -9578,7 +9578,7 @@
                     <a:lstStyle/>
                     <a:p>
                       <a:pPr algn="ctr">
-                        <a:defRPr sz="1200">
+                        <a:defRPr sz="1000">
                           <a:solidFill>
                             <a:srgbClr val="000000"/>
                           </a:solidFill>
@@ -9602,7 +9602,7 @@
                     <a:lstStyle/>
                     <a:p>
                       <a:pPr algn="ctr">
-                        <a:defRPr sz="1200">
+                        <a:defRPr sz="1000">
                           <a:solidFill>
                             <a:srgbClr val="000000"/>
                           </a:solidFill>
@@ -9621,14 +9621,14 @@
                   </a:tcPr>
                 </a:tc>
               </a:tr>
-              <a:tr h="365760">
-                <a:tc>
-                  <a:txBody>
-                    <a:bodyPr/>
-                    <a:lstStyle/>
-                    <a:p>
-                      <a:pPr algn="ctr">
-                        <a:defRPr sz="1200">
+              <a:tr h="246888">
+                <a:tc>
+                  <a:txBody>
+                    <a:bodyPr/>
+                    <a:lstStyle/>
+                    <a:p>
+                      <a:pPr algn="ctr">
+                        <a:defRPr sz="1000">
                           <a:solidFill>
                             <a:srgbClr val="000000"/>
                           </a:solidFill>
@@ -9652,7 +9652,7 @@
                     <a:lstStyle/>
                     <a:p>
                       <a:pPr algn="ctr">
-                        <a:defRPr sz="1200">
+                        <a:defRPr sz="1000">
                           <a:solidFill>
                             <a:srgbClr val="000000"/>
                           </a:solidFill>
@@ -9676,7 +9676,7 @@
                     <a:lstStyle/>
                     <a:p>
                       <a:pPr algn="ctr">
-                        <a:defRPr sz="1200" b="1">
+                        <a:defRPr sz="1000" b="1">
                           <a:solidFill>
                             <a:srgbClr val="107C10"/>
                           </a:solidFill>
@@ -9700,7 +9700,7 @@
                     <a:lstStyle/>
                     <a:p>
                       <a:pPr algn="ctr">
-                        <a:defRPr sz="1200" b="1">
+                        <a:defRPr sz="1000" b="1">
                           <a:solidFill>
                             <a:srgbClr val="FF8C00"/>
                           </a:solidFill>
@@ -9724,7 +9724,7 @@
                     <a:lstStyle/>
                     <a:p>
                       <a:pPr algn="ctr">
-                        <a:defRPr sz="1200">
+                        <a:defRPr sz="1000">
                           <a:solidFill>
                             <a:srgbClr val="000000"/>
                           </a:solidFill>
@@ -9748,7 +9748,7 @@
                     <a:lstStyle/>
                     <a:p>
                       <a:pPr algn="ctr">
-                        <a:defRPr sz="1200">
+                        <a:defRPr sz="1000">
                           <a:solidFill>
                             <a:srgbClr val="000000"/>
                           </a:solidFill>
@@ -9767,14 +9767,14 @@
                   </a:tcPr>
                 </a:tc>
               </a:tr>
-              <a:tr h="365760">
-                <a:tc>
-                  <a:txBody>
-                    <a:bodyPr/>
-                    <a:lstStyle/>
-                    <a:p>
-                      <a:pPr algn="ctr">
-                        <a:defRPr sz="1200">
+              <a:tr h="246888">
+                <a:tc>
+                  <a:txBody>
+                    <a:bodyPr/>
+                    <a:lstStyle/>
+                    <a:p>
+                      <a:pPr algn="ctr">
+                        <a:defRPr sz="1000">
                           <a:solidFill>
                             <a:srgbClr val="000000"/>
                           </a:solidFill>
@@ -9798,7 +9798,7 @@
                     <a:lstStyle/>
                     <a:p>
                       <a:pPr algn="ctr">
-                        <a:defRPr sz="1200">
+                        <a:defRPr sz="1000">
                           <a:solidFill>
                             <a:srgbClr val="000000"/>
                           </a:solidFill>
@@ -9822,7 +9822,7 @@
                     <a:lstStyle/>
                     <a:p>
                       <a:pPr algn="ctr">
-                        <a:defRPr sz="1200" b="1">
+                        <a:defRPr sz="1000" b="1">
                           <a:solidFill>
                             <a:srgbClr val="107C10"/>
                           </a:solidFill>
@@ -9846,7 +9846,7 @@
                     <a:lstStyle/>
                     <a:p>
                       <a:pPr algn="ctr">
-                        <a:defRPr sz="1200" b="1">
+                        <a:defRPr sz="1000" b="1">
                           <a:solidFill>
                             <a:srgbClr val="FF8C00"/>
                           </a:solidFill>
@@ -9870,7 +9870,7 @@
                     <a:lstStyle/>
                     <a:p>
                       <a:pPr algn="ctr">
-                        <a:defRPr sz="1200" b="1">
+                        <a:defRPr sz="1000" b="1">
                           <a:solidFill>
                             <a:srgbClr val="D13438"/>
                           </a:solidFill>
@@ -9894,7 +9894,7 @@
                     <a:lstStyle/>
                     <a:p>
                       <a:pPr algn="ctr">
-                        <a:defRPr sz="1200">
+                        <a:defRPr sz="1000">
                           <a:solidFill>
                             <a:srgbClr val="000000"/>
                           </a:solidFill>
@@ -9913,14 +9913,14 @@
                   </a:tcPr>
                 </a:tc>
               </a:tr>
-              <a:tr h="365760">
-                <a:tc>
-                  <a:txBody>
-                    <a:bodyPr/>
-                    <a:lstStyle/>
-                    <a:p>
-                      <a:pPr algn="ctr">
-                        <a:defRPr sz="1200">
+              <a:tr h="246888">
+                <a:tc>
+                  <a:txBody>
+                    <a:bodyPr/>
+                    <a:lstStyle/>
+                    <a:p>
+                      <a:pPr algn="ctr">
+                        <a:defRPr sz="1000">
                           <a:solidFill>
                             <a:srgbClr val="000000"/>
                           </a:solidFill>
@@ -9944,7 +9944,7 @@
                     <a:lstStyle/>
                     <a:p>
                       <a:pPr algn="ctr">
-                        <a:defRPr sz="1200">
+                        <a:defRPr sz="1000">
                           <a:solidFill>
                             <a:srgbClr val="000000"/>
                           </a:solidFill>
@@ -9968,7 +9968,7 @@
                     <a:lstStyle/>
                     <a:p>
                       <a:pPr algn="ctr">
-                        <a:defRPr sz="1200" b="1">
+                        <a:defRPr sz="1000" b="1">
                           <a:solidFill>
                             <a:srgbClr val="107C10"/>
                           </a:solidFill>
@@ -9992,7 +9992,7 @@
                     <a:lstStyle/>
                     <a:p>
                       <a:pPr algn="ctr">
-                        <a:defRPr sz="1200" b="1">
+                        <a:defRPr sz="1000" b="1">
                           <a:solidFill>
                             <a:srgbClr val="FF8C00"/>
                           </a:solidFill>
@@ -10016,7 +10016,7 @@
                     <a:lstStyle/>
                     <a:p>
                       <a:pPr algn="ctr">
-                        <a:defRPr sz="1200">
+                        <a:defRPr sz="1000">
                           <a:solidFill>
                             <a:srgbClr val="000000"/>
                           </a:solidFill>
@@ -10040,7 +10040,7 @@
                     <a:lstStyle/>
                     <a:p>
                       <a:pPr algn="ctr">
-                        <a:defRPr sz="1200">
+                        <a:defRPr sz="1000">
                           <a:solidFill>
                             <a:srgbClr val="000000"/>
                           </a:solidFill>
@@ -10059,14 +10059,14 @@
                   </a:tcPr>
                 </a:tc>
               </a:tr>
-              <a:tr h="365760">
-                <a:tc>
-                  <a:txBody>
-                    <a:bodyPr/>
-                    <a:lstStyle/>
-                    <a:p>
-                      <a:pPr algn="ctr">
-                        <a:defRPr sz="1200">
+              <a:tr h="246888">
+                <a:tc>
+                  <a:txBody>
+                    <a:bodyPr/>
+                    <a:lstStyle/>
+                    <a:p>
+                      <a:pPr algn="ctr">
+                        <a:defRPr sz="1000">
                           <a:solidFill>
                             <a:srgbClr val="000000"/>
                           </a:solidFill>
@@ -10090,7 +10090,7 @@
                     <a:lstStyle/>
                     <a:p>
                       <a:pPr algn="ctr">
-                        <a:defRPr sz="1200">
+                        <a:defRPr sz="1000">
                           <a:solidFill>
                             <a:srgbClr val="000000"/>
                           </a:solidFill>
@@ -10114,7 +10114,7 @@
                     <a:lstStyle/>
                     <a:p>
                       <a:pPr algn="ctr">
-                        <a:defRPr sz="1200" b="1">
+                        <a:defRPr sz="1000" b="1">
                           <a:solidFill>
                             <a:srgbClr val="107C10"/>
                           </a:solidFill>
@@ -10138,7 +10138,7 @@
                     <a:lstStyle/>
                     <a:p>
                       <a:pPr algn="ctr">
-                        <a:defRPr sz="1200" b="1">
+                        <a:defRPr sz="1000" b="1">
                           <a:solidFill>
                             <a:srgbClr val="FF8C00"/>
                           </a:solidFill>
@@ -10162,7 +10162,7 @@
                     <a:lstStyle/>
                     <a:p>
                       <a:pPr algn="ctr">
-                        <a:defRPr sz="1200" b="1">
+                        <a:defRPr sz="1000" b="1">
                           <a:solidFill>
                             <a:srgbClr val="D13438"/>
                           </a:solidFill>
@@ -10186,7 +10186,7 @@
                     <a:lstStyle/>
                     <a:p>
                       <a:pPr algn="ctr">
-                        <a:defRPr sz="1200" b="1">
+                        <a:defRPr sz="1000" b="1">
                           <a:solidFill>
                             <a:srgbClr val="606060"/>
                           </a:solidFill>
@@ -10205,14 +10205,14 @@
                   </a:tcPr>
                 </a:tc>
               </a:tr>
-              <a:tr h="365760">
-                <a:tc>
-                  <a:txBody>
-                    <a:bodyPr/>
-                    <a:lstStyle/>
-                    <a:p>
-                      <a:pPr algn="ctr">
-                        <a:defRPr sz="1200">
+              <a:tr h="246888">
+                <a:tc>
+                  <a:txBody>
+                    <a:bodyPr/>
+                    <a:lstStyle/>
+                    <a:p>
+                      <a:pPr algn="ctr">
+                        <a:defRPr sz="1000">
                           <a:solidFill>
                             <a:srgbClr val="000000"/>
                           </a:solidFill>
@@ -10236,7 +10236,7 @@
                     <a:lstStyle/>
                     <a:p>
                       <a:pPr algn="ctr">
-                        <a:defRPr sz="1200">
+                        <a:defRPr sz="1000">
                           <a:solidFill>
                             <a:srgbClr val="000000"/>
                           </a:solidFill>
@@ -10260,7 +10260,7 @@
                     <a:lstStyle/>
                     <a:p>
                       <a:pPr algn="ctr">
-                        <a:defRPr sz="1200" b="1">
+                        <a:defRPr sz="1000" b="1">
                           <a:solidFill>
                             <a:srgbClr val="107C10"/>
                           </a:solidFill>
@@ -10284,7 +10284,7 @@
                     <a:lstStyle/>
                     <a:p>
                       <a:pPr algn="ctr">
-                        <a:defRPr sz="1200" b="1">
+                        <a:defRPr sz="1000" b="1">
                           <a:solidFill>
                             <a:srgbClr val="FF8C00"/>
                           </a:solidFill>
@@ -10308,7 +10308,7 @@
                     <a:lstStyle/>
                     <a:p>
                       <a:pPr algn="ctr">
-                        <a:defRPr sz="1200">
+                        <a:defRPr sz="1000">
                           <a:solidFill>
                             <a:srgbClr val="000000"/>
                           </a:solidFill>
@@ -10332,7 +10332,7 @@
                     <a:lstStyle/>
                     <a:p>
                       <a:pPr algn="ctr">
-                        <a:defRPr sz="1200">
+                        <a:defRPr sz="1000">
                           <a:solidFill>
                             <a:srgbClr val="000000"/>
                           </a:solidFill>
@@ -10351,14 +10351,14 @@
                   </a:tcPr>
                 </a:tc>
               </a:tr>
-              <a:tr h="365760">
-                <a:tc>
-                  <a:txBody>
-                    <a:bodyPr/>
-                    <a:lstStyle/>
-                    <a:p>
-                      <a:pPr algn="ctr">
-                        <a:defRPr sz="1200">
+              <a:tr h="246888">
+                <a:tc>
+                  <a:txBody>
+                    <a:bodyPr/>
+                    <a:lstStyle/>
+                    <a:p>
+                      <a:pPr algn="ctr">
+                        <a:defRPr sz="1000">
                           <a:solidFill>
                             <a:srgbClr val="000000"/>
                           </a:solidFill>
@@ -10382,7 +10382,7 @@
                     <a:lstStyle/>
                     <a:p>
                       <a:pPr algn="ctr">
-                        <a:defRPr sz="1200">
+                        <a:defRPr sz="1000">
                           <a:solidFill>
                             <a:srgbClr val="000000"/>
                           </a:solidFill>
@@ -10406,7 +10406,7 @@
                     <a:lstStyle/>
                     <a:p>
                       <a:pPr algn="ctr">
-                        <a:defRPr sz="1200" b="1">
+                        <a:defRPr sz="1000" b="1">
                           <a:solidFill>
                             <a:srgbClr val="107C10"/>
                           </a:solidFill>
@@ -10430,7 +10430,7 @@
                     <a:lstStyle/>
                     <a:p>
                       <a:pPr algn="ctr">
-                        <a:defRPr sz="1200" b="1">
+                        <a:defRPr sz="1000" b="1">
                           <a:solidFill>
                             <a:srgbClr val="FF8C00"/>
                           </a:solidFill>
@@ -10454,7 +10454,7 @@
                     <a:lstStyle/>
                     <a:p>
                       <a:pPr algn="ctr">
-                        <a:defRPr sz="1200">
+                        <a:defRPr sz="1000">
                           <a:solidFill>
                             <a:srgbClr val="000000"/>
                           </a:solidFill>
@@ -10478,7 +10478,7 @@
                     <a:lstStyle/>
                     <a:p>
                       <a:pPr algn="ctr">
-                        <a:defRPr sz="1200">
+                        <a:defRPr sz="1000">
                           <a:solidFill>
                             <a:srgbClr val="000000"/>
                           </a:solidFill>
@@ -10497,14 +10497,14 @@
                   </a:tcPr>
                 </a:tc>
               </a:tr>
-              <a:tr h="365760">
-                <a:tc>
-                  <a:txBody>
-                    <a:bodyPr/>
-                    <a:lstStyle/>
-                    <a:p>
-                      <a:pPr algn="ctr">
-                        <a:defRPr sz="1200">
+              <a:tr h="246888">
+                <a:tc>
+                  <a:txBody>
+                    <a:bodyPr/>
+                    <a:lstStyle/>
+                    <a:p>
+                      <a:pPr algn="ctr">
+                        <a:defRPr sz="1000">
                           <a:solidFill>
                             <a:srgbClr val="000000"/>
                           </a:solidFill>
@@ -10528,7 +10528,7 @@
                     <a:lstStyle/>
                     <a:p>
                       <a:pPr algn="ctr">
-                        <a:defRPr sz="1200">
+                        <a:defRPr sz="1000">
                           <a:solidFill>
                             <a:srgbClr val="000000"/>
                           </a:solidFill>
@@ -10552,7 +10552,7 @@
                     <a:lstStyle/>
                     <a:p>
                       <a:pPr algn="ctr">
-                        <a:defRPr sz="1200" b="1">
+                        <a:defRPr sz="1000" b="1">
                           <a:solidFill>
                             <a:srgbClr val="107C10"/>
                           </a:solidFill>
@@ -10576,7 +10576,7 @@
                     <a:lstStyle/>
                     <a:p>
                       <a:pPr algn="ctr">
-                        <a:defRPr sz="1200" b="1">
+                        <a:defRPr sz="1000" b="1">
                           <a:solidFill>
                             <a:srgbClr val="FF8C00"/>
                           </a:solidFill>
@@ -10600,7 +10600,7 @@
                     <a:lstStyle/>
                     <a:p>
                       <a:pPr algn="ctr">
-                        <a:defRPr sz="1200">
+                        <a:defRPr sz="1000">
                           <a:solidFill>
                             <a:srgbClr val="000000"/>
                           </a:solidFill>
@@ -10624,7 +10624,7 @@
                     <a:lstStyle/>
                     <a:p>
                       <a:pPr algn="ctr">
-                        <a:defRPr sz="1200" b="1">
+                        <a:defRPr sz="1000" b="1">
                           <a:solidFill>
                             <a:srgbClr val="606060"/>
                           </a:solidFill>
@@ -10643,14 +10643,14 @@
                   </a:tcPr>
                 </a:tc>
               </a:tr>
-              <a:tr h="365760">
-                <a:tc>
-                  <a:txBody>
-                    <a:bodyPr/>
-                    <a:lstStyle/>
-                    <a:p>
-                      <a:pPr algn="ctr">
-                        <a:defRPr sz="1200">
+              <a:tr h="246888">
+                <a:tc>
+                  <a:txBody>
+                    <a:bodyPr/>
+                    <a:lstStyle/>
+                    <a:p>
+                      <a:pPr algn="ctr">
+                        <a:defRPr sz="1000">
                           <a:solidFill>
                             <a:srgbClr val="000000"/>
                           </a:solidFill>
@@ -10674,7 +10674,7 @@
                     <a:lstStyle/>
                     <a:p>
                       <a:pPr algn="ctr">
-                        <a:defRPr sz="1200">
+                        <a:defRPr sz="1000">
                           <a:solidFill>
                             <a:srgbClr val="000000"/>
                           </a:solidFill>
@@ -10698,7 +10698,7 @@
                     <a:lstStyle/>
                     <a:p>
                       <a:pPr algn="ctr">
-                        <a:defRPr sz="1200" b="1">
+                        <a:defRPr sz="1000" b="1">
                           <a:solidFill>
                             <a:srgbClr val="107C10"/>
                           </a:solidFill>
@@ -10722,7 +10722,7 @@
                     <a:lstStyle/>
                     <a:p>
                       <a:pPr algn="ctr">
-                        <a:defRPr sz="1200" b="1">
+                        <a:defRPr sz="1000" b="1">
                           <a:solidFill>
                             <a:srgbClr val="FF8C00"/>
                           </a:solidFill>
@@ -10746,7 +10746,7 @@
                     <a:lstStyle/>
                     <a:p>
                       <a:pPr algn="ctr">
-                        <a:defRPr sz="1200" b="1">
+                        <a:defRPr sz="1000" b="1">
                           <a:solidFill>
                             <a:srgbClr val="D13438"/>
                           </a:solidFill>
@@ -10770,7 +10770,7 @@
                     <a:lstStyle/>
                     <a:p>
                       <a:pPr algn="ctr">
-                        <a:defRPr sz="1200">
+                        <a:defRPr sz="1000">
                           <a:solidFill>
                             <a:srgbClr val="000000"/>
                           </a:solidFill>
@@ -10789,14 +10789,14 @@
                   </a:tcPr>
                 </a:tc>
               </a:tr>
-              <a:tr h="365760">
-                <a:tc>
-                  <a:txBody>
-                    <a:bodyPr/>
-                    <a:lstStyle/>
-                    <a:p>
-                      <a:pPr algn="ctr">
-                        <a:defRPr sz="1200">
+              <a:tr h="246888">
+                <a:tc>
+                  <a:txBody>
+                    <a:bodyPr/>
+                    <a:lstStyle/>
+                    <a:p>
+                      <a:pPr algn="ctr">
+                        <a:defRPr sz="1000">
                           <a:solidFill>
                             <a:srgbClr val="000000"/>
                           </a:solidFill>
@@ -10820,7 +10820,7 @@
                     <a:lstStyle/>
                     <a:p>
                       <a:pPr algn="ctr">
-                        <a:defRPr sz="1200">
+                        <a:defRPr sz="1000">
                           <a:solidFill>
                             <a:srgbClr val="000000"/>
                           </a:solidFill>
@@ -10844,7 +10844,7 @@
                     <a:lstStyle/>
                     <a:p>
                       <a:pPr algn="ctr">
-                        <a:defRPr sz="1200">
+                        <a:defRPr sz="1000">
                           <a:solidFill>
                             <a:srgbClr val="000000"/>
                           </a:solidFill>
@@ -10868,7 +10868,7 @@
                     <a:lstStyle/>
                     <a:p>
                       <a:pPr algn="ctr">
-                        <a:defRPr sz="1200" b="1">
+                        <a:defRPr sz="1000" b="1">
                           <a:solidFill>
                             <a:srgbClr val="FF8C00"/>
                           </a:solidFill>
@@ -10892,7 +10892,7 @@
                     <a:lstStyle/>
                     <a:p>
                       <a:pPr algn="ctr">
-                        <a:defRPr sz="1200">
+                        <a:defRPr sz="1000">
                           <a:solidFill>
                             <a:srgbClr val="000000"/>
                           </a:solidFill>
@@ -10916,7 +10916,7 @@
                     <a:lstStyle/>
                     <a:p>
                       <a:pPr algn="ctr">
-                        <a:defRPr sz="1200" b="1">
+                        <a:defRPr sz="1000" b="1">
                           <a:solidFill>
                             <a:srgbClr val="606060"/>
                           </a:solidFill>
@@ -10935,14 +10935,14 @@
                   </a:tcPr>
                 </a:tc>
               </a:tr>
-              <a:tr h="365760">
-                <a:tc>
-                  <a:txBody>
-                    <a:bodyPr/>
-                    <a:lstStyle/>
-                    <a:p>
-                      <a:pPr algn="ctr">
-                        <a:defRPr sz="1200">
+              <a:tr h="246888">
+                <a:tc>
+                  <a:txBody>
+                    <a:bodyPr/>
+                    <a:lstStyle/>
+                    <a:p>
+                      <a:pPr algn="ctr">
+                        <a:defRPr sz="1000">
                           <a:solidFill>
                             <a:srgbClr val="000000"/>
                           </a:solidFill>
@@ -10966,7 +10966,7 @@
                     <a:lstStyle/>
                     <a:p>
                       <a:pPr algn="ctr">
-                        <a:defRPr sz="1200">
+                        <a:defRPr sz="1000">
                           <a:solidFill>
                             <a:srgbClr val="000000"/>
                           </a:solidFill>
@@ -10990,7 +10990,7 @@
                     <a:lstStyle/>
                     <a:p>
                       <a:pPr algn="ctr">
-                        <a:defRPr sz="1200" b="1">
+                        <a:defRPr sz="1000" b="1">
                           <a:solidFill>
                             <a:srgbClr val="107C10"/>
                           </a:solidFill>
@@ -11014,7 +11014,7 @@
                     <a:lstStyle/>
                     <a:p>
                       <a:pPr algn="ctr">
-                        <a:defRPr sz="1200" b="1">
+                        <a:defRPr sz="1000" b="1">
                           <a:solidFill>
                             <a:srgbClr val="FF8C00"/>
                           </a:solidFill>
@@ -11038,7 +11038,7 @@
                     <a:lstStyle/>
                     <a:p>
                       <a:pPr algn="ctr">
-                        <a:defRPr sz="1200">
+                        <a:defRPr sz="1000">
                           <a:solidFill>
                             <a:srgbClr val="000000"/>
                           </a:solidFill>
@@ -11062,7 +11062,7 @@
                     <a:lstStyle/>
                     <a:p>
                       <a:pPr algn="ctr">
-                        <a:defRPr sz="1200">
+                        <a:defRPr sz="1000">
                           <a:solidFill>
                             <a:srgbClr val="000000"/>
                           </a:solidFill>
@@ -12465,7 +12465,7 @@
         </p:nvGraphicFramePr>
         <p:xfrm>
           <a:off x="274320" y="1554480"/>
-          <a:ext cx="4114800" cy="4389120"/>
+          <a:ext cx="4114800" cy="3291840"/>
         </p:xfrm>
         <a:graphic>
           <a:graphicData uri="http://schemas.openxmlformats.org/drawingml/2006/table">
@@ -12477,14 +12477,14 @@
                 <a:gridCol w="1828800"/>
                 <a:gridCol w="2286000"/>
               </a:tblGrid>
-              <a:tr h="365760">
-                <a:tc>
-                  <a:txBody>
-                    <a:bodyPr/>
-                    <a:lstStyle/>
-                    <a:p>
-                      <a:pPr algn="ctr">
-                        <a:defRPr sz="1200" b="1">
+              <a:tr h="274320">
+                <a:tc>
+                  <a:txBody>
+                    <a:bodyPr/>
+                    <a:lstStyle/>
+                    <a:p>
+                      <a:pPr algn="ctr">
+                        <a:defRPr sz="1000" b="1">
                           <a:solidFill>
                             <a:srgbClr val="FFFFFF"/>
                           </a:solidFill>
@@ -12508,7 +12508,7 @@
                     <a:lstStyle/>
                     <a:p>
                       <a:pPr algn="ctr">
-                        <a:defRPr sz="1200" b="1">
+                        <a:defRPr sz="1000" b="1">
                           <a:solidFill>
                             <a:srgbClr val="FFFFFF"/>
                           </a:solidFill>
@@ -12527,14 +12527,14 @@
                   </a:tcPr>
                 </a:tc>
               </a:tr>
-              <a:tr h="365760">
-                <a:tc>
-                  <a:txBody>
-                    <a:bodyPr/>
-                    <a:lstStyle/>
-                    <a:p>
-                      <a:pPr algn="ctr">
-                        <a:defRPr sz="1200">
+              <a:tr h="274320">
+                <a:tc>
+                  <a:txBody>
+                    <a:bodyPr/>
+                    <a:lstStyle/>
+                    <a:p>
+                      <a:pPr algn="ctr">
+                        <a:defRPr sz="1000">
                           <a:solidFill>
                             <a:srgbClr val="000000"/>
                           </a:solidFill>
@@ -12558,7 +12558,7 @@
                     <a:lstStyle/>
                     <a:p>
                       <a:pPr algn="ctr">
-                        <a:defRPr sz="1200">
+                        <a:defRPr sz="1000">
                           <a:solidFill>
                             <a:srgbClr val="000000"/>
                           </a:solidFill>
@@ -12577,14 +12577,14 @@
                   </a:tcPr>
                 </a:tc>
               </a:tr>
-              <a:tr h="365760">
-                <a:tc>
-                  <a:txBody>
-                    <a:bodyPr/>
-                    <a:lstStyle/>
-                    <a:p>
-                      <a:pPr algn="ctr">
-                        <a:defRPr sz="1200">
+              <a:tr h="274320">
+                <a:tc>
+                  <a:txBody>
+                    <a:bodyPr/>
+                    <a:lstStyle/>
+                    <a:p>
+                      <a:pPr algn="ctr">
+                        <a:defRPr sz="1000">
                           <a:solidFill>
                             <a:srgbClr val="000000"/>
                           </a:solidFill>
@@ -12608,7 +12608,7 @@
                     <a:lstStyle/>
                     <a:p>
                       <a:pPr algn="ctr">
-                        <a:defRPr sz="1200">
+                        <a:defRPr sz="1000">
                           <a:solidFill>
                             <a:srgbClr val="000000"/>
                           </a:solidFill>
@@ -12627,14 +12627,14 @@
                   </a:tcPr>
                 </a:tc>
               </a:tr>
-              <a:tr h="365760">
-                <a:tc>
-                  <a:txBody>
-                    <a:bodyPr/>
-                    <a:lstStyle/>
-                    <a:p>
-                      <a:pPr algn="ctr">
-                        <a:defRPr sz="1200">
+              <a:tr h="274320">
+                <a:tc>
+                  <a:txBody>
+                    <a:bodyPr/>
+                    <a:lstStyle/>
+                    <a:p>
+                      <a:pPr algn="ctr">
+                        <a:defRPr sz="1000">
                           <a:solidFill>
                             <a:srgbClr val="000000"/>
                           </a:solidFill>
@@ -12658,7 +12658,7 @@
                     <a:lstStyle/>
                     <a:p>
                       <a:pPr algn="ctr">
-                        <a:defRPr sz="1200">
+                        <a:defRPr sz="1000">
                           <a:solidFill>
                             <a:srgbClr val="000000"/>
                           </a:solidFill>
@@ -12677,14 +12677,14 @@
                   </a:tcPr>
                 </a:tc>
               </a:tr>
-              <a:tr h="365760">
-                <a:tc>
-                  <a:txBody>
-                    <a:bodyPr/>
-                    <a:lstStyle/>
-                    <a:p>
-                      <a:pPr algn="ctr">
-                        <a:defRPr sz="1200">
+              <a:tr h="274320">
+                <a:tc>
+                  <a:txBody>
+                    <a:bodyPr/>
+                    <a:lstStyle/>
+                    <a:p>
+                      <a:pPr algn="ctr">
+                        <a:defRPr sz="1000">
                           <a:solidFill>
                             <a:srgbClr val="000000"/>
                           </a:solidFill>
@@ -12708,7 +12708,7 @@
                     <a:lstStyle/>
                     <a:p>
                       <a:pPr algn="ctr">
-                        <a:defRPr sz="1200">
+                        <a:defRPr sz="1000">
                           <a:solidFill>
                             <a:srgbClr val="000000"/>
                           </a:solidFill>
@@ -12727,14 +12727,14 @@
                   </a:tcPr>
                 </a:tc>
               </a:tr>
-              <a:tr h="365760">
-                <a:tc>
-                  <a:txBody>
-                    <a:bodyPr/>
-                    <a:lstStyle/>
-                    <a:p>
-                      <a:pPr algn="ctr">
-                        <a:defRPr sz="1200">
+              <a:tr h="274320">
+                <a:tc>
+                  <a:txBody>
+                    <a:bodyPr/>
+                    <a:lstStyle/>
+                    <a:p>
+                      <a:pPr algn="ctr">
+                        <a:defRPr sz="1000">
                           <a:solidFill>
                             <a:srgbClr val="000000"/>
                           </a:solidFill>
@@ -12758,7 +12758,7 @@
                     <a:lstStyle/>
                     <a:p>
                       <a:pPr algn="ctr">
-                        <a:defRPr sz="1200">
+                        <a:defRPr sz="1000">
                           <a:solidFill>
                             <a:srgbClr val="000000"/>
                           </a:solidFill>
@@ -12777,14 +12777,14 @@
                   </a:tcPr>
                 </a:tc>
               </a:tr>
-              <a:tr h="365760">
-                <a:tc>
-                  <a:txBody>
-                    <a:bodyPr/>
-                    <a:lstStyle/>
-                    <a:p>
-                      <a:pPr algn="ctr">
-                        <a:defRPr sz="1200">
+              <a:tr h="274320">
+                <a:tc>
+                  <a:txBody>
+                    <a:bodyPr/>
+                    <a:lstStyle/>
+                    <a:p>
+                      <a:pPr algn="ctr">
+                        <a:defRPr sz="1000">
                           <a:solidFill>
                             <a:srgbClr val="000000"/>
                           </a:solidFill>
@@ -12808,7 +12808,7 @@
                     <a:lstStyle/>
                     <a:p>
                       <a:pPr algn="ctr">
-                        <a:defRPr sz="1200">
+                        <a:defRPr sz="1000">
                           <a:solidFill>
                             <a:srgbClr val="000000"/>
                           </a:solidFill>
@@ -12827,14 +12827,14 @@
                   </a:tcPr>
                 </a:tc>
               </a:tr>
-              <a:tr h="365760">
-                <a:tc>
-                  <a:txBody>
-                    <a:bodyPr/>
-                    <a:lstStyle/>
-                    <a:p>
-                      <a:pPr algn="ctr">
-                        <a:defRPr sz="1200">
+              <a:tr h="274320">
+                <a:tc>
+                  <a:txBody>
+                    <a:bodyPr/>
+                    <a:lstStyle/>
+                    <a:p>
+                      <a:pPr algn="ctr">
+                        <a:defRPr sz="1000">
                           <a:solidFill>
                             <a:srgbClr val="000000"/>
                           </a:solidFill>
@@ -12858,7 +12858,7 @@
                     <a:lstStyle/>
                     <a:p>
                       <a:pPr algn="ctr">
-                        <a:defRPr sz="1200">
+                        <a:defRPr sz="1000">
                           <a:solidFill>
                             <a:srgbClr val="000000"/>
                           </a:solidFill>
@@ -12877,14 +12877,14 @@
                   </a:tcPr>
                 </a:tc>
               </a:tr>
-              <a:tr h="365760">
-                <a:tc>
-                  <a:txBody>
-                    <a:bodyPr/>
-                    <a:lstStyle/>
-                    <a:p>
-                      <a:pPr algn="ctr">
-                        <a:defRPr sz="1200">
+              <a:tr h="274320">
+                <a:tc>
+                  <a:txBody>
+                    <a:bodyPr/>
+                    <a:lstStyle/>
+                    <a:p>
+                      <a:pPr algn="ctr">
+                        <a:defRPr sz="1000">
                           <a:solidFill>
                             <a:srgbClr val="000000"/>
                           </a:solidFill>
@@ -12908,7 +12908,7 @@
                     <a:lstStyle/>
                     <a:p>
                       <a:pPr algn="ctr">
-                        <a:defRPr sz="1200">
+                        <a:defRPr sz="1000">
                           <a:solidFill>
                             <a:srgbClr val="000000"/>
                           </a:solidFill>
@@ -12927,14 +12927,14 @@
                   </a:tcPr>
                 </a:tc>
               </a:tr>
-              <a:tr h="365760">
-                <a:tc>
-                  <a:txBody>
-                    <a:bodyPr/>
-                    <a:lstStyle/>
-                    <a:p>
-                      <a:pPr algn="ctr">
-                        <a:defRPr sz="1200">
+              <a:tr h="274320">
+                <a:tc>
+                  <a:txBody>
+                    <a:bodyPr/>
+                    <a:lstStyle/>
+                    <a:p>
+                      <a:pPr algn="ctr">
+                        <a:defRPr sz="1000">
                           <a:solidFill>
                             <a:srgbClr val="000000"/>
                           </a:solidFill>
@@ -12958,7 +12958,7 @@
                     <a:lstStyle/>
                     <a:p>
                       <a:pPr algn="ctr">
-                        <a:defRPr sz="1200">
+                        <a:defRPr sz="1000">
                           <a:solidFill>
                             <a:srgbClr val="000000"/>
                           </a:solidFill>
@@ -12977,14 +12977,14 @@
                   </a:tcPr>
                 </a:tc>
               </a:tr>
-              <a:tr h="365760">
-                <a:tc>
-                  <a:txBody>
-                    <a:bodyPr/>
-                    <a:lstStyle/>
-                    <a:p>
-                      <a:pPr algn="ctr">
-                        <a:defRPr sz="1200">
+              <a:tr h="274320">
+                <a:tc>
+                  <a:txBody>
+                    <a:bodyPr/>
+                    <a:lstStyle/>
+                    <a:p>
+                      <a:pPr algn="ctr">
+                        <a:defRPr sz="1000">
                           <a:solidFill>
                             <a:srgbClr val="000000"/>
                           </a:solidFill>
@@ -13008,7 +13008,7 @@
                     <a:lstStyle/>
                     <a:p>
                       <a:pPr algn="ctr">
-                        <a:defRPr sz="1200">
+                        <a:defRPr sz="1000">
                           <a:solidFill>
                             <a:srgbClr val="000000"/>
                           </a:solidFill>
@@ -13027,14 +13027,14 @@
                   </a:tcPr>
                 </a:tc>
               </a:tr>
-              <a:tr h="365760">
-                <a:tc>
-                  <a:txBody>
-                    <a:bodyPr/>
-                    <a:lstStyle/>
-                    <a:p>
-                      <a:pPr algn="ctr">
-                        <a:defRPr sz="1200">
+              <a:tr h="274320">
+                <a:tc>
+                  <a:txBody>
+                    <a:bodyPr/>
+                    <a:lstStyle/>
+                    <a:p>
+                      <a:pPr algn="ctr">
+                        <a:defRPr sz="1000">
                           <a:solidFill>
                             <a:srgbClr val="000000"/>
                           </a:solidFill>
@@ -13058,7 +13058,7 @@
                     <a:lstStyle/>
                     <a:p>
                       <a:pPr algn="ctr">
-                        <a:defRPr sz="1200">
+                        <a:defRPr sz="1000">
                           <a:solidFill>
                             <a:srgbClr val="000000"/>
                           </a:solidFill>
@@ -13127,7 +13127,7 @@
         </p:nvGraphicFramePr>
         <p:xfrm>
           <a:off x="4389120" y="1554480"/>
-          <a:ext cx="3840480" cy="4389120"/>
+          <a:ext cx="3840480" cy="3291840"/>
         </p:xfrm>
         <a:graphic>
           <a:graphicData uri="http://schemas.openxmlformats.org/drawingml/2006/table">
@@ -13139,14 +13139,14 @@
                 <a:gridCol w="1828800"/>
                 <a:gridCol w="2011680"/>
               </a:tblGrid>
-              <a:tr h="365760">
-                <a:tc>
-                  <a:txBody>
-                    <a:bodyPr/>
-                    <a:lstStyle/>
-                    <a:p>
-                      <a:pPr algn="ctr">
-                        <a:defRPr sz="1200" b="1">
+              <a:tr h="274320">
+                <a:tc>
+                  <a:txBody>
+                    <a:bodyPr/>
+                    <a:lstStyle/>
+                    <a:p>
+                      <a:pPr algn="ctr">
+                        <a:defRPr sz="1000" b="1">
                           <a:solidFill>
                             <a:srgbClr val="FFFFFF"/>
                           </a:solidFill>
@@ -13170,7 +13170,7 @@
                     <a:lstStyle/>
                     <a:p>
                       <a:pPr algn="ctr">
-                        <a:defRPr sz="1200" b="1">
+                        <a:defRPr sz="1000" b="1">
                           <a:solidFill>
                             <a:srgbClr val="FFFFFF"/>
                           </a:solidFill>
@@ -13189,14 +13189,14 @@
                   </a:tcPr>
                 </a:tc>
               </a:tr>
-              <a:tr h="365760">
-                <a:tc>
-                  <a:txBody>
-                    <a:bodyPr/>
-                    <a:lstStyle/>
-                    <a:p>
-                      <a:pPr algn="ctr">
-                        <a:defRPr sz="1200">
+              <a:tr h="274320">
+                <a:tc>
+                  <a:txBody>
+                    <a:bodyPr/>
+                    <a:lstStyle/>
+                    <a:p>
+                      <a:pPr algn="ctr">
+                        <a:defRPr sz="1000">
                           <a:solidFill>
                             <a:srgbClr val="000000"/>
                           </a:solidFill>
@@ -13220,7 +13220,7 @@
                     <a:lstStyle/>
                     <a:p>
                       <a:pPr algn="ctr">
-                        <a:defRPr sz="1200">
+                        <a:defRPr sz="1000">
                           <a:solidFill>
                             <a:srgbClr val="000000"/>
                           </a:solidFill>
@@ -13239,14 +13239,14 @@
                   </a:tcPr>
                 </a:tc>
               </a:tr>
-              <a:tr h="365760">
-                <a:tc>
-                  <a:txBody>
-                    <a:bodyPr/>
-                    <a:lstStyle/>
-                    <a:p>
-                      <a:pPr algn="ctr">
-                        <a:defRPr sz="1200">
+              <a:tr h="274320">
+                <a:tc>
+                  <a:txBody>
+                    <a:bodyPr/>
+                    <a:lstStyle/>
+                    <a:p>
+                      <a:pPr algn="ctr">
+                        <a:defRPr sz="1000">
                           <a:solidFill>
                             <a:srgbClr val="000000"/>
                           </a:solidFill>
@@ -13270,7 +13270,7 @@
                     <a:lstStyle/>
                     <a:p>
                       <a:pPr algn="ctr">
-                        <a:defRPr sz="1200">
+                        <a:defRPr sz="1000">
                           <a:solidFill>
                             <a:srgbClr val="000000"/>
                           </a:solidFill>
@@ -13289,14 +13289,14 @@
                   </a:tcPr>
                 </a:tc>
               </a:tr>
-              <a:tr h="365760">
-                <a:tc>
-                  <a:txBody>
-                    <a:bodyPr/>
-                    <a:lstStyle/>
-                    <a:p>
-                      <a:pPr algn="ctr">
-                        <a:defRPr sz="1200">
+              <a:tr h="274320">
+                <a:tc>
+                  <a:txBody>
+                    <a:bodyPr/>
+                    <a:lstStyle/>
+                    <a:p>
+                      <a:pPr algn="ctr">
+                        <a:defRPr sz="1000">
                           <a:solidFill>
                             <a:srgbClr val="000000"/>
                           </a:solidFill>
@@ -13320,7 +13320,7 @@
                     <a:lstStyle/>
                     <a:p>
                       <a:pPr algn="ctr">
-                        <a:defRPr sz="1200">
+                        <a:defRPr sz="1000">
                           <a:solidFill>
                             <a:srgbClr val="000000"/>
                           </a:solidFill>
@@ -13339,14 +13339,14 @@
                   </a:tcPr>
                 </a:tc>
               </a:tr>
-              <a:tr h="365760">
-                <a:tc>
-                  <a:txBody>
-                    <a:bodyPr/>
-                    <a:lstStyle/>
-                    <a:p>
-                      <a:pPr algn="ctr">
-                        <a:defRPr sz="1200">
+              <a:tr h="274320">
+                <a:tc>
+                  <a:txBody>
+                    <a:bodyPr/>
+                    <a:lstStyle/>
+                    <a:p>
+                      <a:pPr algn="ctr">
+                        <a:defRPr sz="1000">
                           <a:solidFill>
                             <a:srgbClr val="000000"/>
                           </a:solidFill>
@@ -13370,7 +13370,7 @@
                     <a:lstStyle/>
                     <a:p>
                       <a:pPr algn="ctr">
-                        <a:defRPr sz="1200">
+                        <a:defRPr sz="1000">
                           <a:solidFill>
                             <a:srgbClr val="000000"/>
                           </a:solidFill>
@@ -13389,14 +13389,14 @@
                   </a:tcPr>
                 </a:tc>
               </a:tr>
-              <a:tr h="365760">
-                <a:tc>
-                  <a:txBody>
-                    <a:bodyPr/>
-                    <a:lstStyle/>
-                    <a:p>
-                      <a:pPr algn="ctr">
-                        <a:defRPr sz="1200">
+              <a:tr h="274320">
+                <a:tc>
+                  <a:txBody>
+                    <a:bodyPr/>
+                    <a:lstStyle/>
+                    <a:p>
+                      <a:pPr algn="ctr">
+                        <a:defRPr sz="1000">
                           <a:solidFill>
                             <a:srgbClr val="000000"/>
                           </a:solidFill>
@@ -13420,7 +13420,7 @@
                     <a:lstStyle/>
                     <a:p>
                       <a:pPr algn="ctr">
-                        <a:defRPr sz="1200">
+                        <a:defRPr sz="1000">
                           <a:solidFill>
                             <a:srgbClr val="000000"/>
                           </a:solidFill>
@@ -13439,14 +13439,14 @@
                   </a:tcPr>
                 </a:tc>
               </a:tr>
-              <a:tr h="365760">
-                <a:tc>
-                  <a:txBody>
-                    <a:bodyPr/>
-                    <a:lstStyle/>
-                    <a:p>
-                      <a:pPr algn="ctr">
-                        <a:defRPr sz="1200">
+              <a:tr h="274320">
+                <a:tc>
+                  <a:txBody>
+                    <a:bodyPr/>
+                    <a:lstStyle/>
+                    <a:p>
+                      <a:pPr algn="ctr">
+                        <a:defRPr sz="1000">
                           <a:solidFill>
                             <a:srgbClr val="000000"/>
                           </a:solidFill>
@@ -13470,7 +13470,7 @@
                     <a:lstStyle/>
                     <a:p>
                       <a:pPr algn="ctr">
-                        <a:defRPr sz="1200">
+                        <a:defRPr sz="1000">
                           <a:solidFill>
                             <a:srgbClr val="000000"/>
                           </a:solidFill>
@@ -13489,14 +13489,14 @@
                   </a:tcPr>
                 </a:tc>
               </a:tr>
-              <a:tr h="365760">
-                <a:tc>
-                  <a:txBody>
-                    <a:bodyPr/>
-                    <a:lstStyle/>
-                    <a:p>
-                      <a:pPr algn="ctr">
-                        <a:defRPr sz="1200">
+              <a:tr h="274320">
+                <a:tc>
+                  <a:txBody>
+                    <a:bodyPr/>
+                    <a:lstStyle/>
+                    <a:p>
+                      <a:pPr algn="ctr">
+                        <a:defRPr sz="1000">
                           <a:solidFill>
                             <a:srgbClr val="000000"/>
                           </a:solidFill>
@@ -13520,7 +13520,7 @@
                     <a:lstStyle/>
                     <a:p>
                       <a:pPr algn="ctr">
-                        <a:defRPr sz="1200">
+                        <a:defRPr sz="1000">
                           <a:solidFill>
                             <a:srgbClr val="000000"/>
                           </a:solidFill>
@@ -13539,14 +13539,14 @@
                   </a:tcPr>
                 </a:tc>
               </a:tr>
-              <a:tr h="365760">
-                <a:tc>
-                  <a:txBody>
-                    <a:bodyPr/>
-                    <a:lstStyle/>
-                    <a:p>
-                      <a:pPr algn="ctr">
-                        <a:defRPr sz="1200">
+              <a:tr h="274320">
+                <a:tc>
+                  <a:txBody>
+                    <a:bodyPr/>
+                    <a:lstStyle/>
+                    <a:p>
+                      <a:pPr algn="ctr">
+                        <a:defRPr sz="1000">
                           <a:solidFill>
                             <a:srgbClr val="000000"/>
                           </a:solidFill>
@@ -13570,7 +13570,7 @@
                     <a:lstStyle/>
                     <a:p>
                       <a:pPr algn="ctr">
-                        <a:defRPr sz="1200">
+                        <a:defRPr sz="1000">
                           <a:solidFill>
                             <a:srgbClr val="000000"/>
                           </a:solidFill>
@@ -13589,14 +13589,14 @@
                   </a:tcPr>
                 </a:tc>
               </a:tr>
-              <a:tr h="365760">
-                <a:tc>
-                  <a:txBody>
-                    <a:bodyPr/>
-                    <a:lstStyle/>
-                    <a:p>
-                      <a:pPr algn="ctr">
-                        <a:defRPr sz="1200">
+              <a:tr h="274320">
+                <a:tc>
+                  <a:txBody>
+                    <a:bodyPr/>
+                    <a:lstStyle/>
+                    <a:p>
+                      <a:pPr algn="ctr">
+                        <a:defRPr sz="1000">
                           <a:solidFill>
                             <a:srgbClr val="000000"/>
                           </a:solidFill>
@@ -13620,7 +13620,7 @@
                     <a:lstStyle/>
                     <a:p>
                       <a:pPr algn="ctr">
-                        <a:defRPr sz="1200">
+                        <a:defRPr sz="1000">
                           <a:solidFill>
                             <a:srgbClr val="000000"/>
                           </a:solidFill>
@@ -13639,14 +13639,14 @@
                   </a:tcPr>
                 </a:tc>
               </a:tr>
-              <a:tr h="365760">
-                <a:tc>
-                  <a:txBody>
-                    <a:bodyPr/>
-                    <a:lstStyle/>
-                    <a:p>
-                      <a:pPr algn="ctr">
-                        <a:defRPr sz="1200">
+              <a:tr h="274320">
+                <a:tc>
+                  <a:txBody>
+                    <a:bodyPr/>
+                    <a:lstStyle/>
+                    <a:p>
+                      <a:pPr algn="ctr">
+                        <a:defRPr sz="1000">
                           <a:solidFill>
                             <a:srgbClr val="000000"/>
                           </a:solidFill>
@@ -13670,7 +13670,7 @@
                     <a:lstStyle/>
                     <a:p>
                       <a:pPr algn="ctr">
-                        <a:defRPr sz="1200">
+                        <a:defRPr sz="1000">
                           <a:solidFill>
                             <a:srgbClr val="000000"/>
                           </a:solidFill>
@@ -13689,14 +13689,14 @@
                   </a:tcPr>
                 </a:tc>
               </a:tr>
-              <a:tr h="365760">
-                <a:tc>
-                  <a:txBody>
-                    <a:bodyPr/>
-                    <a:lstStyle/>
-                    <a:p>
-                      <a:pPr algn="ctr">
-                        <a:defRPr sz="1200">
+              <a:tr h="274320">
+                <a:tc>
+                  <a:txBody>
+                    <a:bodyPr/>
+                    <a:lstStyle/>
+                    <a:p>
+                      <a:pPr algn="ctr">
+                        <a:defRPr sz="1000">
                           <a:solidFill>
                             <a:srgbClr val="000000"/>
                           </a:solidFill>
@@ -13720,7 +13720,7 @@
                     <a:lstStyle/>
                     <a:p>
                       <a:pPr algn="ctr">
-                        <a:defRPr sz="1200">
+                        <a:defRPr sz="1000">
                           <a:solidFill>
                             <a:srgbClr val="000000"/>
                           </a:solidFill>
@@ -13789,7 +13789,7 @@
         </p:nvGraphicFramePr>
         <p:xfrm>
           <a:off x="8321040" y="1554480"/>
-          <a:ext cx="3474720" cy="4389120"/>
+          <a:ext cx="3474720" cy="3291840"/>
         </p:xfrm>
         <a:graphic>
           <a:graphicData uri="http://schemas.openxmlformats.org/drawingml/2006/table">
@@ -13801,14 +13801,14 @@
                 <a:gridCol w="1463040"/>
                 <a:gridCol w="2011680"/>
               </a:tblGrid>
-              <a:tr h="365760">
-                <a:tc>
-                  <a:txBody>
-                    <a:bodyPr/>
-                    <a:lstStyle/>
-                    <a:p>
-                      <a:pPr algn="ctr">
-                        <a:defRPr sz="1200" b="1">
+              <a:tr h="274320">
+                <a:tc>
+                  <a:txBody>
+                    <a:bodyPr/>
+                    <a:lstStyle/>
+                    <a:p>
+                      <a:pPr algn="ctr">
+                        <a:defRPr sz="1000" b="1">
                           <a:solidFill>
                             <a:srgbClr val="FFFFFF"/>
                           </a:solidFill>
@@ -13832,7 +13832,7 @@
                     <a:lstStyle/>
                     <a:p>
                       <a:pPr algn="ctr">
-                        <a:defRPr sz="1200" b="1">
+                        <a:defRPr sz="1000" b="1">
                           <a:solidFill>
                             <a:srgbClr val="FFFFFF"/>
                           </a:solidFill>
@@ -13851,14 +13851,14 @@
                   </a:tcPr>
                 </a:tc>
               </a:tr>
-              <a:tr h="365760">
-                <a:tc>
-                  <a:txBody>
-                    <a:bodyPr/>
-                    <a:lstStyle/>
-                    <a:p>
-                      <a:pPr algn="ctr">
-                        <a:defRPr sz="1200">
+              <a:tr h="274320">
+                <a:tc>
+                  <a:txBody>
+                    <a:bodyPr/>
+                    <a:lstStyle/>
+                    <a:p>
+                      <a:pPr algn="ctr">
+                        <a:defRPr sz="1000">
                           <a:solidFill>
                             <a:srgbClr val="000000"/>
                           </a:solidFill>
@@ -13882,7 +13882,7 @@
                     <a:lstStyle/>
                     <a:p>
                       <a:pPr algn="ctr">
-                        <a:defRPr sz="1200">
+                        <a:defRPr sz="1000">
                           <a:solidFill>
                             <a:srgbClr val="000000"/>
                           </a:solidFill>
@@ -13901,14 +13901,14 @@
                   </a:tcPr>
                 </a:tc>
               </a:tr>
-              <a:tr h="365760">
-                <a:tc>
-                  <a:txBody>
-                    <a:bodyPr/>
-                    <a:lstStyle/>
-                    <a:p>
-                      <a:pPr algn="ctr">
-                        <a:defRPr sz="1200">
+              <a:tr h="274320">
+                <a:tc>
+                  <a:txBody>
+                    <a:bodyPr/>
+                    <a:lstStyle/>
+                    <a:p>
+                      <a:pPr algn="ctr">
+                        <a:defRPr sz="1000">
                           <a:solidFill>
                             <a:srgbClr val="000000"/>
                           </a:solidFill>
@@ -13932,7 +13932,7 @@
                     <a:lstStyle/>
                     <a:p>
                       <a:pPr algn="ctr">
-                        <a:defRPr sz="1200">
+                        <a:defRPr sz="1000">
                           <a:solidFill>
                             <a:srgbClr val="000000"/>
                           </a:solidFill>
@@ -13951,14 +13951,14 @@
                   </a:tcPr>
                 </a:tc>
               </a:tr>
-              <a:tr h="365760">
-                <a:tc>
-                  <a:txBody>
-                    <a:bodyPr/>
-                    <a:lstStyle/>
-                    <a:p>
-                      <a:pPr algn="ctr">
-                        <a:defRPr sz="1200">
+              <a:tr h="274320">
+                <a:tc>
+                  <a:txBody>
+                    <a:bodyPr/>
+                    <a:lstStyle/>
+                    <a:p>
+                      <a:pPr algn="ctr">
+                        <a:defRPr sz="1000">
                           <a:solidFill>
                             <a:srgbClr val="000000"/>
                           </a:solidFill>
@@ -13982,7 +13982,7 @@
                     <a:lstStyle/>
                     <a:p>
                       <a:pPr algn="ctr">
-                        <a:defRPr sz="1200">
+                        <a:defRPr sz="1000">
                           <a:solidFill>
                             <a:srgbClr val="000000"/>
                           </a:solidFill>
@@ -14001,14 +14001,14 @@
                   </a:tcPr>
                 </a:tc>
               </a:tr>
-              <a:tr h="365760">
-                <a:tc>
-                  <a:txBody>
-                    <a:bodyPr/>
-                    <a:lstStyle/>
-                    <a:p>
-                      <a:pPr algn="ctr">
-                        <a:defRPr sz="1200">
+              <a:tr h="274320">
+                <a:tc>
+                  <a:txBody>
+                    <a:bodyPr/>
+                    <a:lstStyle/>
+                    <a:p>
+                      <a:pPr algn="ctr">
+                        <a:defRPr sz="1000">
                           <a:solidFill>
                             <a:srgbClr val="000000"/>
                           </a:solidFill>
@@ -14032,7 +14032,7 @@
                     <a:lstStyle/>
                     <a:p>
                       <a:pPr algn="ctr">
-                        <a:defRPr sz="1200">
+                        <a:defRPr sz="1000">
                           <a:solidFill>
                             <a:srgbClr val="000000"/>
                           </a:solidFill>
@@ -14051,14 +14051,14 @@
                   </a:tcPr>
                 </a:tc>
               </a:tr>
-              <a:tr h="365760">
-                <a:tc>
-                  <a:txBody>
-                    <a:bodyPr/>
-                    <a:lstStyle/>
-                    <a:p>
-                      <a:pPr algn="ctr">
-                        <a:defRPr sz="1200">
+              <a:tr h="274320">
+                <a:tc>
+                  <a:txBody>
+                    <a:bodyPr/>
+                    <a:lstStyle/>
+                    <a:p>
+                      <a:pPr algn="ctr">
+                        <a:defRPr sz="1000">
                           <a:solidFill>
                             <a:srgbClr val="000000"/>
                           </a:solidFill>
@@ -14082,7 +14082,7 @@
                     <a:lstStyle/>
                     <a:p>
                       <a:pPr algn="ctr">
-                        <a:defRPr sz="1200">
+                        <a:defRPr sz="1000">
                           <a:solidFill>
                             <a:srgbClr val="000000"/>
                           </a:solidFill>
@@ -14101,14 +14101,14 @@
                   </a:tcPr>
                 </a:tc>
               </a:tr>
-              <a:tr h="365760">
-                <a:tc>
-                  <a:txBody>
-                    <a:bodyPr/>
-                    <a:lstStyle/>
-                    <a:p>
-                      <a:pPr algn="ctr">
-                        <a:defRPr sz="1200">
+              <a:tr h="274320">
+                <a:tc>
+                  <a:txBody>
+                    <a:bodyPr/>
+                    <a:lstStyle/>
+                    <a:p>
+                      <a:pPr algn="ctr">
+                        <a:defRPr sz="1000">
                           <a:solidFill>
                             <a:srgbClr val="000000"/>
                           </a:solidFill>
@@ -14132,7 +14132,7 @@
                     <a:lstStyle/>
                     <a:p>
                       <a:pPr algn="ctr">
-                        <a:defRPr sz="1200">
+                        <a:defRPr sz="1000">
                           <a:solidFill>
                             <a:srgbClr val="000000"/>
                           </a:solidFill>
@@ -14151,14 +14151,14 @@
                   </a:tcPr>
                 </a:tc>
               </a:tr>
-              <a:tr h="365760">
-                <a:tc>
-                  <a:txBody>
-                    <a:bodyPr/>
-                    <a:lstStyle/>
-                    <a:p>
-                      <a:pPr algn="ctr">
-                        <a:defRPr sz="1200">
+              <a:tr h="274320">
+                <a:tc>
+                  <a:txBody>
+                    <a:bodyPr/>
+                    <a:lstStyle/>
+                    <a:p>
+                      <a:pPr algn="ctr">
+                        <a:defRPr sz="1000">
                           <a:solidFill>
                             <a:srgbClr val="000000"/>
                           </a:solidFill>
@@ -14182,7 +14182,7 @@
                     <a:lstStyle/>
                     <a:p>
                       <a:pPr algn="ctr">
-                        <a:defRPr sz="1200">
+                        <a:defRPr sz="1000">
                           <a:solidFill>
                             <a:srgbClr val="000000"/>
                           </a:solidFill>
@@ -14201,14 +14201,14 @@
                   </a:tcPr>
                 </a:tc>
               </a:tr>
-              <a:tr h="365760">
-                <a:tc>
-                  <a:txBody>
-                    <a:bodyPr/>
-                    <a:lstStyle/>
-                    <a:p>
-                      <a:pPr algn="ctr">
-                        <a:defRPr sz="1200">
+              <a:tr h="274320">
+                <a:tc>
+                  <a:txBody>
+                    <a:bodyPr/>
+                    <a:lstStyle/>
+                    <a:p>
+                      <a:pPr algn="ctr">
+                        <a:defRPr sz="1000">
                           <a:solidFill>
                             <a:srgbClr val="000000"/>
                           </a:solidFill>
@@ -14232,7 +14232,7 @@
                     <a:lstStyle/>
                     <a:p>
                       <a:pPr algn="ctr">
-                        <a:defRPr sz="1200">
+                        <a:defRPr sz="1000">
                           <a:solidFill>
                             <a:srgbClr val="000000"/>
                           </a:solidFill>
@@ -14251,14 +14251,14 @@
                   </a:tcPr>
                 </a:tc>
               </a:tr>
-              <a:tr h="365760">
-                <a:tc>
-                  <a:txBody>
-                    <a:bodyPr/>
-                    <a:lstStyle/>
-                    <a:p>
-                      <a:pPr algn="ctr">
-                        <a:defRPr sz="1200">
+              <a:tr h="274320">
+                <a:tc>
+                  <a:txBody>
+                    <a:bodyPr/>
+                    <a:lstStyle/>
+                    <a:p>
+                      <a:pPr algn="ctr">
+                        <a:defRPr sz="1000">
                           <a:solidFill>
                             <a:srgbClr val="000000"/>
                           </a:solidFill>
@@ -14282,7 +14282,7 @@
                     <a:lstStyle/>
                     <a:p>
                       <a:pPr algn="ctr">
-                        <a:defRPr sz="1200">
+                        <a:defRPr sz="1000">
                           <a:solidFill>
                             <a:srgbClr val="000000"/>
                           </a:solidFill>
@@ -14301,14 +14301,14 @@
                   </a:tcPr>
                 </a:tc>
               </a:tr>
-              <a:tr h="365760">
-                <a:tc>
-                  <a:txBody>
-                    <a:bodyPr/>
-                    <a:lstStyle/>
-                    <a:p>
-                      <a:pPr algn="ctr">
-                        <a:defRPr sz="1200">
+              <a:tr h="274320">
+                <a:tc>
+                  <a:txBody>
+                    <a:bodyPr/>
+                    <a:lstStyle/>
+                    <a:p>
+                      <a:pPr algn="ctr">
+                        <a:defRPr sz="1000">
                           <a:solidFill>
                             <a:srgbClr val="000000"/>
                           </a:solidFill>
@@ -14332,7 +14332,7 @@
                     <a:lstStyle/>
                     <a:p>
                       <a:pPr algn="ctr">
-                        <a:defRPr sz="1200">
+                        <a:defRPr sz="1000">
                           <a:solidFill>
                             <a:srgbClr val="000000"/>
                           </a:solidFill>
@@ -14351,14 +14351,14 @@
                   </a:tcPr>
                 </a:tc>
               </a:tr>
-              <a:tr h="365760">
-                <a:tc>
-                  <a:txBody>
-                    <a:bodyPr/>
-                    <a:lstStyle/>
-                    <a:p>
-                      <a:pPr algn="ctr">
-                        <a:defRPr sz="1200">
+              <a:tr h="274320">
+                <a:tc>
+                  <a:txBody>
+                    <a:bodyPr/>
+                    <a:lstStyle/>
+                    <a:p>
+                      <a:pPr algn="ctr">
+                        <a:defRPr sz="1000">
                           <a:solidFill>
                             <a:srgbClr val="000000"/>
                           </a:solidFill>
@@ -14382,7 +14382,7 @@
                     <a:lstStyle/>
                     <a:p>
                       <a:pPr algn="ctr">
-                        <a:defRPr sz="1200">
+                        <a:defRPr sz="1000">
                           <a:solidFill>
                             <a:srgbClr val="000000"/>
                           </a:solidFill>
@@ -14413,7 +14413,7 @@
         </p:nvSpPr>
         <p:spPr>
           <a:xfrm>
-            <a:off x="0" y="5303520"/>
+            <a:off x="0" y="5212080"/>
             <a:ext cx="12191695" cy="45720"/>
           </a:xfrm>
           <a:prstGeom prst="rect">
@@ -14457,7 +14457,7 @@
         </p:nvSpPr>
         <p:spPr>
           <a:xfrm>
-            <a:off x="457200" y="5440680"/>
+            <a:off x="457200" y="5349240"/>
             <a:ext cx="3657600" cy="320040"/>
           </a:xfrm>
           <a:prstGeom prst="rect">
@@ -14493,7 +14493,7 @@
         </p:nvSpPr>
         <p:spPr>
           <a:xfrm>
-            <a:off x="640080" y="5760720"/>
+            <a:off x="640080" y="5623560"/>
             <a:ext cx="4114800" cy="201168"/>
           </a:xfrm>
           <a:prstGeom prst="rect">
@@ -14529,7 +14529,7 @@
         </p:nvSpPr>
         <p:spPr>
           <a:xfrm>
-            <a:off x="640080" y="5961888"/>
+            <a:off x="640080" y="5824728"/>
             <a:ext cx="4114800" cy="201168"/>
           </a:xfrm>
           <a:prstGeom prst="rect">
@@ -14565,7 +14565,7 @@
         </p:nvSpPr>
         <p:spPr>
           <a:xfrm>
-            <a:off x="640080" y="6163056"/>
+            <a:off x="640080" y="6025896"/>
             <a:ext cx="4114800" cy="201168"/>
           </a:xfrm>
           <a:prstGeom prst="rect">
@@ -14601,7 +14601,7 @@
         </p:nvSpPr>
         <p:spPr>
           <a:xfrm>
-            <a:off x="5029200" y="5440680"/>
+            <a:off x="5029200" y="5349240"/>
             <a:ext cx="3657600" cy="320040"/>
           </a:xfrm>
           <a:prstGeom prst="rect">
@@ -14637,7 +14637,7 @@
         </p:nvSpPr>
         <p:spPr>
           <a:xfrm>
-            <a:off x="5212080" y="5760720"/>
+            <a:off x="5212080" y="5623560"/>
             <a:ext cx="4114800" cy="201168"/>
           </a:xfrm>
           <a:prstGeom prst="rect">
@@ -14673,7 +14673,7 @@
         </p:nvSpPr>
         <p:spPr>
           <a:xfrm>
-            <a:off x="5212080" y="5961888"/>
+            <a:off x="5212080" y="5824728"/>
             <a:ext cx="4114800" cy="201168"/>
           </a:xfrm>
           <a:prstGeom prst="rect">
@@ -14709,7 +14709,7 @@
         </p:nvSpPr>
         <p:spPr>
           <a:xfrm>
-            <a:off x="5212080" y="6163056"/>
+            <a:off x="5212080" y="6025896"/>
             <a:ext cx="4114800" cy="201168"/>
           </a:xfrm>
           <a:prstGeom prst="rect">
@@ -14745,7 +14745,7 @@
         </p:nvSpPr>
         <p:spPr>
           <a:xfrm>
-            <a:off x="9601200" y="5440680"/>
+            <a:off x="9601200" y="5349240"/>
             <a:ext cx="2286000" cy="320040"/>
           </a:xfrm>
           <a:prstGeom prst="rect">
@@ -14781,7 +14781,7 @@
         </p:nvSpPr>
         <p:spPr>
           <a:xfrm>
-            <a:off x="9601200" y="5760720"/>
+            <a:off x="9601200" y="5623560"/>
             <a:ext cx="1188720" cy="201168"/>
           </a:xfrm>
           <a:prstGeom prst="rect">
@@ -14817,7 +14817,7 @@
         </p:nvSpPr>
         <p:spPr>
           <a:xfrm>
-            <a:off x="10789920" y="5760720"/>
+            <a:off x="10789920" y="5623560"/>
             <a:ext cx="914400" cy="201168"/>
           </a:xfrm>
           <a:prstGeom prst="rect">
@@ -14853,7 +14853,7 @@
         </p:nvSpPr>
         <p:spPr>
           <a:xfrm>
-            <a:off x="9601200" y="5961888"/>
+            <a:off x="9601200" y="5824728"/>
             <a:ext cx="1188720" cy="201168"/>
           </a:xfrm>
           <a:prstGeom prst="rect">
@@ -14889,7 +14889,7 @@
         </p:nvSpPr>
         <p:spPr>
           <a:xfrm>
-            <a:off x="10789920" y="5961888"/>
+            <a:off x="10789920" y="5824728"/>
             <a:ext cx="914400" cy="201168"/>
           </a:xfrm>
           <a:prstGeom prst="rect">
@@ -14925,7 +14925,7 @@
         </p:nvSpPr>
         <p:spPr>
           <a:xfrm>
-            <a:off x="9601200" y="6163056"/>
+            <a:off x="9601200" y="6025896"/>
             <a:ext cx="1188720" cy="201168"/>
           </a:xfrm>
           <a:prstGeom prst="rect">
@@ -14961,7 +14961,7 @@
         </p:nvSpPr>
         <p:spPr>
           <a:xfrm>
-            <a:off x="10789920" y="6163056"/>
+            <a:off x="10789920" y="6025896"/>
             <a:ext cx="914400" cy="201168"/>
           </a:xfrm>
           <a:prstGeom prst="rect">
@@ -15133,7 +15133,7 @@
         </p:nvGraphicFramePr>
         <p:xfrm>
           <a:off x="274320" y="1554480"/>
-          <a:ext cx="5577840" cy="2560320"/>
+          <a:ext cx="5577840" cy="1920240"/>
         </p:xfrm>
         <a:graphic>
           <a:graphicData uri="http://schemas.openxmlformats.org/drawingml/2006/table">
@@ -15147,14 +15147,14 @@
                 <a:gridCol w="1828800"/>
                 <a:gridCol w="1097280"/>
               </a:tblGrid>
-              <a:tr h="365760">
-                <a:tc>
-                  <a:txBody>
-                    <a:bodyPr/>
-                    <a:lstStyle/>
-                    <a:p>
-                      <a:pPr algn="ctr">
-                        <a:defRPr sz="1200" b="1">
+              <a:tr h="274320">
+                <a:tc>
+                  <a:txBody>
+                    <a:bodyPr/>
+                    <a:lstStyle/>
+                    <a:p>
+                      <a:pPr algn="ctr">
+                        <a:defRPr sz="1000" b="1">
                           <a:solidFill>
                             <a:srgbClr val="FFFFFF"/>
                           </a:solidFill>
@@ -15178,7 +15178,7 @@
                     <a:lstStyle/>
                     <a:p>
                       <a:pPr algn="ctr">
-                        <a:defRPr sz="1200" b="1">
+                        <a:defRPr sz="1000" b="1">
                           <a:solidFill>
                             <a:srgbClr val="FFFFFF"/>
                           </a:solidFill>
@@ -15202,7 +15202,7 @@
                     <a:lstStyle/>
                     <a:p>
                       <a:pPr algn="ctr">
-                        <a:defRPr sz="1200" b="1">
+                        <a:defRPr sz="1000" b="1">
                           <a:solidFill>
                             <a:srgbClr val="FFFFFF"/>
                           </a:solidFill>
@@ -15226,7 +15226,7 @@
                     <a:lstStyle/>
                     <a:p>
                       <a:pPr algn="ctr">
-                        <a:defRPr sz="1200" b="1">
+                        <a:defRPr sz="1000" b="1">
                           <a:solidFill>
                             <a:srgbClr val="FFFFFF"/>
                           </a:solidFill>
@@ -15245,14 +15245,14 @@
                   </a:tcPr>
                 </a:tc>
               </a:tr>
-              <a:tr h="365760">
-                <a:tc>
-                  <a:txBody>
-                    <a:bodyPr/>
-                    <a:lstStyle/>
-                    <a:p>
-                      <a:pPr algn="ctr">
-                        <a:defRPr sz="1200">
+              <a:tr h="274320">
+                <a:tc>
+                  <a:txBody>
+                    <a:bodyPr/>
+                    <a:lstStyle/>
+                    <a:p>
+                      <a:pPr algn="ctr">
+                        <a:defRPr sz="1000">
                           <a:solidFill>
                             <a:srgbClr val="000000"/>
                           </a:solidFill>
@@ -15276,7 +15276,7 @@
                     <a:lstStyle/>
                     <a:p>
                       <a:pPr algn="ctr">
-                        <a:defRPr sz="1200">
+                        <a:defRPr sz="1000">
                           <a:solidFill>
                             <a:srgbClr val="000000"/>
                           </a:solidFill>
@@ -15300,7 +15300,7 @@
                     <a:lstStyle/>
                     <a:p>
                       <a:pPr algn="ctr">
-                        <a:defRPr sz="1200">
+                        <a:defRPr sz="1000">
                           <a:solidFill>
                             <a:srgbClr val="000000"/>
                           </a:solidFill>
@@ -15324,7 +15324,7 @@
                     <a:lstStyle/>
                     <a:p>
                       <a:pPr algn="ctr">
-                        <a:defRPr sz="1200">
+                        <a:defRPr sz="1000">
                           <a:solidFill>
                             <a:srgbClr val="000000"/>
                           </a:solidFill>
@@ -15343,14 +15343,14 @@
                   </a:tcPr>
                 </a:tc>
               </a:tr>
-              <a:tr h="365760">
-                <a:tc>
-                  <a:txBody>
-                    <a:bodyPr/>
-                    <a:lstStyle/>
-                    <a:p>
-                      <a:pPr algn="ctr">
-                        <a:defRPr sz="1200">
+              <a:tr h="274320">
+                <a:tc>
+                  <a:txBody>
+                    <a:bodyPr/>
+                    <a:lstStyle/>
+                    <a:p>
+                      <a:pPr algn="ctr">
+                        <a:defRPr sz="1000">
                           <a:solidFill>
                             <a:srgbClr val="000000"/>
                           </a:solidFill>
@@ -15374,7 +15374,7 @@
                     <a:lstStyle/>
                     <a:p>
                       <a:pPr algn="ctr">
-                        <a:defRPr sz="1200">
+                        <a:defRPr sz="1000">
                           <a:solidFill>
                             <a:srgbClr val="000000"/>
                           </a:solidFill>
@@ -15398,7 +15398,7 @@
                     <a:lstStyle/>
                     <a:p>
                       <a:pPr algn="ctr">
-                        <a:defRPr sz="1200">
+                        <a:defRPr sz="1000">
                           <a:solidFill>
                             <a:srgbClr val="000000"/>
                           </a:solidFill>
@@ -15422,7 +15422,7 @@
                     <a:lstStyle/>
                     <a:p>
                       <a:pPr algn="ctr">
-                        <a:defRPr sz="1200">
+                        <a:defRPr sz="1000">
                           <a:solidFill>
                             <a:srgbClr val="000000"/>
                           </a:solidFill>
@@ -15441,14 +15441,14 @@
                   </a:tcPr>
                 </a:tc>
               </a:tr>
-              <a:tr h="365760">
-                <a:tc>
-                  <a:txBody>
-                    <a:bodyPr/>
-                    <a:lstStyle/>
-                    <a:p>
-                      <a:pPr algn="ctr">
-                        <a:defRPr sz="1200">
+              <a:tr h="274320">
+                <a:tc>
+                  <a:txBody>
+                    <a:bodyPr/>
+                    <a:lstStyle/>
+                    <a:p>
+                      <a:pPr algn="ctr">
+                        <a:defRPr sz="1000">
                           <a:solidFill>
                             <a:srgbClr val="000000"/>
                           </a:solidFill>
@@ -15472,7 +15472,7 @@
                     <a:lstStyle/>
                     <a:p>
                       <a:pPr algn="ctr">
-                        <a:defRPr sz="1200">
+                        <a:defRPr sz="1000">
                           <a:solidFill>
                             <a:srgbClr val="000000"/>
                           </a:solidFill>
@@ -15496,7 +15496,7 @@
                     <a:lstStyle/>
                     <a:p>
                       <a:pPr algn="ctr">
-                        <a:defRPr sz="1200">
+                        <a:defRPr sz="1000">
                           <a:solidFill>
                             <a:srgbClr val="000000"/>
                           </a:solidFill>
@@ -15520,7 +15520,7 @@
                     <a:lstStyle/>
                     <a:p>
                       <a:pPr algn="ctr">
-                        <a:defRPr sz="1200">
+                        <a:defRPr sz="1000">
                           <a:solidFill>
                             <a:srgbClr val="000000"/>
                           </a:solidFill>
@@ -15539,14 +15539,14 @@
                   </a:tcPr>
                 </a:tc>
               </a:tr>
-              <a:tr h="365760">
-                <a:tc>
-                  <a:txBody>
-                    <a:bodyPr/>
-                    <a:lstStyle/>
-                    <a:p>
-                      <a:pPr algn="ctr">
-                        <a:defRPr sz="1200">
+              <a:tr h="274320">
+                <a:tc>
+                  <a:txBody>
+                    <a:bodyPr/>
+                    <a:lstStyle/>
+                    <a:p>
+                      <a:pPr algn="ctr">
+                        <a:defRPr sz="1000">
                           <a:solidFill>
                             <a:srgbClr val="000000"/>
                           </a:solidFill>
@@ -15570,7 +15570,7 @@
                     <a:lstStyle/>
                     <a:p>
                       <a:pPr algn="ctr">
-                        <a:defRPr sz="1200">
+                        <a:defRPr sz="1000">
                           <a:solidFill>
                             <a:srgbClr val="000000"/>
                           </a:solidFill>
@@ -15594,7 +15594,7 @@
                     <a:lstStyle/>
                     <a:p>
                       <a:pPr algn="ctr">
-                        <a:defRPr sz="1200">
+                        <a:defRPr sz="1000">
                           <a:solidFill>
                             <a:srgbClr val="000000"/>
                           </a:solidFill>
@@ -15618,7 +15618,7 @@
                     <a:lstStyle/>
                     <a:p>
                       <a:pPr algn="ctr">
-                        <a:defRPr sz="1200">
+                        <a:defRPr sz="1000">
                           <a:solidFill>
                             <a:srgbClr val="000000"/>
                           </a:solidFill>
@@ -15637,14 +15637,14 @@
                   </a:tcPr>
                 </a:tc>
               </a:tr>
-              <a:tr h="365760">
-                <a:tc>
-                  <a:txBody>
-                    <a:bodyPr/>
-                    <a:lstStyle/>
-                    <a:p>
-                      <a:pPr algn="ctr">
-                        <a:defRPr sz="1200">
+              <a:tr h="274320">
+                <a:tc>
+                  <a:txBody>
+                    <a:bodyPr/>
+                    <a:lstStyle/>
+                    <a:p>
+                      <a:pPr algn="ctr">
+                        <a:defRPr sz="1000">
                           <a:solidFill>
                             <a:srgbClr val="000000"/>
                           </a:solidFill>
@@ -15668,7 +15668,7 @@
                     <a:lstStyle/>
                     <a:p>
                       <a:pPr algn="ctr">
-                        <a:defRPr sz="1200">
+                        <a:defRPr sz="1000">
                           <a:solidFill>
                             <a:srgbClr val="000000"/>
                           </a:solidFill>
@@ -15692,7 +15692,7 @@
                     <a:lstStyle/>
                     <a:p>
                       <a:pPr algn="ctr">
-                        <a:defRPr sz="1200">
+                        <a:defRPr sz="1000">
                           <a:solidFill>
                             <a:srgbClr val="000000"/>
                           </a:solidFill>
@@ -15716,7 +15716,7 @@
                     <a:lstStyle/>
                     <a:p>
                       <a:pPr algn="ctr">
-                        <a:defRPr sz="1200">
+                        <a:defRPr sz="1000">
                           <a:solidFill>
                             <a:srgbClr val="000000"/>
                           </a:solidFill>
@@ -15735,14 +15735,14 @@
                   </a:tcPr>
                 </a:tc>
               </a:tr>
-              <a:tr h="365760">
-                <a:tc>
-                  <a:txBody>
-                    <a:bodyPr/>
-                    <a:lstStyle/>
-                    <a:p>
-                      <a:pPr algn="ctr">
-                        <a:defRPr sz="1200">
+              <a:tr h="274320">
+                <a:tc>
+                  <a:txBody>
+                    <a:bodyPr/>
+                    <a:lstStyle/>
+                    <a:p>
+                      <a:pPr algn="ctr">
+                        <a:defRPr sz="1000">
                           <a:solidFill>
                             <a:srgbClr val="000000"/>
                           </a:solidFill>
@@ -15766,7 +15766,7 @@
                     <a:lstStyle/>
                     <a:p>
                       <a:pPr algn="ctr">
-                        <a:defRPr sz="1200">
+                        <a:defRPr sz="1000">
                           <a:solidFill>
                             <a:srgbClr val="000000"/>
                           </a:solidFill>
@@ -15790,7 +15790,7 @@
                     <a:lstStyle/>
                     <a:p>
                       <a:pPr algn="ctr">
-                        <a:defRPr sz="1200">
+                        <a:defRPr sz="1000">
                           <a:solidFill>
                             <a:srgbClr val="000000"/>
                           </a:solidFill>
@@ -15814,7 +15814,7 @@
                     <a:lstStyle/>
                     <a:p>
                       <a:pPr algn="ctr">
-                        <a:defRPr sz="1200">
+                        <a:defRPr sz="1000">
                           <a:solidFill>
                             <a:srgbClr val="000000"/>
                           </a:solidFill>
@@ -15883,7 +15883,7 @@
         </p:nvGraphicFramePr>
         <p:xfrm>
           <a:off x="6217920" y="1554480"/>
-          <a:ext cx="4114800" cy="3657600"/>
+          <a:ext cx="4114800" cy="2743200"/>
         </p:xfrm>
         <a:graphic>
           <a:graphicData uri="http://schemas.openxmlformats.org/drawingml/2006/table">
@@ -15895,14 +15895,14 @@
                 <a:gridCol w="1828800"/>
                 <a:gridCol w="2286000"/>
               </a:tblGrid>
-              <a:tr h="365760">
-                <a:tc>
-                  <a:txBody>
-                    <a:bodyPr/>
-                    <a:lstStyle/>
-                    <a:p>
-                      <a:pPr algn="ctr">
-                        <a:defRPr sz="1200" b="1">
+              <a:tr h="274320">
+                <a:tc>
+                  <a:txBody>
+                    <a:bodyPr/>
+                    <a:lstStyle/>
+                    <a:p>
+                      <a:pPr algn="ctr">
+                        <a:defRPr sz="1000" b="1">
                           <a:solidFill>
                             <a:srgbClr val="FFFFFF"/>
                           </a:solidFill>
@@ -15926,7 +15926,7 @@
                     <a:lstStyle/>
                     <a:p>
                       <a:pPr algn="ctr">
-                        <a:defRPr sz="1200" b="1">
+                        <a:defRPr sz="1000" b="1">
                           <a:solidFill>
                             <a:srgbClr val="FFFFFF"/>
                           </a:solidFill>
@@ -15945,14 +15945,14 @@
                   </a:tcPr>
                 </a:tc>
               </a:tr>
-              <a:tr h="365760">
-                <a:tc>
-                  <a:txBody>
-                    <a:bodyPr/>
-                    <a:lstStyle/>
-                    <a:p>
-                      <a:pPr algn="ctr">
-                        <a:defRPr sz="1200">
+              <a:tr h="274320">
+                <a:tc>
+                  <a:txBody>
+                    <a:bodyPr/>
+                    <a:lstStyle/>
+                    <a:p>
+                      <a:pPr algn="ctr">
+                        <a:defRPr sz="1000">
                           <a:solidFill>
                             <a:srgbClr val="000000"/>
                           </a:solidFill>
@@ -15976,7 +15976,7 @@
                     <a:lstStyle/>
                     <a:p>
                       <a:pPr algn="ctr">
-                        <a:defRPr sz="1200">
+                        <a:defRPr sz="1000">
                           <a:solidFill>
                             <a:srgbClr val="000000"/>
                           </a:solidFill>
@@ -15995,14 +15995,14 @@
                   </a:tcPr>
                 </a:tc>
               </a:tr>
-              <a:tr h="365760">
-                <a:tc>
-                  <a:txBody>
-                    <a:bodyPr/>
-                    <a:lstStyle/>
-                    <a:p>
-                      <a:pPr algn="ctr">
-                        <a:defRPr sz="1200">
+              <a:tr h="274320">
+                <a:tc>
+                  <a:txBody>
+                    <a:bodyPr/>
+                    <a:lstStyle/>
+                    <a:p>
+                      <a:pPr algn="ctr">
+                        <a:defRPr sz="1000">
                           <a:solidFill>
                             <a:srgbClr val="000000"/>
                           </a:solidFill>
@@ -16026,7 +16026,7 @@
                     <a:lstStyle/>
                     <a:p>
                       <a:pPr algn="ctr">
-                        <a:defRPr sz="1200">
+                        <a:defRPr sz="1000">
                           <a:solidFill>
                             <a:srgbClr val="000000"/>
                           </a:solidFill>
@@ -16045,14 +16045,14 @@
                   </a:tcPr>
                 </a:tc>
               </a:tr>
-              <a:tr h="365760">
-                <a:tc>
-                  <a:txBody>
-                    <a:bodyPr/>
-                    <a:lstStyle/>
-                    <a:p>
-                      <a:pPr algn="ctr">
-                        <a:defRPr sz="1200">
+              <a:tr h="274320">
+                <a:tc>
+                  <a:txBody>
+                    <a:bodyPr/>
+                    <a:lstStyle/>
+                    <a:p>
+                      <a:pPr algn="ctr">
+                        <a:defRPr sz="1000">
                           <a:solidFill>
                             <a:srgbClr val="000000"/>
                           </a:solidFill>
@@ -16076,7 +16076,7 @@
                     <a:lstStyle/>
                     <a:p>
                       <a:pPr algn="ctr">
-                        <a:defRPr sz="1200">
+                        <a:defRPr sz="1000">
                           <a:solidFill>
                             <a:srgbClr val="000000"/>
                           </a:solidFill>
@@ -16095,14 +16095,14 @@
                   </a:tcPr>
                 </a:tc>
               </a:tr>
-              <a:tr h="365760">
-                <a:tc>
-                  <a:txBody>
-                    <a:bodyPr/>
-                    <a:lstStyle/>
-                    <a:p>
-                      <a:pPr algn="ctr">
-                        <a:defRPr sz="1200">
+              <a:tr h="274320">
+                <a:tc>
+                  <a:txBody>
+                    <a:bodyPr/>
+                    <a:lstStyle/>
+                    <a:p>
+                      <a:pPr algn="ctr">
+                        <a:defRPr sz="1000">
                           <a:solidFill>
                             <a:srgbClr val="000000"/>
                           </a:solidFill>
@@ -16126,7 +16126,7 @@
                     <a:lstStyle/>
                     <a:p>
                       <a:pPr algn="ctr">
-                        <a:defRPr sz="1200">
+                        <a:defRPr sz="1000">
                           <a:solidFill>
                             <a:srgbClr val="000000"/>
                           </a:solidFill>
@@ -16145,14 +16145,14 @@
                   </a:tcPr>
                 </a:tc>
               </a:tr>
-              <a:tr h="365760">
-                <a:tc>
-                  <a:txBody>
-                    <a:bodyPr/>
-                    <a:lstStyle/>
-                    <a:p>
-                      <a:pPr algn="ctr">
-                        <a:defRPr sz="1200">
+              <a:tr h="274320">
+                <a:tc>
+                  <a:txBody>
+                    <a:bodyPr/>
+                    <a:lstStyle/>
+                    <a:p>
+                      <a:pPr algn="ctr">
+                        <a:defRPr sz="1000">
                           <a:solidFill>
                             <a:srgbClr val="000000"/>
                           </a:solidFill>
@@ -16176,7 +16176,7 @@
                     <a:lstStyle/>
                     <a:p>
                       <a:pPr algn="ctr">
-                        <a:defRPr sz="1200">
+                        <a:defRPr sz="1000">
                           <a:solidFill>
                             <a:srgbClr val="000000"/>
                           </a:solidFill>
@@ -16195,14 +16195,14 @@
                   </a:tcPr>
                 </a:tc>
               </a:tr>
-              <a:tr h="365760">
-                <a:tc>
-                  <a:txBody>
-                    <a:bodyPr/>
-                    <a:lstStyle/>
-                    <a:p>
-                      <a:pPr algn="ctr">
-                        <a:defRPr sz="1200">
+              <a:tr h="274320">
+                <a:tc>
+                  <a:txBody>
+                    <a:bodyPr/>
+                    <a:lstStyle/>
+                    <a:p>
+                      <a:pPr algn="ctr">
+                        <a:defRPr sz="1000">
                           <a:solidFill>
                             <a:srgbClr val="000000"/>
                           </a:solidFill>
@@ -16226,7 +16226,7 @@
                     <a:lstStyle/>
                     <a:p>
                       <a:pPr algn="ctr">
-                        <a:defRPr sz="1200">
+                        <a:defRPr sz="1000">
                           <a:solidFill>
                             <a:srgbClr val="000000"/>
                           </a:solidFill>
@@ -16245,14 +16245,14 @@
                   </a:tcPr>
                 </a:tc>
               </a:tr>
-              <a:tr h="365760">
-                <a:tc>
-                  <a:txBody>
-                    <a:bodyPr/>
-                    <a:lstStyle/>
-                    <a:p>
-                      <a:pPr algn="ctr">
-                        <a:defRPr sz="1200">
+              <a:tr h="274320">
+                <a:tc>
+                  <a:txBody>
+                    <a:bodyPr/>
+                    <a:lstStyle/>
+                    <a:p>
+                      <a:pPr algn="ctr">
+                        <a:defRPr sz="1000">
                           <a:solidFill>
                             <a:srgbClr val="000000"/>
                           </a:solidFill>
@@ -16276,7 +16276,7 @@
                     <a:lstStyle/>
                     <a:p>
                       <a:pPr algn="ctr">
-                        <a:defRPr sz="1200">
+                        <a:defRPr sz="1000">
                           <a:solidFill>
                             <a:srgbClr val="000000"/>
                           </a:solidFill>
@@ -16295,14 +16295,14 @@
                   </a:tcPr>
                 </a:tc>
               </a:tr>
-              <a:tr h="365760">
-                <a:tc>
-                  <a:txBody>
-                    <a:bodyPr/>
-                    <a:lstStyle/>
-                    <a:p>
-                      <a:pPr algn="ctr">
-                        <a:defRPr sz="1200">
+              <a:tr h="274320">
+                <a:tc>
+                  <a:txBody>
+                    <a:bodyPr/>
+                    <a:lstStyle/>
+                    <a:p>
+                      <a:pPr algn="ctr">
+                        <a:defRPr sz="1000">
                           <a:solidFill>
                             <a:srgbClr val="000000"/>
                           </a:solidFill>
@@ -16326,7 +16326,7 @@
                     <a:lstStyle/>
                     <a:p>
                       <a:pPr algn="ctr">
-                        <a:defRPr sz="1200">
+                        <a:defRPr sz="1000">
                           <a:solidFill>
                             <a:srgbClr val="000000"/>
                           </a:solidFill>
@@ -16345,14 +16345,14 @@
                   </a:tcPr>
                 </a:tc>
               </a:tr>
-              <a:tr h="365760">
-                <a:tc>
-                  <a:txBody>
-                    <a:bodyPr/>
-                    <a:lstStyle/>
-                    <a:p>
-                      <a:pPr algn="ctr">
-                        <a:defRPr sz="1200">
+              <a:tr h="274320">
+                <a:tc>
+                  <a:txBody>
+                    <a:bodyPr/>
+                    <a:lstStyle/>
+                    <a:p>
+                      <a:pPr algn="ctr">
+                        <a:defRPr sz="1000">
                           <a:solidFill>
                             <a:srgbClr val="000000"/>
                           </a:solidFill>
@@ -16376,7 +16376,7 @@
                     <a:lstStyle/>
                     <a:p>
                       <a:pPr algn="ctr">
-                        <a:defRPr sz="1200">
+                        <a:defRPr sz="1000">
                           <a:solidFill>
                             <a:srgbClr val="000000"/>
                           </a:solidFill>
@@ -16407,7 +16407,7 @@
         </p:nvSpPr>
         <p:spPr>
           <a:xfrm>
-            <a:off x="0" y="4572000"/>
+            <a:off x="0" y="4663440"/>
             <a:ext cx="12191695" cy="45720"/>
           </a:xfrm>
           <a:prstGeom prst="rect">
@@ -16451,7 +16451,7 @@
         </p:nvSpPr>
         <p:spPr>
           <a:xfrm>
-            <a:off x="457200" y="4709160"/>
+            <a:off x="457200" y="4754880"/>
             <a:ext cx="10972800" cy="320040"/>
           </a:xfrm>
           <a:prstGeom prst="rect">
@@ -16488,7 +16488,7 @@
         <p:spPr>
           <a:xfrm>
             <a:off x="457200" y="5120640"/>
-            <a:ext cx="2011680" cy="1188720"/>
+            <a:ext cx="2011680" cy="914400"/>
           </a:xfrm>
           <a:prstGeom prst="roundRect">
             <a:avLst/>
@@ -16520,7 +16520,7 @@
           <a:lstStyle/>
           <a:p>
             <a:pPr algn="ctr">
-              <a:defRPr sz="1100" b="1">
+              <a:defRPr sz="1000" b="1">
                 <a:solidFill>
                   <a:srgbClr val="FFFFFF"/>
                 </a:solidFill>
@@ -16546,7 +16546,7 @@
         <p:spPr>
           <a:xfrm>
             <a:off x="2743200" y="5120640"/>
-            <a:ext cx="2011680" cy="1188720"/>
+            <a:ext cx="2011680" cy="914400"/>
           </a:xfrm>
           <a:prstGeom prst="roundRect">
             <a:avLst/>
@@ -16578,7 +16578,7 @@
           <a:lstStyle/>
           <a:p>
             <a:pPr algn="ctr">
-              <a:defRPr sz="1100" b="1">
+              <a:defRPr sz="1000" b="1">
                 <a:solidFill>
                   <a:srgbClr val="FFFFFF"/>
                 </a:solidFill>
@@ -16586,11 +16586,7 @@
               </a:defRPr>
             </a:pPr>
             <a:r>
-              <a:t>Fabric</a:t>
-            </a:r>
-            <a:br/>
-            <a:r>
-              <a:t>Warehouse</a:t>
+              <a:t>Fabric Warehouse</a:t>
             </a:r>
             <a:br/>
             <a:r>
@@ -16608,7 +16604,7 @@
         <p:spPr>
           <a:xfrm>
             <a:off x="5029200" y="5120640"/>
-            <a:ext cx="2011680" cy="1188720"/>
+            <a:ext cx="2011680" cy="914400"/>
           </a:xfrm>
           <a:prstGeom prst="roundRect">
             <a:avLst/>
@@ -16640,7 +16636,7 @@
           <a:lstStyle/>
           <a:p>
             <a:pPr algn="ctr">
-              <a:defRPr sz="1100" b="1">
+              <a:defRPr sz="1000" b="1">
                 <a:solidFill>
                   <a:srgbClr val="FFFFFF"/>
                 </a:solidFill>
@@ -16648,11 +16644,7 @@
               </a:defRPr>
             </a:pPr>
             <a:r>
-              <a:t>PySpark</a:t>
-            </a:r>
-            <a:br/>
-            <a:r>
-              <a:t>Notebook</a:t>
+              <a:t>PySpark Notebook</a:t>
             </a:r>
             <a:br/>
             <a:r>
@@ -16670,7 +16662,7 @@
         <p:spPr>
           <a:xfrm>
             <a:off x="7315200" y="5120640"/>
-            <a:ext cx="2011680" cy="1188720"/>
+            <a:ext cx="2011680" cy="914400"/>
           </a:xfrm>
           <a:prstGeom prst="roundRect">
             <a:avLst/>
@@ -16702,7 +16694,7 @@
           <a:lstStyle/>
           <a:p>
             <a:pPr algn="ctr">
-              <a:defRPr sz="1100" b="1">
+              <a:defRPr sz="1000" b="1">
                 <a:solidFill>
                   <a:srgbClr val="FFFFFF"/>
                 </a:solidFill>
@@ -16728,7 +16720,7 @@
         <p:spPr>
           <a:xfrm>
             <a:off x="9601200" y="5120640"/>
-            <a:ext cx="2011680" cy="1188720"/>
+            <a:ext cx="2011680" cy="914400"/>
           </a:xfrm>
           <a:prstGeom prst="roundRect">
             <a:avLst/>
@@ -16760,7 +16752,7 @@
           <a:lstStyle/>
           <a:p>
             <a:pPr algn="ctr">
-              <a:defRPr sz="1100" b="1">
+              <a:defRPr sz="1000" b="1">
                 <a:solidFill>
                   <a:srgbClr val="FFFFFF"/>
                 </a:solidFill>
@@ -16773,10 +16765,6 @@
             <a:br/>
             <a:r>
               <a:t>Semantic Model</a:t>
-            </a:r>
-            <a:br/>
-            <a:r>
-              <a:t>Auto-refresh</a:t>
             </a:r>
           </a:p>
         </p:txBody>
@@ -16789,7 +16777,7 @@
         </p:nvSpPr>
         <p:spPr>
           <a:xfrm>
-            <a:off x="2468880" y="5440680"/>
+            <a:off x="2468880" y="5349240"/>
             <a:ext cx="274320" cy="365760"/>
           </a:xfrm>
           <a:prstGeom prst="rect">
@@ -16825,7 +16813,7 @@
         </p:nvSpPr>
         <p:spPr>
           <a:xfrm>
-            <a:off x="4754880" y="5440680"/>
+            <a:off x="4754880" y="5349240"/>
             <a:ext cx="274320" cy="365760"/>
           </a:xfrm>
           <a:prstGeom prst="rect">
@@ -16861,7 +16849,7 @@
         </p:nvSpPr>
         <p:spPr>
           <a:xfrm>
-            <a:off x="7040880" y="5440680"/>
+            <a:off x="7040880" y="5349240"/>
             <a:ext cx="274320" cy="365760"/>
           </a:xfrm>
           <a:prstGeom prst="rect">
@@ -16897,7 +16885,7 @@
         </p:nvSpPr>
         <p:spPr>
           <a:xfrm>
-            <a:off x="9326880" y="5440680"/>
+            <a:off x="9326880" y="5349240"/>
             <a:ext cx="274320" cy="365760"/>
           </a:xfrm>
           <a:prstGeom prst="rect">
@@ -16933,7 +16921,7 @@
         </p:nvSpPr>
         <p:spPr>
           <a:xfrm>
-            <a:off x="457200" y="6400800"/>
+            <a:off x="457200" y="6217920"/>
             <a:ext cx="10972800" cy="274320"/>
           </a:xfrm>
           <a:prstGeom prst="rect">

</xml_diff>

<commit_message>
feat: slide 6 now shows 2 Longview migration options side-by-side
Option A: Keep Longview, swap Essbase backend for Fabric Warehouse (TDS)
Option B: Drop Longview, use Power BI Writeback + Power Apps on SQL
Each with layer comparison table, architecture flow, pros/cons
Bottom recommendation: Option A first, Option B as phased follow-up
</commit_message>
<xml_diff>
--- a/output/OAC_to_Fabric_Business_Deck.pptx
+++ b/output/OAC_to_Fabric_Business_Deck.pptx
@@ -15046,7 +15046,7 @@
               </a:defRPr>
             </a:pPr>
             <a:r>
-              <a:t>Longview / EPM Writeback → Microsoft Fabric</a:t>
+              <a:t>Longview / EPM Writeback → Two Migration Paths</a:t>
             </a:r>
           </a:p>
         </p:txBody>
@@ -15060,7 +15060,7 @@
         <p:spPr>
           <a:xfrm>
             <a:off x="457200" y="685800"/>
-            <a:ext cx="10972800" cy="365760"/>
+            <a:ext cx="10972800" cy="320040"/>
           </a:xfrm>
           <a:prstGeom prst="rect">
             <a:avLst/>
@@ -15082,43 +15082,61 @@
               </a:defRPr>
             </a:pPr>
             <a:r>
-              <a:t>Keep Longview (insightsoftware) as-is — only the Essbase backend is replaced by Fabric Warehouse. Connection string change only, no code changes on the Longview side.</a:t>
-            </a:r>
-          </a:p>
-        </p:txBody>
-      </p:sp>
-      <p:sp>
-        <p:nvSpPr>
-          <p:cNvPr id="4" name="TextBox 3"/>
-          <p:cNvSpPr txBox="1"/>
-          <p:nvPr/>
-        </p:nvSpPr>
-        <p:spPr>
-          <a:xfrm>
-            <a:off x="457200" y="1188720"/>
-            <a:ext cx="5029200" cy="320040"/>
-          </a:xfrm>
-          <a:prstGeom prst="rect">
-            <a:avLst/>
-          </a:prstGeom>
-          <a:noFill/>
-        </p:spPr>
-        <p:txBody>
-          <a:bodyPr wrap="square">
-            <a:spAutoFit/>
-          </a:bodyPr>
-          <a:lstStyle/>
-          <a:p>
-            <a:pPr algn="l">
+              <a:t>Choose the path that fits your timeline and budget planning maturity</a:t>
+            </a:r>
+          </a:p>
+        </p:txBody>
+      </p:sp>
+      <p:sp>
+        <p:nvSpPr>
+          <p:cNvPr id="4" name="Rounded Rectangle 3"/>
+          <p:cNvSpPr/>
+          <p:nvPr/>
+        </p:nvSpPr>
+        <p:spPr>
+          <a:xfrm>
+            <a:off x="274320" y="1097280"/>
+            <a:ext cx="5486400" cy="457200"/>
+          </a:xfrm>
+          <a:prstGeom prst="roundRect">
+            <a:avLst/>
+          </a:prstGeom>
+          <a:solidFill>
+            <a:srgbClr val="00B7C3"/>
+          </a:solidFill>
+          <a:ln>
+            <a:noFill/>
+          </a:ln>
+          <a:effectLst/>
+        </p:spPr>
+        <p:style>
+          <a:lnRef idx="1">
+            <a:schemeClr val="accent1"/>
+          </a:lnRef>
+          <a:fillRef idx="3">
+            <a:schemeClr val="accent1"/>
+          </a:fillRef>
+          <a:effectRef idx="2">
+            <a:schemeClr val="accent1"/>
+          </a:effectRef>
+          <a:fontRef idx="minor">
+            <a:schemeClr val="lt1"/>
+          </a:fontRef>
+        </p:style>
+        <p:txBody>
+          <a:bodyPr rtlCol="0" anchor="ctr"/>
+          <a:lstStyle/>
+          <a:p>
+            <a:pPr algn="ctr">
               <a:defRPr sz="1400" b="1">
                 <a:solidFill>
-                  <a:srgbClr val="00B7C3"/>
-                </a:solidFill>
-                <a:latin typeface="Segoe UI"/>
-              </a:defRPr>
-            </a:pPr>
-            <a:r>
-              <a:t>Backend-Only Migration Strategy</a:t>
+                  <a:srgbClr val="FFFFFF"/>
+                </a:solidFill>
+                <a:latin typeface="Segoe UI"/>
+              </a:defRPr>
+            </a:pPr>
+            <a:r>
+              <a:t>Option A — Keep Longview, Replace Backend</a:t>
             </a:r>
           </a:p>
         </p:txBody>
@@ -15132,8 +15150,8 @@
           <p:nvPr/>
         </p:nvGraphicFramePr>
         <p:xfrm>
-          <a:off x="274320" y="1554480"/>
-          <a:ext cx="5577840" cy="1920240"/>
+          <a:off x="274320" y="1691640"/>
+          <a:ext cx="5029200" cy="1792224"/>
         </p:xfrm>
         <a:graphic>
           <a:graphicData uri="http://schemas.openxmlformats.org/drawingml/2006/table">
@@ -15143,11 +15161,10 @@
               </a:tblPr>
               <a:tblGrid>
                 <a:gridCol w="1097280"/>
-                <a:gridCol w="1554480"/>
-                <a:gridCol w="1828800"/>
-                <a:gridCol w="1097280"/>
+                <a:gridCol w="1645920"/>
+                <a:gridCol w="2286000"/>
               </a:tblGrid>
-              <a:tr h="274320">
+              <a:tr h="256032">
                 <a:tc>
                   <a:txBody>
                     <a:bodyPr/>
@@ -15220,32 +15237,8 @@
                     </a:solidFill>
                   </a:tcPr>
                 </a:tc>
-                <a:tc>
-                  <a:txBody>
-                    <a:bodyPr/>
-                    <a:lstStyle/>
-                    <a:p>
-                      <a:pPr algn="ctr">
-                        <a:defRPr sz="1000" b="1">
-                          <a:solidFill>
-                            <a:srgbClr val="FFFFFF"/>
-                          </a:solidFill>
-                          <a:latin typeface="Segoe UI"/>
-                        </a:defRPr>
-                      </a:pPr>
-                      <a:r>
-                        <a:t>User Impact</a:t>
-                      </a:r>
-                    </a:p>
-                  </a:txBody>
-                  <a:tcPr anchor="ctr">
-                    <a:solidFill>
-                      <a:srgbClr val="00B7C3"/>
-                    </a:solidFill>
-                  </a:tcPr>
-                </a:tc>
               </a:tr>
-              <a:tr h="274320">
+              <a:tr h="256032">
                 <a:tc>
                   <a:txBody>
                     <a:bodyPr/>
@@ -15284,7 +15277,7 @@
                         </a:defRPr>
                       </a:pPr>
                       <a:r>
-                        <a:t>Longview UI / Excel</a:t>
+                        <a:t>Longview UI</a:t>
                       </a:r>
                     </a:p>
                   </a:txBody>
@@ -15308,7 +15301,7 @@
                         </a:defRPr>
                       </a:pPr>
                       <a:r>
-                        <a:t>Longview UI / Excel</a:t>
+                        <a:t>Longview UI (unchanged)</a:t>
                       </a:r>
                     </a:p>
                   </a:txBody>
@@ -15318,6 +15311,8 @@
                     </a:solidFill>
                   </a:tcPr>
                 </a:tc>
+              </a:tr>
+              <a:tr h="256032">
                 <a:tc>
                   <a:txBody>
                     <a:bodyPr/>
@@ -15332,7 +15327,81 @@
                         </a:defRPr>
                       </a:pPr>
                       <a:r>
-                        <a:t>None</a:t>
+                        <a:t>Writeback</a:t>
+                      </a:r>
+                    </a:p>
+                  </a:txBody>
+                  <a:tcPr anchor="ctr">
+                    <a:solidFill>
+                      <a:srgbClr val="F3F2F1"/>
+                    </a:solidFill>
+                  </a:tcPr>
+                </a:tc>
+                <a:tc>
+                  <a:txBody>
+                    <a:bodyPr/>
+                    <a:lstStyle/>
+                    <a:p>
+                      <a:pPr algn="ctr">
+                        <a:defRPr sz="1000">
+                          <a:solidFill>
+                            <a:srgbClr val="000000"/>
+                          </a:solidFill>
+                          <a:latin typeface="Segoe UI"/>
+                        </a:defRPr>
+                      </a:pPr>
+                      <a:r>
+                        <a:t>Essbase cube</a:t>
+                      </a:r>
+                    </a:p>
+                  </a:txBody>
+                  <a:tcPr anchor="ctr">
+                    <a:solidFill>
+                      <a:srgbClr val="F3F2F1"/>
+                    </a:solidFill>
+                  </a:tcPr>
+                </a:tc>
+                <a:tc>
+                  <a:txBody>
+                    <a:bodyPr/>
+                    <a:lstStyle/>
+                    <a:p>
+                      <a:pPr algn="ctr">
+                        <a:defRPr sz="1000">
+                          <a:solidFill>
+                            <a:srgbClr val="000000"/>
+                          </a:solidFill>
+                          <a:latin typeface="Segoe UI"/>
+                        </a:defRPr>
+                      </a:pPr>
+                      <a:r>
+                        <a:t>Fabric Warehouse (TDS)</a:t>
+                      </a:r>
+                    </a:p>
+                  </a:txBody>
+                  <a:tcPr anchor="ctr">
+                    <a:solidFill>
+                      <a:srgbClr val="F3F2F1"/>
+                    </a:solidFill>
+                  </a:tcPr>
+                </a:tc>
+              </a:tr>
+              <a:tr h="256032">
+                <a:tc>
+                  <a:txBody>
+                    <a:bodyPr/>
+                    <a:lstStyle/>
+                    <a:p>
+                      <a:pPr algn="ctr">
+                        <a:defRPr sz="1000">
+                          <a:solidFill>
+                            <a:srgbClr val="000000"/>
+                          </a:solidFill>
+                          <a:latin typeface="Segoe UI"/>
+                        </a:defRPr>
+                      </a:pPr>
+                      <a:r>
+                        <a:t>Calc engine</a:t>
                       </a:r>
                     </a:p>
                   </a:txBody>
@@ -15342,8 +15411,56 @@
                     </a:solidFill>
                   </a:tcPr>
                 </a:tc>
+                <a:tc>
+                  <a:txBody>
+                    <a:bodyPr/>
+                    <a:lstStyle/>
+                    <a:p>
+                      <a:pPr algn="ctr">
+                        <a:defRPr sz="1000">
+                          <a:solidFill>
+                            <a:srgbClr val="000000"/>
+                          </a:solidFill>
+                          <a:latin typeface="Segoe UI"/>
+                        </a:defRPr>
+                      </a:pPr>
+                      <a:r>
+                        <a:t>Essbase scripts</a:t>
+                      </a:r>
+                    </a:p>
+                  </a:txBody>
+                  <a:tcPr anchor="ctr">
+                    <a:solidFill>
+                      <a:srgbClr val="FFFFFF"/>
+                    </a:solidFill>
+                  </a:tcPr>
+                </a:tc>
+                <a:tc>
+                  <a:txBody>
+                    <a:bodyPr/>
+                    <a:lstStyle/>
+                    <a:p>
+                      <a:pPr algn="ctr">
+                        <a:defRPr sz="1000">
+                          <a:solidFill>
+                            <a:srgbClr val="000000"/>
+                          </a:solidFill>
+                          <a:latin typeface="Segoe UI"/>
+                        </a:defRPr>
+                      </a:pPr>
+                      <a:r>
+                        <a:t>Fabric Notebook (PySpark)</a:t>
+                      </a:r>
+                    </a:p>
+                  </a:txBody>
+                  <a:tcPr anchor="ctr">
+                    <a:solidFill>
+                      <a:srgbClr val="FFFFFF"/>
+                    </a:solidFill>
+                  </a:tcPr>
+                </a:tc>
               </a:tr>
-              <a:tr h="274320">
+              <a:tr h="256032">
                 <a:tc>
                   <a:txBody>
                     <a:bodyPr/>
@@ -15358,7 +15475,7 @@
                         </a:defRPr>
                       </a:pPr>
                       <a:r>
-                        <a:t>Writeback</a:t>
+                        <a:t>Reporting</a:t>
                       </a:r>
                     </a:p>
                   </a:txBody>
@@ -15382,7 +15499,7 @@
                         </a:defRPr>
                       </a:pPr>
                       <a:r>
-                        <a:t>Essbase cube</a:t>
+                        <a:t>OAC / Smart View</a:t>
                       </a:r>
                     </a:p>
                   </a:txBody>
@@ -15406,7 +15523,7 @@
                         </a:defRPr>
                       </a:pPr>
                       <a:r>
-                        <a:t>Fabric Warehouse (TDS)</a:t>
+                        <a:t>Power BI DirectLake</a:t>
                       </a:r>
                     </a:p>
                   </a:txBody>
@@ -15416,6 +15533,8 @@
                     </a:solidFill>
                   </a:tcPr>
                 </a:tc>
+              </a:tr>
+              <a:tr h="256032">
                 <a:tc>
                   <a:txBody>
                     <a:bodyPr/>
@@ -15430,7 +15549,81 @@
                         </a:defRPr>
                       </a:pPr>
                       <a:r>
-                        <a:t>Conn. string</a:t>
+                        <a:t>Security</a:t>
+                      </a:r>
+                    </a:p>
+                  </a:txBody>
+                  <a:tcPr anchor="ctr">
+                    <a:solidFill>
+                      <a:srgbClr val="FFFFFF"/>
+                    </a:solidFill>
+                  </a:tcPr>
+                </a:tc>
+                <a:tc>
+                  <a:txBody>
+                    <a:bodyPr/>
+                    <a:lstStyle/>
+                    <a:p>
+                      <a:pPr algn="ctr">
+                        <a:defRPr sz="1000">
+                          <a:solidFill>
+                            <a:srgbClr val="000000"/>
+                          </a:solidFill>
+                          <a:latin typeface="Segoe UI"/>
+                        </a:defRPr>
+                      </a:pPr>
+                      <a:r>
+                        <a:t>Essbase filters</a:t>
+                      </a:r>
+                    </a:p>
+                  </a:txBody>
+                  <a:tcPr anchor="ctr">
+                    <a:solidFill>
+                      <a:srgbClr val="FFFFFF"/>
+                    </a:solidFill>
+                  </a:tcPr>
+                </a:tc>
+                <a:tc>
+                  <a:txBody>
+                    <a:bodyPr/>
+                    <a:lstStyle/>
+                    <a:p>
+                      <a:pPr algn="ctr">
+                        <a:defRPr sz="1000">
+                          <a:solidFill>
+                            <a:srgbClr val="000000"/>
+                          </a:solidFill>
+                          <a:latin typeface="Segoe UI"/>
+                        </a:defRPr>
+                      </a:pPr>
+                      <a:r>
+                        <a:t>Entra ID + RLS</a:t>
+                      </a:r>
+                    </a:p>
+                  </a:txBody>
+                  <a:tcPr anchor="ctr">
+                    <a:solidFill>
+                      <a:srgbClr val="FFFFFF"/>
+                    </a:solidFill>
+                  </a:tcPr>
+                </a:tc>
+              </a:tr>
+              <a:tr h="256032">
+                <a:tc>
+                  <a:txBody>
+                    <a:bodyPr/>
+                    <a:lstStyle/>
+                    <a:p>
+                      <a:pPr algn="ctr">
+                        <a:defRPr sz="1000">
+                          <a:solidFill>
+                            <a:srgbClr val="000000"/>
+                          </a:solidFill>
+                          <a:latin typeface="Segoe UI"/>
+                        </a:defRPr>
+                      </a:pPr>
+                      <a:r>
+                        <a:t>License</a:t>
                       </a:r>
                     </a:p>
                   </a:txBody>
@@ -15440,8 +15633,6 @@
                     </a:solidFill>
                   </a:tcPr>
                 </a:tc>
-              </a:tr>
-              <a:tr h="274320">
                 <a:tc>
                   <a:txBody>
                     <a:bodyPr/>
@@ -15456,13 +15647,13 @@
                         </a:defRPr>
                       </a:pPr>
                       <a:r>
-                        <a:t>Calc engine</a:t>
-                      </a:r>
-                    </a:p>
-                  </a:txBody>
-                  <a:tcPr anchor="ctr">
-                    <a:solidFill>
-                      <a:srgbClr val="FFFFFF"/>
+                        <a:t>Oracle Essbase</a:t>
+                      </a:r>
+                    </a:p>
+                  </a:txBody>
+                  <a:tcPr anchor="ctr">
+                    <a:solidFill>
+                      <a:srgbClr val="F3F2F1"/>
                     </a:solidFill>
                   </a:tcPr>
                 </a:tc>
@@ -15480,349 +15671,7 @@
                         </a:defRPr>
                       </a:pPr>
                       <a:r>
-                        <a:t>Essbase calc scripts</a:t>
-                      </a:r>
-                    </a:p>
-                  </a:txBody>
-                  <a:tcPr anchor="ctr">
-                    <a:solidFill>
-                      <a:srgbClr val="FFFFFF"/>
-                    </a:solidFill>
-                  </a:tcPr>
-                </a:tc>
-                <a:tc>
-                  <a:txBody>
-                    <a:bodyPr/>
-                    <a:lstStyle/>
-                    <a:p>
-                      <a:pPr algn="ctr">
-                        <a:defRPr sz="1000">
-                          <a:solidFill>
-                            <a:srgbClr val="000000"/>
-                          </a:solidFill>
-                          <a:latin typeface="Segoe UI"/>
-                        </a:defRPr>
-                      </a:pPr>
-                      <a:r>
-                        <a:t>Fabric Notebook (PySpark)</a:t>
-                      </a:r>
-                    </a:p>
-                  </a:txBody>
-                  <a:tcPr anchor="ctr">
-                    <a:solidFill>
-                      <a:srgbClr val="FFFFFF"/>
-                    </a:solidFill>
-                  </a:tcPr>
-                </a:tc>
-                <a:tc>
-                  <a:txBody>
-                    <a:bodyPr/>
-                    <a:lstStyle/>
-                    <a:p>
-                      <a:pPr algn="ctr">
-                        <a:defRPr sz="1000">
-                          <a:solidFill>
-                            <a:srgbClr val="000000"/>
-                          </a:solidFill>
-                          <a:latin typeface="Segoe UI"/>
-                        </a:defRPr>
-                      </a:pPr>
-                      <a:r>
-                        <a:t>Transparent</a:t>
-                      </a:r>
-                    </a:p>
-                  </a:txBody>
-                  <a:tcPr anchor="ctr">
-                    <a:solidFill>
-                      <a:srgbClr val="FFFFFF"/>
-                    </a:solidFill>
-                  </a:tcPr>
-                </a:tc>
-              </a:tr>
-              <a:tr h="274320">
-                <a:tc>
-                  <a:txBody>
-                    <a:bodyPr/>
-                    <a:lstStyle/>
-                    <a:p>
-                      <a:pPr algn="ctr">
-                        <a:defRPr sz="1000">
-                          <a:solidFill>
-                            <a:srgbClr val="000000"/>
-                          </a:solidFill>
-                          <a:latin typeface="Segoe UI"/>
-                        </a:defRPr>
-                      </a:pPr>
-                      <a:r>
-                        <a:t>Reporting</a:t>
-                      </a:r>
-                    </a:p>
-                  </a:txBody>
-                  <a:tcPr anchor="ctr">
-                    <a:solidFill>
-                      <a:srgbClr val="F3F2F1"/>
-                    </a:solidFill>
-                  </a:tcPr>
-                </a:tc>
-                <a:tc>
-                  <a:txBody>
-                    <a:bodyPr/>
-                    <a:lstStyle/>
-                    <a:p>
-                      <a:pPr algn="ctr">
-                        <a:defRPr sz="1000">
-                          <a:solidFill>
-                            <a:srgbClr val="000000"/>
-                          </a:solidFill>
-                          <a:latin typeface="Segoe UI"/>
-                        </a:defRPr>
-                      </a:pPr>
-                      <a:r>
-                        <a:t>OAC / Smart View</a:t>
-                      </a:r>
-                    </a:p>
-                  </a:txBody>
-                  <a:tcPr anchor="ctr">
-                    <a:solidFill>
-                      <a:srgbClr val="F3F2F1"/>
-                    </a:solidFill>
-                  </a:tcPr>
-                </a:tc>
-                <a:tc>
-                  <a:txBody>
-                    <a:bodyPr/>
-                    <a:lstStyle/>
-                    <a:p>
-                      <a:pPr algn="ctr">
-                        <a:defRPr sz="1000">
-                          <a:solidFill>
-                            <a:srgbClr val="000000"/>
-                          </a:solidFill>
-                          <a:latin typeface="Segoe UI"/>
-                        </a:defRPr>
-                      </a:pPr>
-                      <a:r>
-                        <a:t>Power BI DirectLake</a:t>
-                      </a:r>
-                    </a:p>
-                  </a:txBody>
-                  <a:tcPr anchor="ctr">
-                    <a:solidFill>
-                      <a:srgbClr val="F3F2F1"/>
-                    </a:solidFill>
-                  </a:tcPr>
-                </a:tc>
-                <a:tc>
-                  <a:txBody>
-                    <a:bodyPr/>
-                    <a:lstStyle/>
-                    <a:p>
-                      <a:pPr algn="ctr">
-                        <a:defRPr sz="1000">
-                          <a:solidFill>
-                            <a:srgbClr val="000000"/>
-                          </a:solidFill>
-                          <a:latin typeface="Segoe UI"/>
-                        </a:defRPr>
-                      </a:pPr>
-                      <a:r>
-                        <a:t>New dashboards</a:t>
-                      </a:r>
-                    </a:p>
-                  </a:txBody>
-                  <a:tcPr anchor="ctr">
-                    <a:solidFill>
-                      <a:srgbClr val="F3F2F1"/>
-                    </a:solidFill>
-                  </a:tcPr>
-                </a:tc>
-              </a:tr>
-              <a:tr h="274320">
-                <a:tc>
-                  <a:txBody>
-                    <a:bodyPr/>
-                    <a:lstStyle/>
-                    <a:p>
-                      <a:pPr algn="ctr">
-                        <a:defRPr sz="1000">
-                          <a:solidFill>
-                            <a:srgbClr val="000000"/>
-                          </a:solidFill>
-                          <a:latin typeface="Segoe UI"/>
-                        </a:defRPr>
-                      </a:pPr>
-                      <a:r>
-                        <a:t>Security</a:t>
-                      </a:r>
-                    </a:p>
-                  </a:txBody>
-                  <a:tcPr anchor="ctr">
-                    <a:solidFill>
-                      <a:srgbClr val="FFFFFF"/>
-                    </a:solidFill>
-                  </a:tcPr>
-                </a:tc>
-                <a:tc>
-                  <a:txBody>
-                    <a:bodyPr/>
-                    <a:lstStyle/>
-                    <a:p>
-                      <a:pPr algn="ctr">
-                        <a:defRPr sz="1000">
-                          <a:solidFill>
-                            <a:srgbClr val="000000"/>
-                          </a:solidFill>
-                          <a:latin typeface="Segoe UI"/>
-                        </a:defRPr>
-                      </a:pPr>
-                      <a:r>
-                        <a:t>Essbase filters + SSO</a:t>
-                      </a:r>
-                    </a:p>
-                  </a:txBody>
-                  <a:tcPr anchor="ctr">
-                    <a:solidFill>
-                      <a:srgbClr val="FFFFFF"/>
-                    </a:solidFill>
-                  </a:tcPr>
-                </a:tc>
-                <a:tc>
-                  <a:txBody>
-                    <a:bodyPr/>
-                    <a:lstStyle/>
-                    <a:p>
-                      <a:pPr algn="ctr">
-                        <a:defRPr sz="1000">
-                          <a:solidFill>
-                            <a:srgbClr val="000000"/>
-                          </a:solidFill>
-                          <a:latin typeface="Segoe UI"/>
-                        </a:defRPr>
-                      </a:pPr>
-                      <a:r>
-                        <a:t>Entra ID + RLS</a:t>
-                      </a:r>
-                    </a:p>
-                  </a:txBody>
-                  <a:tcPr anchor="ctr">
-                    <a:solidFill>
-                      <a:srgbClr val="FFFFFF"/>
-                    </a:solidFill>
-                  </a:tcPr>
-                </a:tc>
-                <a:tc>
-                  <a:txBody>
-                    <a:bodyPr/>
-                    <a:lstStyle/>
-                    <a:p>
-                      <a:pPr algn="ctr">
-                        <a:defRPr sz="1000">
-                          <a:solidFill>
-                            <a:srgbClr val="000000"/>
-                          </a:solidFill>
-                          <a:latin typeface="Segoe UI"/>
-                        </a:defRPr>
-                      </a:pPr>
-                      <a:r>
-                        <a:t>Upgraded</a:t>
-                      </a:r>
-                    </a:p>
-                  </a:txBody>
-                  <a:tcPr anchor="ctr">
-                    <a:solidFill>
-                      <a:srgbClr val="FFFFFF"/>
-                    </a:solidFill>
-                  </a:tcPr>
-                </a:tc>
-              </a:tr>
-              <a:tr h="274320">
-                <a:tc>
-                  <a:txBody>
-                    <a:bodyPr/>
-                    <a:lstStyle/>
-                    <a:p>
-                      <a:pPr algn="ctr">
-                        <a:defRPr sz="1000">
-                          <a:solidFill>
-                            <a:srgbClr val="000000"/>
-                          </a:solidFill>
-                          <a:latin typeface="Segoe UI"/>
-                        </a:defRPr>
-                      </a:pPr>
-                      <a:r>
-                        <a:t>Licensing</a:t>
-                      </a:r>
-                    </a:p>
-                  </a:txBody>
-                  <a:tcPr anchor="ctr">
-                    <a:solidFill>
-                      <a:srgbClr val="F3F2F1"/>
-                    </a:solidFill>
-                  </a:tcPr>
-                </a:tc>
-                <a:tc>
-                  <a:txBody>
-                    <a:bodyPr/>
-                    <a:lstStyle/>
-                    <a:p>
-                      <a:pPr algn="ctr">
-                        <a:defRPr sz="1000">
-                          <a:solidFill>
-                            <a:srgbClr val="000000"/>
-                          </a:solidFill>
-                          <a:latin typeface="Segoe UI"/>
-                        </a:defRPr>
-                      </a:pPr>
-                      <a:r>
-                        <a:t>Oracle Essbase</a:t>
-                      </a:r>
-                    </a:p>
-                  </a:txBody>
-                  <a:tcPr anchor="ctr">
-                    <a:solidFill>
-                      <a:srgbClr val="F3F2F1"/>
-                    </a:solidFill>
-                  </a:tcPr>
-                </a:tc>
-                <a:tc>
-                  <a:txBody>
-                    <a:bodyPr/>
-                    <a:lstStyle/>
-                    <a:p>
-                      <a:pPr algn="ctr">
-                        <a:defRPr sz="1000">
-                          <a:solidFill>
-                            <a:srgbClr val="000000"/>
-                          </a:solidFill>
-                          <a:latin typeface="Segoe UI"/>
-                        </a:defRPr>
-                      </a:pPr>
-                      <a:r>
-                        <a:t>Fabric capacity (F SKU)</a:t>
-                      </a:r>
-                    </a:p>
-                  </a:txBody>
-                  <a:tcPr anchor="ctr">
-                    <a:solidFill>
-                      <a:srgbClr val="F3F2F1"/>
-                    </a:solidFill>
-                  </a:tcPr>
-                </a:tc>
-                <a:tc>
-                  <a:txBody>
-                    <a:bodyPr/>
-                    <a:lstStyle/>
-                    <a:p>
-                      <a:pPr algn="ctr">
-                        <a:defRPr sz="1000">
-                          <a:solidFill>
-                            <a:srgbClr val="000000"/>
-                          </a:solidFill>
-                          <a:latin typeface="Segoe UI"/>
-                        </a:defRPr>
-                      </a:pPr>
-                      <a:r>
-                        <a:t>Cost saving</a:t>
+                        <a:t>Fabric F SKU</a:t>
                       </a:r>
                     </a:p>
                   </a:txBody>
@@ -15839,14 +15688,242 @@
       </p:graphicFrame>
       <p:sp>
         <p:nvSpPr>
-          <p:cNvPr id="6" name="TextBox 5"/>
+          <p:cNvPr id="6" name="Rounded Rectangle 5"/>
+          <p:cNvSpPr/>
+          <p:nvPr/>
+        </p:nvSpPr>
+        <p:spPr>
+          <a:xfrm>
+            <a:off x="365760" y="3794760"/>
+            <a:ext cx="1143000" cy="640080"/>
+          </a:xfrm>
+          <a:prstGeom prst="roundRect">
+            <a:avLst/>
+          </a:prstGeom>
+          <a:solidFill>
+            <a:srgbClr val="6B2D8B"/>
+          </a:solidFill>
+          <a:ln>
+            <a:noFill/>
+          </a:ln>
+          <a:effectLst/>
+        </p:spPr>
+        <p:style>
+          <a:lnRef idx="1">
+            <a:schemeClr val="accent1"/>
+          </a:lnRef>
+          <a:fillRef idx="3">
+            <a:schemeClr val="accent1"/>
+          </a:fillRef>
+          <a:effectRef idx="2">
+            <a:schemeClr val="accent1"/>
+          </a:effectRef>
+          <a:fontRef idx="minor">
+            <a:schemeClr val="lt1"/>
+          </a:fontRef>
+        </p:style>
+        <p:txBody>
+          <a:bodyPr rtlCol="0" anchor="ctr" wrap="square"/>
+          <a:lstStyle/>
+          <a:p>
+            <a:pPr algn="ctr">
+              <a:defRPr sz="900" b="1">
+                <a:solidFill>
+                  <a:srgbClr val="FFFFFF"/>
+                </a:solidFill>
+                <a:latin typeface="Segoe UI"/>
+              </a:defRPr>
+            </a:pPr>
+            <a:r>
+              <a:t>Longview</a:t>
+            </a:r>
+          </a:p>
+        </p:txBody>
+      </p:sp>
+      <p:sp>
+        <p:nvSpPr>
+          <p:cNvPr id="7" name="Rounded Rectangle 6"/>
+          <p:cNvSpPr/>
+          <p:nvPr/>
+        </p:nvSpPr>
+        <p:spPr>
+          <a:xfrm>
+            <a:off x="1645920" y="3794760"/>
+            <a:ext cx="1143000" cy="640080"/>
+          </a:xfrm>
+          <a:prstGeom prst="roundRect">
+            <a:avLst/>
+          </a:prstGeom>
+          <a:solidFill>
+            <a:srgbClr val="0078D4"/>
+          </a:solidFill>
+          <a:ln>
+            <a:noFill/>
+          </a:ln>
+          <a:effectLst/>
+        </p:spPr>
+        <p:style>
+          <a:lnRef idx="1">
+            <a:schemeClr val="accent1"/>
+          </a:lnRef>
+          <a:fillRef idx="3">
+            <a:schemeClr val="accent1"/>
+          </a:fillRef>
+          <a:effectRef idx="2">
+            <a:schemeClr val="accent1"/>
+          </a:effectRef>
+          <a:fontRef idx="minor">
+            <a:schemeClr val="lt1"/>
+          </a:fontRef>
+        </p:style>
+        <p:txBody>
+          <a:bodyPr rtlCol="0" anchor="ctr" wrap="square"/>
+          <a:lstStyle/>
+          <a:p>
+            <a:pPr algn="ctr">
+              <a:defRPr sz="900" b="1">
+                <a:solidFill>
+                  <a:srgbClr val="FFFFFF"/>
+                </a:solidFill>
+                <a:latin typeface="Segoe UI"/>
+              </a:defRPr>
+            </a:pPr>
+            <a:r>
+              <a:t>Fabric</a:t>
+            </a:r>
+            <a:br/>
+            <a:r>
+              <a:t>Warehouse</a:t>
+            </a:r>
+          </a:p>
+        </p:txBody>
+      </p:sp>
+      <p:sp>
+        <p:nvSpPr>
+          <p:cNvPr id="8" name="Rounded Rectangle 7"/>
+          <p:cNvSpPr/>
+          <p:nvPr/>
+        </p:nvSpPr>
+        <p:spPr>
+          <a:xfrm>
+            <a:off x="2926080" y="3794760"/>
+            <a:ext cx="1143000" cy="640080"/>
+          </a:xfrm>
+          <a:prstGeom prst="roundRect">
+            <a:avLst/>
+          </a:prstGeom>
+          <a:solidFill>
+            <a:srgbClr val="FF8C00"/>
+          </a:solidFill>
+          <a:ln>
+            <a:noFill/>
+          </a:ln>
+          <a:effectLst/>
+        </p:spPr>
+        <p:style>
+          <a:lnRef idx="1">
+            <a:schemeClr val="accent1"/>
+          </a:lnRef>
+          <a:fillRef idx="3">
+            <a:schemeClr val="accent1"/>
+          </a:fillRef>
+          <a:effectRef idx="2">
+            <a:schemeClr val="accent1"/>
+          </a:effectRef>
+          <a:fontRef idx="minor">
+            <a:schemeClr val="lt1"/>
+          </a:fontRef>
+        </p:style>
+        <p:txBody>
+          <a:bodyPr rtlCol="0" anchor="ctr" wrap="square"/>
+          <a:lstStyle/>
+          <a:p>
+            <a:pPr algn="ctr">
+              <a:defRPr sz="900" b="1">
+                <a:solidFill>
+                  <a:srgbClr val="FFFFFF"/>
+                </a:solidFill>
+                <a:latin typeface="Segoe UI"/>
+              </a:defRPr>
+            </a:pPr>
+            <a:r>
+              <a:t>PySpark</a:t>
+            </a:r>
+            <a:br/>
+            <a:r>
+              <a:t>Notebook</a:t>
+            </a:r>
+          </a:p>
+        </p:txBody>
+      </p:sp>
+      <p:sp>
+        <p:nvSpPr>
+          <p:cNvPr id="9" name="Rounded Rectangle 8"/>
+          <p:cNvSpPr/>
+          <p:nvPr/>
+        </p:nvSpPr>
+        <p:spPr>
+          <a:xfrm>
+            <a:off x="4206240" y="3794760"/>
+            <a:ext cx="1143000" cy="640080"/>
+          </a:xfrm>
+          <a:prstGeom prst="roundRect">
+            <a:avLst/>
+          </a:prstGeom>
+          <a:solidFill>
+            <a:srgbClr val="107C10"/>
+          </a:solidFill>
+          <a:ln>
+            <a:noFill/>
+          </a:ln>
+          <a:effectLst/>
+        </p:spPr>
+        <p:style>
+          <a:lnRef idx="1">
+            <a:schemeClr val="accent1"/>
+          </a:lnRef>
+          <a:fillRef idx="3">
+            <a:schemeClr val="accent1"/>
+          </a:fillRef>
+          <a:effectRef idx="2">
+            <a:schemeClr val="accent1"/>
+          </a:effectRef>
+          <a:fontRef idx="minor">
+            <a:schemeClr val="lt1"/>
+          </a:fontRef>
+        </p:style>
+        <p:txBody>
+          <a:bodyPr rtlCol="0" anchor="ctr" wrap="square"/>
+          <a:lstStyle/>
+          <a:p>
+            <a:pPr algn="ctr">
+              <a:defRPr sz="900" b="1">
+                <a:solidFill>
+                  <a:srgbClr val="FFFFFF"/>
+                </a:solidFill>
+                <a:latin typeface="Segoe UI"/>
+              </a:defRPr>
+            </a:pPr>
+            <a:r>
+              <a:t>DirectLake</a:t>
+            </a:r>
+            <a:br/>
+            <a:r>
+              <a:t>Power BI</a:t>
+            </a:r>
+          </a:p>
+        </p:txBody>
+      </p:sp>
+      <p:sp>
+        <p:nvSpPr>
+          <p:cNvPr id="10" name="TextBox 9"/>
           <p:cNvSpPr txBox="1"/>
           <p:nvPr/>
         </p:nvSpPr>
         <p:spPr>
           <a:xfrm>
-            <a:off x="6400800" y="1188720"/>
-            <a:ext cx="5029200" cy="320040"/>
+            <a:off x="1508760" y="3886200"/>
+            <a:ext cx="137160" cy="365760"/>
           </a:xfrm>
           <a:prstGeom prst="rect">
             <a:avLst/>
@@ -15859,31 +15936,543 @@
           </a:bodyPr>
           <a:lstStyle/>
           <a:p>
+            <a:pPr algn="ctr">
+              <a:defRPr sz="1400" b="1">
+                <a:solidFill>
+                  <a:srgbClr val="002B5C"/>
+                </a:solidFill>
+                <a:latin typeface="Segoe UI"/>
+              </a:defRPr>
+            </a:pPr>
+            <a:r>
+              <a:t>→</a:t>
+            </a:r>
+          </a:p>
+        </p:txBody>
+      </p:sp>
+      <p:sp>
+        <p:nvSpPr>
+          <p:cNvPr id="11" name="TextBox 10"/>
+          <p:cNvSpPr txBox="1"/>
+          <p:nvPr/>
+        </p:nvSpPr>
+        <p:spPr>
+          <a:xfrm>
+            <a:off x="2788920" y="3886200"/>
+            <a:ext cx="137160" cy="365760"/>
+          </a:xfrm>
+          <a:prstGeom prst="rect">
+            <a:avLst/>
+          </a:prstGeom>
+          <a:noFill/>
+        </p:spPr>
+        <p:txBody>
+          <a:bodyPr wrap="square">
+            <a:spAutoFit/>
+          </a:bodyPr>
+          <a:lstStyle/>
+          <a:p>
+            <a:pPr algn="ctr">
+              <a:defRPr sz="1400" b="1">
+                <a:solidFill>
+                  <a:srgbClr val="002B5C"/>
+                </a:solidFill>
+                <a:latin typeface="Segoe UI"/>
+              </a:defRPr>
+            </a:pPr>
+            <a:r>
+              <a:t>→</a:t>
+            </a:r>
+          </a:p>
+        </p:txBody>
+      </p:sp>
+      <p:sp>
+        <p:nvSpPr>
+          <p:cNvPr id="12" name="TextBox 11"/>
+          <p:cNvSpPr txBox="1"/>
+          <p:nvPr/>
+        </p:nvSpPr>
+        <p:spPr>
+          <a:xfrm>
+            <a:off x="4069080" y="3886200"/>
+            <a:ext cx="137160" cy="365760"/>
+          </a:xfrm>
+          <a:prstGeom prst="rect">
+            <a:avLst/>
+          </a:prstGeom>
+          <a:noFill/>
+        </p:spPr>
+        <p:txBody>
+          <a:bodyPr wrap="square">
+            <a:spAutoFit/>
+          </a:bodyPr>
+          <a:lstStyle/>
+          <a:p>
+            <a:pPr algn="ctr">
+              <a:defRPr sz="1400" b="1">
+                <a:solidFill>
+                  <a:srgbClr val="002B5C"/>
+                </a:solidFill>
+                <a:latin typeface="Segoe UI"/>
+              </a:defRPr>
+            </a:pPr>
+            <a:r>
+              <a:t>→</a:t>
+            </a:r>
+          </a:p>
+        </p:txBody>
+      </p:sp>
+      <p:sp>
+        <p:nvSpPr>
+          <p:cNvPr id="13" name="TextBox 12"/>
+          <p:cNvSpPr txBox="1"/>
+          <p:nvPr/>
+        </p:nvSpPr>
+        <p:spPr>
+          <a:xfrm>
+            <a:off x="274320" y="4572000"/>
+            <a:ext cx="5486400" cy="228600"/>
+          </a:xfrm>
+          <a:prstGeom prst="rect">
+            <a:avLst/>
+          </a:prstGeom>
+          <a:noFill/>
+        </p:spPr>
+        <p:txBody>
+          <a:bodyPr wrap="square">
+            <a:spAutoFit/>
+          </a:bodyPr>
+          <a:lstStyle/>
+          <a:p>
             <a:pPr algn="l">
+              <a:defRPr sz="1100" b="1">
+                <a:solidFill>
+                  <a:srgbClr val="107C10"/>
+                </a:solidFill>
+                <a:latin typeface="Segoe UI"/>
+              </a:defRPr>
+            </a:pPr>
+            <a:r>
+              <a:t>✅ Pros</a:t>
+            </a:r>
+          </a:p>
+        </p:txBody>
+      </p:sp>
+      <p:sp>
+        <p:nvSpPr>
+          <p:cNvPr id="14" name="TextBox 13"/>
+          <p:cNvSpPr txBox="1"/>
+          <p:nvPr/>
+        </p:nvSpPr>
+        <p:spPr>
+          <a:xfrm>
+            <a:off x="411480" y="4800600"/>
+            <a:ext cx="5303520" cy="182880"/>
+          </a:xfrm>
+          <a:prstGeom prst="rect">
+            <a:avLst/>
+          </a:prstGeom>
+          <a:noFill/>
+        </p:spPr>
+        <p:txBody>
+          <a:bodyPr wrap="square">
+            <a:spAutoFit/>
+          </a:bodyPr>
+          <a:lstStyle/>
+          <a:p>
+            <a:pPr algn="l">
+              <a:defRPr sz="900" b="0">
+                <a:solidFill>
+                  <a:srgbClr val="000000"/>
+                </a:solidFill>
+                <a:latin typeface="Segoe UI"/>
+              </a:defRPr>
+            </a:pPr>
+            <a:r>
+              <a:t>• Zero change for Longview users (same UI/forms)</a:t>
+            </a:r>
+          </a:p>
+        </p:txBody>
+      </p:sp>
+      <p:sp>
+        <p:nvSpPr>
+          <p:cNvPr id="15" name="TextBox 14"/>
+          <p:cNvSpPr txBox="1"/>
+          <p:nvPr/>
+        </p:nvSpPr>
+        <p:spPr>
+          <a:xfrm>
+            <a:off x="411480" y="4965192"/>
+            <a:ext cx="5303520" cy="182880"/>
+          </a:xfrm>
+          <a:prstGeom prst="rect">
+            <a:avLst/>
+          </a:prstGeom>
+          <a:noFill/>
+        </p:spPr>
+        <p:txBody>
+          <a:bodyPr wrap="square">
+            <a:spAutoFit/>
+          </a:bodyPr>
+          <a:lstStyle/>
+          <a:p>
+            <a:pPr algn="l">
+              <a:defRPr sz="900" b="0">
+                <a:solidFill>
+                  <a:srgbClr val="000000"/>
+                </a:solidFill>
+                <a:latin typeface="Segoe UI"/>
+              </a:defRPr>
+            </a:pPr>
+            <a:r>
+              <a:t>• Preserves all Longview workflows &amp; approvals</a:t>
+            </a:r>
+          </a:p>
+        </p:txBody>
+      </p:sp>
+      <p:sp>
+        <p:nvSpPr>
+          <p:cNvPr id="16" name="TextBox 15"/>
+          <p:cNvSpPr txBox="1"/>
+          <p:nvPr/>
+        </p:nvSpPr>
+        <p:spPr>
+          <a:xfrm>
+            <a:off x="411480" y="5129784"/>
+            <a:ext cx="5303520" cy="182880"/>
+          </a:xfrm>
+          <a:prstGeom prst="rect">
+            <a:avLst/>
+          </a:prstGeom>
+          <a:noFill/>
+        </p:spPr>
+        <p:txBody>
+          <a:bodyPr wrap="square">
+            <a:spAutoFit/>
+          </a:bodyPr>
+          <a:lstStyle/>
+          <a:p>
+            <a:pPr algn="l">
+              <a:defRPr sz="900" b="0">
+                <a:solidFill>
+                  <a:srgbClr val="000000"/>
+                </a:solidFill>
+                <a:latin typeface="Segoe UI"/>
+              </a:defRPr>
+            </a:pPr>
+            <a:r>
+              <a:t>• Connection string change only — low risk</a:t>
+            </a:r>
+          </a:p>
+        </p:txBody>
+      </p:sp>
+      <p:sp>
+        <p:nvSpPr>
+          <p:cNvPr id="17" name="TextBox 16"/>
+          <p:cNvSpPr txBox="1"/>
+          <p:nvPr/>
+        </p:nvSpPr>
+        <p:spPr>
+          <a:xfrm>
+            <a:off x="411480" y="5294376"/>
+            <a:ext cx="5303520" cy="182880"/>
+          </a:xfrm>
+          <a:prstGeom prst="rect">
+            <a:avLst/>
+          </a:prstGeom>
+          <a:noFill/>
+        </p:spPr>
+        <p:txBody>
+          <a:bodyPr wrap="square">
+            <a:spAutoFit/>
+          </a:bodyPr>
+          <a:lstStyle/>
+          <a:p>
+            <a:pPr algn="l">
+              <a:defRPr sz="900" b="0">
+                <a:solidFill>
+                  <a:srgbClr val="000000"/>
+                </a:solidFill>
+                <a:latin typeface="Segoe UI"/>
+              </a:defRPr>
+            </a:pPr>
+            <a:r>
+              <a:t>• Faster rollout (2–4 weeks)</a:t>
+            </a:r>
+          </a:p>
+        </p:txBody>
+      </p:sp>
+      <p:sp>
+        <p:nvSpPr>
+          <p:cNvPr id="18" name="TextBox 17"/>
+          <p:cNvSpPr txBox="1"/>
+          <p:nvPr/>
+        </p:nvSpPr>
+        <p:spPr>
+          <a:xfrm>
+            <a:off x="274320" y="5504688"/>
+            <a:ext cx="5486400" cy="228600"/>
+          </a:xfrm>
+          <a:prstGeom prst="rect">
+            <a:avLst/>
+          </a:prstGeom>
+          <a:noFill/>
+        </p:spPr>
+        <p:txBody>
+          <a:bodyPr wrap="square">
+            <a:spAutoFit/>
+          </a:bodyPr>
+          <a:lstStyle/>
+          <a:p>
+            <a:pPr algn="l">
+              <a:defRPr sz="1100" b="1">
+                <a:solidFill>
+                  <a:srgbClr val="FF8C00"/>
+                </a:solidFill>
+                <a:latin typeface="Segoe UI"/>
+              </a:defRPr>
+            </a:pPr>
+            <a:r>
+              <a:t>⚠️ Cons</a:t>
+            </a:r>
+          </a:p>
+        </p:txBody>
+      </p:sp>
+      <p:sp>
+        <p:nvSpPr>
+          <p:cNvPr id="19" name="TextBox 18"/>
+          <p:cNvSpPr txBox="1"/>
+          <p:nvPr/>
+        </p:nvSpPr>
+        <p:spPr>
+          <a:xfrm>
+            <a:off x="411480" y="5715000"/>
+            <a:ext cx="5303520" cy="182880"/>
+          </a:xfrm>
+          <a:prstGeom prst="rect">
+            <a:avLst/>
+          </a:prstGeom>
+          <a:noFill/>
+        </p:spPr>
+        <p:txBody>
+          <a:bodyPr wrap="square">
+            <a:spAutoFit/>
+          </a:bodyPr>
+          <a:lstStyle/>
+          <a:p>
+            <a:pPr algn="l">
+              <a:defRPr sz="900" b="0">
+                <a:solidFill>
+                  <a:srgbClr val="000000"/>
+                </a:solidFill>
+                <a:latin typeface="Segoe UI"/>
+              </a:defRPr>
+            </a:pPr>
+            <a:r>
+              <a:t>• Keeps Longview license cost</a:t>
+            </a:r>
+          </a:p>
+        </p:txBody>
+      </p:sp>
+      <p:sp>
+        <p:nvSpPr>
+          <p:cNvPr id="20" name="TextBox 19"/>
+          <p:cNvSpPr txBox="1"/>
+          <p:nvPr/>
+        </p:nvSpPr>
+        <p:spPr>
+          <a:xfrm>
+            <a:off x="411480" y="5879592"/>
+            <a:ext cx="5303520" cy="182880"/>
+          </a:xfrm>
+          <a:prstGeom prst="rect">
+            <a:avLst/>
+          </a:prstGeom>
+          <a:noFill/>
+        </p:spPr>
+        <p:txBody>
+          <a:bodyPr wrap="square">
+            <a:spAutoFit/>
+          </a:bodyPr>
+          <a:lstStyle/>
+          <a:p>
+            <a:pPr algn="l">
+              <a:defRPr sz="900" b="0">
+                <a:solidFill>
+                  <a:srgbClr val="000000"/>
+                </a:solidFill>
+                <a:latin typeface="Segoe UI"/>
+              </a:defRPr>
+            </a:pPr>
+            <a:r>
+              <a:t>• Two tools to maintain (Longview + Power BI)</a:t>
+            </a:r>
+          </a:p>
+        </p:txBody>
+      </p:sp>
+      <p:sp>
+        <p:nvSpPr>
+          <p:cNvPr id="21" name="Rectangle 20"/>
+          <p:cNvSpPr/>
+          <p:nvPr/>
+        </p:nvSpPr>
+        <p:spPr>
+          <a:xfrm>
+            <a:off x="5989320" y="1097280"/>
+            <a:ext cx="36576" cy="5120640"/>
+          </a:xfrm>
+          <a:prstGeom prst="rect">
+            <a:avLst/>
+          </a:prstGeom>
+          <a:solidFill>
+            <a:srgbClr val="0078D4"/>
+          </a:solidFill>
+          <a:ln>
+            <a:noFill/>
+          </a:ln>
+          <a:effectLst/>
+        </p:spPr>
+        <p:style>
+          <a:lnRef idx="1">
+            <a:schemeClr val="accent1"/>
+          </a:lnRef>
+          <a:fillRef idx="3">
+            <a:schemeClr val="accent1"/>
+          </a:fillRef>
+          <a:effectRef idx="2">
+            <a:schemeClr val="accent1"/>
+          </a:effectRef>
+          <a:fontRef idx="minor">
+            <a:schemeClr val="lt1"/>
+          </a:fontRef>
+        </p:style>
+        <p:txBody>
+          <a:bodyPr rtlCol="0" anchor="ctr"/>
+          <a:lstStyle/>
+          <a:p>
+            <a:pPr algn="ctr"/>
+          </a:p>
+        </p:txBody>
+      </p:sp>
+      <p:sp>
+        <p:nvSpPr>
+          <p:cNvPr id="22" name="Oval 21"/>
+          <p:cNvSpPr/>
+          <p:nvPr/>
+        </p:nvSpPr>
+        <p:spPr>
+          <a:xfrm>
+            <a:off x="5760720" y="3429000"/>
+            <a:ext cx="502920" cy="502920"/>
+          </a:xfrm>
+          <a:prstGeom prst="ellipse">
+            <a:avLst/>
+          </a:prstGeom>
+          <a:solidFill>
+            <a:srgbClr val="0078D4"/>
+          </a:solidFill>
+          <a:ln>
+            <a:noFill/>
+          </a:ln>
+          <a:effectLst/>
+        </p:spPr>
+        <p:style>
+          <a:lnRef idx="1">
+            <a:schemeClr val="accent1"/>
+          </a:lnRef>
+          <a:fillRef idx="3">
+            <a:schemeClr val="accent1"/>
+          </a:fillRef>
+          <a:effectRef idx="2">
+            <a:schemeClr val="accent1"/>
+          </a:effectRef>
+          <a:fontRef idx="minor">
+            <a:schemeClr val="lt1"/>
+          </a:fontRef>
+        </p:style>
+        <p:txBody>
+          <a:bodyPr rtlCol="0" anchor="ctr"/>
+          <a:lstStyle/>
+          <a:p>
+            <a:pPr algn="ctr">
+              <a:defRPr sz="1200" b="1">
+                <a:solidFill>
+                  <a:srgbClr val="FFFFFF"/>
+                </a:solidFill>
+                <a:latin typeface="Segoe UI"/>
+              </a:defRPr>
+            </a:pPr>
+            <a:r>
+              <a:t>VS</a:t>
+            </a:r>
+          </a:p>
+        </p:txBody>
+      </p:sp>
+      <p:sp>
+        <p:nvSpPr>
+          <p:cNvPr id="23" name="Rounded Rectangle 22"/>
+          <p:cNvSpPr/>
+          <p:nvPr/>
+        </p:nvSpPr>
+        <p:spPr>
+          <a:xfrm>
+            <a:off x="6309360" y="1097280"/>
+            <a:ext cx="5486400" cy="457200"/>
+          </a:xfrm>
+          <a:prstGeom prst="roundRect">
+            <a:avLst/>
+          </a:prstGeom>
+          <a:solidFill>
+            <a:srgbClr val="FF8C00"/>
+          </a:solidFill>
+          <a:ln>
+            <a:noFill/>
+          </a:ln>
+          <a:effectLst/>
+        </p:spPr>
+        <p:style>
+          <a:lnRef idx="1">
+            <a:schemeClr val="accent1"/>
+          </a:lnRef>
+          <a:fillRef idx="3">
+            <a:schemeClr val="accent1"/>
+          </a:fillRef>
+          <a:effectRef idx="2">
+            <a:schemeClr val="accent1"/>
+          </a:effectRef>
+          <a:fontRef idx="minor">
+            <a:schemeClr val="lt1"/>
+          </a:fontRef>
+        </p:style>
+        <p:txBody>
+          <a:bodyPr rtlCol="0" anchor="ctr"/>
+          <a:lstStyle/>
+          <a:p>
+            <a:pPr algn="ctr">
               <a:defRPr sz="1400" b="1">
                 <a:solidFill>
-                  <a:srgbClr val="FF8C00"/>
-                </a:solidFill>
-                <a:latin typeface="Segoe UI"/>
-              </a:defRPr>
-            </a:pPr>
-            <a:r>
-              <a:t>Essbase Calc Scripts → PySpark</a:t>
+                  <a:srgbClr val="FFFFFF"/>
+                </a:solidFill>
+                <a:latin typeface="Segoe UI"/>
+              </a:defRPr>
+            </a:pPr>
+            <a:r>
+              <a:t>Option B — Power BI Writeback on SQL</a:t>
             </a:r>
           </a:p>
         </p:txBody>
       </p:sp>
       <p:graphicFrame>
         <p:nvGraphicFramePr>
-          <p:cNvPr id="7" name="Table 6"/>
+          <p:cNvPr id="24" name="Table 23"/>
           <p:cNvGraphicFramePr>
             <a:graphicFrameLocks noGrp="1"/>
           </p:cNvGraphicFramePr>
           <p:nvPr/>
         </p:nvGraphicFramePr>
         <p:xfrm>
-          <a:off x="6217920" y="1554480"/>
-          <a:ext cx="4114800" cy="2743200"/>
+          <a:off x="6309360" y="1691640"/>
+          <a:ext cx="5029200" cy="1792224"/>
         </p:xfrm>
         <a:graphic>
           <a:graphicData uri="http://schemas.openxmlformats.org/drawingml/2006/table">
@@ -15892,10 +16481,11 @@
                 <a:tableStyleId>{5C22544A-7EE6-4342-B048-85BDC9FD1C3A}</a:tableStyleId>
               </a:tblPr>
               <a:tblGrid>
-                <a:gridCol w="1828800"/>
+                <a:gridCol w="1097280"/>
+                <a:gridCol w="1645920"/>
                 <a:gridCol w="2286000"/>
               </a:tblGrid>
-              <a:tr h="274320">
+              <a:tr h="256032">
                 <a:tc>
                   <a:txBody>
                     <a:bodyPr/>
@@ -15910,7 +16500,7 @@
                         </a:defRPr>
                       </a:pPr>
                       <a:r>
-                        <a:t>Essbase Calc</a:t>
+                        <a:t>Layer</a:t>
                       </a:r>
                     </a:p>
                   </a:txBody>
@@ -15934,7 +16524,7 @@
                         </a:defRPr>
                       </a:pPr>
                       <a:r>
-                        <a:t>PySpark Equivalent</a:t>
+                        <a:t>Before</a:t>
                       </a:r>
                     </a:p>
                   </a:txBody>
@@ -15944,8 +16534,32 @@
                     </a:solidFill>
                   </a:tcPr>
                 </a:tc>
+                <a:tc>
+                  <a:txBody>
+                    <a:bodyPr/>
+                    <a:lstStyle/>
+                    <a:p>
+                      <a:pPr algn="ctr">
+                        <a:defRPr sz="1000" b="1">
+                          <a:solidFill>
+                            <a:srgbClr val="FFFFFF"/>
+                          </a:solidFill>
+                          <a:latin typeface="Segoe UI"/>
+                        </a:defRPr>
+                      </a:pPr>
+                      <a:r>
+                        <a:t>After</a:t>
+                      </a:r>
+                    </a:p>
+                  </a:txBody>
+                  <a:tcPr anchor="ctr">
+                    <a:solidFill>
+                      <a:srgbClr val="FF8C00"/>
+                    </a:solidFill>
+                  </a:tcPr>
+                </a:tc>
               </a:tr>
-              <a:tr h="274320">
+              <a:tr h="256032">
                 <a:tc>
                   <a:txBody>
                     <a:bodyPr/>
@@ -15960,7 +16574,7 @@
                         </a:defRPr>
                       </a:pPr>
                       <a:r>
-                        <a:t>AGG(Entity)</a:t>
+                        <a:t>Frontend</a:t>
                       </a:r>
                     </a:p>
                   </a:txBody>
@@ -15984,7 +16598,7 @@
                         </a:defRPr>
                       </a:pPr>
                       <a:r>
-                        <a:t>groupBy().agg(F.sum())</a:t>
+                        <a:t>Longview UI</a:t>
                       </a:r>
                     </a:p>
                   </a:txBody>
@@ -15994,8 +16608,32 @@
                     </a:solidFill>
                   </a:tcPr>
                 </a:tc>
+                <a:tc>
+                  <a:txBody>
+                    <a:bodyPr/>
+                    <a:lstStyle/>
+                    <a:p>
+                      <a:pPr algn="ctr">
+                        <a:defRPr sz="1000">
+                          <a:solidFill>
+                            <a:srgbClr val="000000"/>
+                          </a:solidFill>
+                          <a:latin typeface="Segoe UI"/>
+                        </a:defRPr>
+                      </a:pPr>
+                      <a:r>
+                        <a:t>Power BI + Power Apps</a:t>
+                      </a:r>
+                    </a:p>
+                  </a:txBody>
+                  <a:tcPr anchor="ctr">
+                    <a:solidFill>
+                      <a:srgbClr val="FFFFFF"/>
+                    </a:solidFill>
+                  </a:tcPr>
+                </a:tc>
               </a:tr>
-              <a:tr h="274320">
+              <a:tr h="256032">
                 <a:tc>
                   <a:txBody>
                     <a:bodyPr/>
@@ -16010,7 +16648,7 @@
                         </a:defRPr>
                       </a:pPr>
                       <a:r>
-                        <a:t>@ALLOCATE</a:t>
+                        <a:t>Writeback</a:t>
                       </a:r>
                     </a:p>
                   </a:txBody>
@@ -16034,7 +16672,7 @@
                         </a:defRPr>
                       </a:pPr>
                       <a:r>
-                        <a:t>Window + proportional weights</a:t>
+                        <a:t>Essbase cube</a:t>
                       </a:r>
                     </a:p>
                   </a:txBody>
@@ -16044,8 +16682,32 @@
                     </a:solidFill>
                   </a:tcPr>
                 </a:tc>
+                <a:tc>
+                  <a:txBody>
+                    <a:bodyPr/>
+                    <a:lstStyle/>
+                    <a:p>
+                      <a:pPr algn="ctr">
+                        <a:defRPr sz="1000">
+                          <a:solidFill>
+                            <a:srgbClr val="000000"/>
+                          </a:solidFill>
+                          <a:latin typeface="Segoe UI"/>
+                        </a:defRPr>
+                      </a:pPr>
+                      <a:r>
+                        <a:t>Azure SQL / Fabric WH</a:t>
+                      </a:r>
+                    </a:p>
+                  </a:txBody>
+                  <a:tcPr anchor="ctr">
+                    <a:solidFill>
+                      <a:srgbClr val="F3F2F1"/>
+                    </a:solidFill>
+                  </a:tcPr>
+                </a:tc>
               </a:tr>
-              <a:tr h="274320">
+              <a:tr h="256032">
                 <a:tc>
                   <a:txBody>
                     <a:bodyPr/>
@@ -16060,7 +16722,7 @@
                         </a:defRPr>
                       </a:pPr>
                       <a:r>
-                        <a:t>@TODATE(Period)</a:t>
+                        <a:t>Calc engine</a:t>
                       </a:r>
                     </a:p>
                   </a:txBody>
@@ -16084,7 +16746,7 @@
                         </a:defRPr>
                       </a:pPr>
                       <a:r>
-                        <a:t>cumulative sum (Window)</a:t>
+                        <a:t>Essbase scripts</a:t>
                       </a:r>
                     </a:p>
                   </a:txBody>
@@ -16094,8 +16756,32 @@
                     </a:solidFill>
                   </a:tcPr>
                 </a:tc>
+                <a:tc>
+                  <a:txBody>
+                    <a:bodyPr/>
+                    <a:lstStyle/>
+                    <a:p>
+                      <a:pPr algn="ctr">
+                        <a:defRPr sz="1000">
+                          <a:solidFill>
+                            <a:srgbClr val="000000"/>
+                          </a:solidFill>
+                          <a:latin typeface="Segoe UI"/>
+                        </a:defRPr>
+                      </a:pPr>
+                      <a:r>
+                        <a:t>SQL SP + DAX measures</a:t>
+                      </a:r>
+                    </a:p>
+                  </a:txBody>
+                  <a:tcPr anchor="ctr">
+                    <a:solidFill>
+                      <a:srgbClr val="FFFFFF"/>
+                    </a:solidFill>
+                  </a:tcPr>
+                </a:tc>
               </a:tr>
-              <a:tr h="274320">
+              <a:tr h="256032">
                 <a:tc>
                   <a:txBody>
                     <a:bodyPr/>
@@ -16110,7 +16796,7 @@
                         </a:defRPr>
                       </a:pPr>
                       <a:r>
-                        <a:t>@XREF(FXRates)</a:t>
+                        <a:t>Reporting</a:t>
                       </a:r>
                     </a:p>
                   </a:txBody>
@@ -16134,7 +16820,7 @@
                         </a:defRPr>
                       </a:pPr>
                       <a:r>
-                        <a:t>join(fx_rates, key)</a:t>
+                        <a:t>OAC / Smart View</a:t>
                       </a:r>
                     </a:p>
                   </a:txBody>
@@ -16144,8 +16830,32 @@
                     </a:solidFill>
                   </a:tcPr>
                 </a:tc>
+                <a:tc>
+                  <a:txBody>
+                    <a:bodyPr/>
+                    <a:lstStyle/>
+                    <a:p>
+                      <a:pPr algn="ctr">
+                        <a:defRPr sz="1000">
+                          <a:solidFill>
+                            <a:srgbClr val="000000"/>
+                          </a:solidFill>
+                          <a:latin typeface="Segoe UI"/>
+                        </a:defRPr>
+                      </a:pPr>
+                      <a:r>
+                        <a:t>Power BI DirectLake</a:t>
+                      </a:r>
+                    </a:p>
+                  </a:txBody>
+                  <a:tcPr anchor="ctr">
+                    <a:solidFill>
+                      <a:srgbClr val="F3F2F1"/>
+                    </a:solidFill>
+                  </a:tcPr>
+                </a:tc>
               </a:tr>
-              <a:tr h="274320">
+              <a:tr h="256032">
                 <a:tc>
                   <a:txBody>
                     <a:bodyPr/>
@@ -16160,7 +16870,7 @@
                         </a:defRPr>
                       </a:pPr>
                       <a:r>
-                        <a:t>@PRIOR(Revenue, 1)</a:t>
+                        <a:t>Security</a:t>
                       </a:r>
                     </a:p>
                   </a:txBody>
@@ -16184,7 +16894,7 @@
                         </a:defRPr>
                       </a:pPr>
                       <a:r>
-                        <a:t>F.lag().over(Window)</a:t>
+                        <a:t>Essbase filters</a:t>
                       </a:r>
                     </a:p>
                   </a:txBody>
@@ -16194,8 +16904,32 @@
                     </a:solidFill>
                   </a:tcPr>
                 </a:tc>
+                <a:tc>
+                  <a:txBody>
+                    <a:bodyPr/>
+                    <a:lstStyle/>
+                    <a:p>
+                      <a:pPr algn="ctr">
+                        <a:defRPr sz="1000">
+                          <a:solidFill>
+                            <a:srgbClr val="000000"/>
+                          </a:solidFill>
+                          <a:latin typeface="Segoe UI"/>
+                        </a:defRPr>
+                      </a:pPr>
+                      <a:r>
+                        <a:t>Entra ID + RLS</a:t>
+                      </a:r>
+                    </a:p>
+                  </a:txBody>
+                  <a:tcPr anchor="ctr">
+                    <a:solidFill>
+                      <a:srgbClr val="FFFFFF"/>
+                    </a:solidFill>
+                  </a:tcPr>
+                </a:tc>
               </a:tr>
-              <a:tr h="274320">
+              <a:tr h="256032">
                 <a:tc>
                   <a:txBody>
                     <a:bodyPr/>
@@ -16210,7 +16944,7 @@
                         </a:defRPr>
                       </a:pPr>
                       <a:r>
-                        <a:t>@SUMRANGE</a:t>
+                        <a:t>License</a:t>
                       </a:r>
                     </a:p>
                   </a:txBody>
@@ -16234,7 +16968,7 @@
                         </a:defRPr>
                       </a:pPr>
                       <a:r>
-                        <a:t>F.sum().over(rangeBetween)</a:t>
+                        <a:t>Oracle + Longview</a:t>
                       </a:r>
                     </a:p>
                   </a:txBody>
@@ -16244,8 +16978,6 @@
                     </a:solidFill>
                   </a:tcPr>
                 </a:tc>
-              </a:tr>
-              <a:tr h="274320">
                 <a:tc>
                   <a:txBody>
                     <a:bodyPr/>
@@ -16260,137 +16992,13 @@
                         </a:defRPr>
                       </a:pPr>
                       <a:r>
-                        <a:t>FIX("Budget")</a:t>
-                      </a:r>
-                    </a:p>
-                  </a:txBody>
-                  <a:tcPr anchor="ctr">
-                    <a:solidFill>
-                      <a:srgbClr val="FFFFFF"/>
-                    </a:solidFill>
-                  </a:tcPr>
-                </a:tc>
-                <a:tc>
-                  <a:txBody>
-                    <a:bodyPr/>
-                    <a:lstStyle/>
-                    <a:p>
-                      <a:pPr algn="ctr">
-                        <a:defRPr sz="1000">
-                          <a:solidFill>
-                            <a:srgbClr val="000000"/>
-                          </a:solidFill>
-                          <a:latin typeface="Segoe UI"/>
-                        </a:defRPr>
-                      </a:pPr>
-                      <a:r>
-                        <a:t>.filter(col == "Budget")</a:t>
-                      </a:r>
-                    </a:p>
-                  </a:txBody>
-                  <a:tcPr anchor="ctr">
-                    <a:solidFill>
-                      <a:srgbClr val="FFFFFF"/>
-                    </a:solidFill>
-                  </a:tcPr>
-                </a:tc>
-              </a:tr>
-              <a:tr h="274320">
-                <a:tc>
-                  <a:txBody>
-                    <a:bodyPr/>
-                    <a:lstStyle/>
-                    <a:p>
-                      <a:pPr algn="ctr">
-                        <a:defRPr sz="1000">
-                          <a:solidFill>
-                            <a:srgbClr val="000000"/>
-                          </a:solidFill>
-                          <a:latin typeface="Segoe UI"/>
-                        </a:defRPr>
-                      </a:pPr>
-                      <a:r>
-                        <a:t>DATACOPY</a:t>
+                        <a:t>Fabric + M365 (no Longview)</a:t>
                       </a:r>
                     </a:p>
                   </a:txBody>
                   <a:tcPr anchor="ctr">
                     <a:solidFill>
                       <a:srgbClr val="F3F2F1"/>
-                    </a:solidFill>
-                  </a:tcPr>
-                </a:tc>
-                <a:tc>
-                  <a:txBody>
-                    <a:bodyPr/>
-                    <a:lstStyle/>
-                    <a:p>
-                      <a:pPr algn="ctr">
-                        <a:defRPr sz="1000">
-                          <a:solidFill>
-                            <a:srgbClr val="000000"/>
-                          </a:solidFill>
-                          <a:latin typeface="Segoe UI"/>
-                        </a:defRPr>
-                      </a:pPr>
-                      <a:r>
-                        <a:t>df.write.mode("overwrite")</a:t>
-                      </a:r>
-                    </a:p>
-                  </a:txBody>
-                  <a:tcPr anchor="ctr">
-                    <a:solidFill>
-                      <a:srgbClr val="F3F2F1"/>
-                    </a:solidFill>
-                  </a:tcPr>
-                </a:tc>
-              </a:tr>
-              <a:tr h="274320">
-                <a:tc>
-                  <a:txBody>
-                    <a:bodyPr/>
-                    <a:lstStyle/>
-                    <a:p>
-                      <a:pPr algn="ctr">
-                        <a:defRPr sz="1000">
-                          <a:solidFill>
-                            <a:srgbClr val="000000"/>
-                          </a:solidFill>
-                          <a:latin typeface="Segoe UI"/>
-                        </a:defRPr>
-                      </a:pPr>
-                      <a:r>
-                        <a:t>CLEARBLOCK</a:t>
-                      </a:r>
-                    </a:p>
-                  </a:txBody>
-                  <a:tcPr anchor="ctr">
-                    <a:solidFill>
-                      <a:srgbClr val="FFFFFF"/>
-                    </a:solidFill>
-                  </a:tcPr>
-                </a:tc>
-                <a:tc>
-                  <a:txBody>
-                    <a:bodyPr/>
-                    <a:lstStyle/>
-                    <a:p>
-                      <a:pPr algn="ctr">
-                        <a:defRPr sz="1000">
-                          <a:solidFill>
-                            <a:srgbClr val="000000"/>
-                          </a:solidFill>
-                          <a:latin typeface="Segoe UI"/>
-                        </a:defRPr>
-                      </a:pPr>
-                      <a:r>
-                        <a:t>DELETE / overwrite partition</a:t>
-                      </a:r>
-                    </a:p>
-                  </a:txBody>
-                  <a:tcPr anchor="ctr">
-                    <a:solidFill>
-                      <a:srgbClr val="FFFFFF"/>
                     </a:solidFill>
                   </a:tcPr>
                 </a:tc>
@@ -16401,16 +17009,74 @@
       </p:graphicFrame>
       <p:sp>
         <p:nvSpPr>
-          <p:cNvPr id="8" name="Rectangle 7"/>
+          <p:cNvPr id="25" name="Rounded Rectangle 24"/>
           <p:cNvSpPr/>
           <p:nvPr/>
         </p:nvSpPr>
         <p:spPr>
           <a:xfrm>
-            <a:off x="0" y="4663440"/>
-            <a:ext cx="12191695" cy="45720"/>
-          </a:xfrm>
-          <a:prstGeom prst="rect">
+            <a:off x="6400800" y="3794760"/>
+            <a:ext cx="1143000" cy="640080"/>
+          </a:xfrm>
+          <a:prstGeom prst="roundRect">
+            <a:avLst/>
+          </a:prstGeom>
+          <a:solidFill>
+            <a:srgbClr val="6B2D8B"/>
+          </a:solidFill>
+          <a:ln>
+            <a:noFill/>
+          </a:ln>
+          <a:effectLst/>
+        </p:spPr>
+        <p:style>
+          <a:lnRef idx="1">
+            <a:schemeClr val="accent1"/>
+          </a:lnRef>
+          <a:fillRef idx="3">
+            <a:schemeClr val="accent1"/>
+          </a:fillRef>
+          <a:effectRef idx="2">
+            <a:schemeClr val="accent1"/>
+          </a:effectRef>
+          <a:fontRef idx="minor">
+            <a:schemeClr val="lt1"/>
+          </a:fontRef>
+        </p:style>
+        <p:txBody>
+          <a:bodyPr rtlCol="0" anchor="ctr" wrap="square"/>
+          <a:lstStyle/>
+          <a:p>
+            <a:pPr algn="ctr">
+              <a:defRPr sz="900" b="1">
+                <a:solidFill>
+                  <a:srgbClr val="FFFFFF"/>
+                </a:solidFill>
+                <a:latin typeface="Segoe UI"/>
+              </a:defRPr>
+            </a:pPr>
+            <a:r>
+              <a:t>Power BI</a:t>
+            </a:r>
+            <a:br/>
+            <a:r>
+              <a:t>+ Power Apps</a:t>
+            </a:r>
+          </a:p>
+        </p:txBody>
+      </p:sp>
+      <p:sp>
+        <p:nvSpPr>
+          <p:cNvPr id="26" name="Rounded Rectangle 25"/>
+          <p:cNvSpPr/>
+          <p:nvPr/>
+        </p:nvSpPr>
+        <p:spPr>
+          <a:xfrm>
+            <a:off x="7680960" y="3794760"/>
+            <a:ext cx="1143000" cy="640080"/>
+          </a:xfrm>
+          <a:prstGeom prst="roundRect">
             <a:avLst/>
           </a:prstGeom>
           <a:solidFill>
@@ -16436,175 +17102,37 @@
           </a:fontRef>
         </p:style>
         <p:txBody>
-          <a:bodyPr rtlCol="0" anchor="ctr"/>
-          <a:lstStyle/>
-          <a:p>
-            <a:pPr algn="ctr"/>
-          </a:p>
-        </p:txBody>
-      </p:sp>
-      <p:sp>
-        <p:nvSpPr>
-          <p:cNvPr id="9" name="TextBox 8"/>
-          <p:cNvSpPr txBox="1"/>
-          <p:nvPr/>
-        </p:nvSpPr>
-        <p:spPr>
-          <a:xfrm>
-            <a:off x="457200" y="4754880"/>
-            <a:ext cx="10972800" cy="320040"/>
-          </a:xfrm>
-          <a:prstGeom prst="rect">
-            <a:avLst/>
-          </a:prstGeom>
-          <a:noFill/>
-        </p:spPr>
-        <p:txBody>
-          <a:bodyPr wrap="square">
-            <a:spAutoFit/>
-          </a:bodyPr>
-          <a:lstStyle/>
-          <a:p>
-            <a:pPr algn="l">
-              <a:defRPr sz="1400" b="1">
-                <a:solidFill>
-                  <a:srgbClr val="002B5C"/>
-                </a:solidFill>
-                <a:latin typeface="Segoe UI"/>
-              </a:defRPr>
-            </a:pPr>
-            <a:r>
-              <a:t>Fabric Writeback Pipeline (4 stages)</a:t>
-            </a:r>
-          </a:p>
-        </p:txBody>
-      </p:sp>
-      <p:sp>
-        <p:nvSpPr>
-          <p:cNvPr id="10" name="Rounded Rectangle 9"/>
+          <a:bodyPr rtlCol="0" anchor="ctr" wrap="square"/>
+          <a:lstStyle/>
+          <a:p>
+            <a:pPr algn="ctr">
+              <a:defRPr sz="900" b="1">
+                <a:solidFill>
+                  <a:srgbClr val="FFFFFF"/>
+                </a:solidFill>
+                <a:latin typeface="Segoe UI"/>
+              </a:defRPr>
+            </a:pPr>
+            <a:r>
+              <a:t>Azure SQL /</a:t>
+            </a:r>
+            <a:br/>
+            <a:r>
+              <a:t>Fabric WH</a:t>
+            </a:r>
+          </a:p>
+        </p:txBody>
+      </p:sp>
+      <p:sp>
+        <p:nvSpPr>
+          <p:cNvPr id="27" name="Rounded Rectangle 26"/>
           <p:cNvSpPr/>
           <p:nvPr/>
         </p:nvSpPr>
         <p:spPr>
           <a:xfrm>
-            <a:off x="457200" y="5120640"/>
-            <a:ext cx="2011680" cy="914400"/>
-          </a:xfrm>
-          <a:prstGeom prst="roundRect">
-            <a:avLst/>
-          </a:prstGeom>
-          <a:solidFill>
-            <a:srgbClr val="6B2D8B"/>
-          </a:solidFill>
-          <a:ln>
-            <a:noFill/>
-          </a:ln>
-          <a:effectLst/>
-        </p:spPr>
-        <p:style>
-          <a:lnRef idx="1">
-            <a:schemeClr val="accent1"/>
-          </a:lnRef>
-          <a:fillRef idx="3">
-            <a:schemeClr val="accent1"/>
-          </a:fillRef>
-          <a:effectRef idx="2">
-            <a:schemeClr val="accent1"/>
-          </a:effectRef>
-          <a:fontRef idx="minor">
-            <a:schemeClr val="lt1"/>
-          </a:fontRef>
-        </p:style>
-        <p:txBody>
-          <a:bodyPr rtlCol="0" anchor="ctr" wrap="square"/>
-          <a:lstStyle/>
-          <a:p>
-            <a:pPr algn="ctr">
-              <a:defRPr sz="1000" b="1">
-                <a:solidFill>
-                  <a:srgbClr val="FFFFFF"/>
-                </a:solidFill>
-                <a:latin typeface="Segoe UI"/>
-              </a:defRPr>
-            </a:pPr>
-            <a:r>
-              <a:t>Longview</a:t>
-            </a:r>
-            <a:br/>
-            <a:r>
-              <a:t>writeback</a:t>
-            </a:r>
-          </a:p>
-        </p:txBody>
-      </p:sp>
-      <p:sp>
-        <p:nvSpPr>
-          <p:cNvPr id="11" name="Rounded Rectangle 10"/>
-          <p:cNvSpPr/>
-          <p:nvPr/>
-        </p:nvSpPr>
-        <p:spPr>
-          <a:xfrm>
-            <a:off x="2743200" y="5120640"/>
-            <a:ext cx="2011680" cy="914400"/>
-          </a:xfrm>
-          <a:prstGeom prst="roundRect">
-            <a:avLst/>
-          </a:prstGeom>
-          <a:solidFill>
-            <a:srgbClr val="0078D4"/>
-          </a:solidFill>
-          <a:ln>
-            <a:noFill/>
-          </a:ln>
-          <a:effectLst/>
-        </p:spPr>
-        <p:style>
-          <a:lnRef idx="1">
-            <a:schemeClr val="accent1"/>
-          </a:lnRef>
-          <a:fillRef idx="3">
-            <a:schemeClr val="accent1"/>
-          </a:fillRef>
-          <a:effectRef idx="2">
-            <a:schemeClr val="accent1"/>
-          </a:effectRef>
-          <a:fontRef idx="minor">
-            <a:schemeClr val="lt1"/>
-          </a:fontRef>
-        </p:style>
-        <p:txBody>
-          <a:bodyPr rtlCol="0" anchor="ctr" wrap="square"/>
-          <a:lstStyle/>
-          <a:p>
-            <a:pPr algn="ctr">
-              <a:defRPr sz="1000" b="1">
-                <a:solidFill>
-                  <a:srgbClr val="FFFFFF"/>
-                </a:solidFill>
-                <a:latin typeface="Segoe UI"/>
-              </a:defRPr>
-            </a:pPr>
-            <a:r>
-              <a:t>Fabric Warehouse</a:t>
-            </a:r>
-            <a:br/>
-            <a:r>
-              <a:t>(TDS endpoint)</a:t>
-            </a:r>
-          </a:p>
-        </p:txBody>
-      </p:sp>
-      <p:sp>
-        <p:nvSpPr>
-          <p:cNvPr id="12" name="Rounded Rectangle 11"/>
-          <p:cNvSpPr/>
-          <p:nvPr/>
-        </p:nvSpPr>
-        <p:spPr>
-          <a:xfrm>
-            <a:off x="5029200" y="5120640"/>
-            <a:ext cx="2011680" cy="914400"/>
+            <a:off x="8961120" y="3794760"/>
+            <a:ext cx="1143000" cy="640080"/>
           </a:xfrm>
           <a:prstGeom prst="roundRect">
             <a:avLst/>
@@ -16636,7 +17164,7 @@
           <a:lstStyle/>
           <a:p>
             <a:pPr algn="ctr">
-              <a:defRPr sz="1000" b="1">
+              <a:defRPr sz="900" b="1">
                 <a:solidFill>
                   <a:srgbClr val="FFFFFF"/>
                 </a:solidFill>
@@ -16644,83 +17172,25 @@
               </a:defRPr>
             </a:pPr>
             <a:r>
-              <a:t>PySpark Notebook</a:t>
+              <a:t>SQL SPs</a:t>
             </a:r>
             <a:br/>
             <a:r>
-              <a:t>(AGG, ALLOCATE)</a:t>
-            </a:r>
-          </a:p>
-        </p:txBody>
-      </p:sp>
-      <p:sp>
-        <p:nvSpPr>
-          <p:cNvPr id="13" name="Rounded Rectangle 12"/>
+              <a:t>+ DAX</a:t>
+            </a:r>
+          </a:p>
+        </p:txBody>
+      </p:sp>
+      <p:sp>
+        <p:nvSpPr>
+          <p:cNvPr id="28" name="Rounded Rectangle 27"/>
           <p:cNvSpPr/>
           <p:nvPr/>
         </p:nvSpPr>
         <p:spPr>
           <a:xfrm>
-            <a:off x="7315200" y="5120640"/>
-            <a:ext cx="2011680" cy="914400"/>
-          </a:xfrm>
-          <a:prstGeom prst="roundRect">
-            <a:avLst/>
-          </a:prstGeom>
-          <a:solidFill>
-            <a:srgbClr val="00B7C3"/>
-          </a:solidFill>
-          <a:ln>
-            <a:noFill/>
-          </a:ln>
-          <a:effectLst/>
-        </p:spPr>
-        <p:style>
-          <a:lnRef idx="1">
-            <a:schemeClr val="accent1"/>
-          </a:lnRef>
-          <a:fillRef idx="3">
-            <a:schemeClr val="accent1"/>
-          </a:fillRef>
-          <a:effectRef idx="2">
-            <a:schemeClr val="accent1"/>
-          </a:effectRef>
-          <a:fontRef idx="minor">
-            <a:schemeClr val="lt1"/>
-          </a:fontRef>
-        </p:style>
-        <p:txBody>
-          <a:bodyPr rtlCol="0" anchor="ctr" wrap="square"/>
-          <a:lstStyle/>
-          <a:p>
-            <a:pPr algn="ctr">
-              <a:defRPr sz="1000" b="1">
-                <a:solidFill>
-                  <a:srgbClr val="FFFFFF"/>
-                </a:solidFill>
-                <a:latin typeface="Segoe UI"/>
-              </a:defRPr>
-            </a:pPr>
-            <a:r>
-              <a:t>Validation</a:t>
-            </a:r>
-            <a:br/>
-            <a:r>
-              <a:t>Stored Proc</a:t>
-            </a:r>
-          </a:p>
-        </p:txBody>
-      </p:sp>
-      <p:sp>
-        <p:nvSpPr>
-          <p:cNvPr id="14" name="Rounded Rectangle 13"/>
-          <p:cNvSpPr/>
-          <p:nvPr/>
-        </p:nvSpPr>
-        <p:spPr>
-          <a:xfrm>
-            <a:off x="9601200" y="5120640"/>
-            <a:ext cx="2011680" cy="914400"/>
+            <a:off x="10241280" y="3794760"/>
+            <a:ext cx="1143000" cy="640080"/>
           </a:xfrm>
           <a:prstGeom prst="roundRect">
             <a:avLst/>
@@ -16752,7 +17222,7 @@
           <a:lstStyle/>
           <a:p>
             <a:pPr algn="ctr">
-              <a:defRPr sz="1000" b="1">
+              <a:defRPr sz="900" b="1">
                 <a:solidFill>
                   <a:srgbClr val="FFFFFF"/>
                 </a:solidFill>
@@ -16764,21 +17234,21 @@
             </a:r>
             <a:br/>
             <a:r>
-              <a:t>Semantic Model</a:t>
-            </a:r>
-          </a:p>
-        </p:txBody>
-      </p:sp>
-      <p:sp>
-        <p:nvSpPr>
-          <p:cNvPr id="15" name="TextBox 14"/>
+              <a:t>Power BI</a:t>
+            </a:r>
+          </a:p>
+        </p:txBody>
+      </p:sp>
+      <p:sp>
+        <p:nvSpPr>
+          <p:cNvPr id="29" name="TextBox 28"/>
           <p:cNvSpPr txBox="1"/>
           <p:nvPr/>
         </p:nvSpPr>
         <p:spPr>
           <a:xfrm>
-            <a:off x="2468880" y="5349240"/>
-            <a:ext cx="274320" cy="365760"/>
+            <a:off x="7543800" y="3886200"/>
+            <a:ext cx="137160" cy="365760"/>
           </a:xfrm>
           <a:prstGeom prst="rect">
             <a:avLst/>
@@ -16792,7 +17262,7 @@
           <a:lstStyle/>
           <a:p>
             <a:pPr algn="ctr">
-              <a:defRPr sz="2000" b="1">
+              <a:defRPr sz="1400" b="1">
                 <a:solidFill>
                   <a:srgbClr val="002B5C"/>
                 </a:solidFill>
@@ -16807,14 +17277,14 @@
       </p:sp>
       <p:sp>
         <p:nvSpPr>
-          <p:cNvPr id="16" name="TextBox 15"/>
+          <p:cNvPr id="30" name="TextBox 29"/>
           <p:cNvSpPr txBox="1"/>
           <p:nvPr/>
         </p:nvSpPr>
         <p:spPr>
           <a:xfrm>
-            <a:off x="4754880" y="5349240"/>
-            <a:ext cx="274320" cy="365760"/>
+            <a:off x="8823960" y="3886200"/>
+            <a:ext cx="137160" cy="365760"/>
           </a:xfrm>
           <a:prstGeom prst="rect">
             <a:avLst/>
@@ -16828,7 +17298,7 @@
           <a:lstStyle/>
           <a:p>
             <a:pPr algn="ctr">
-              <a:defRPr sz="2000" b="1">
+              <a:defRPr sz="1400" b="1">
                 <a:solidFill>
                   <a:srgbClr val="002B5C"/>
                 </a:solidFill>
@@ -16843,14 +17313,14 @@
       </p:sp>
       <p:sp>
         <p:nvSpPr>
-          <p:cNvPr id="17" name="TextBox 16"/>
+          <p:cNvPr id="31" name="TextBox 30"/>
           <p:cNvSpPr txBox="1"/>
           <p:nvPr/>
         </p:nvSpPr>
         <p:spPr>
           <a:xfrm>
-            <a:off x="7040880" y="5349240"/>
-            <a:ext cx="274320" cy="365760"/>
+            <a:off x="10104120" y="3886200"/>
+            <a:ext cx="137160" cy="365760"/>
           </a:xfrm>
           <a:prstGeom prst="rect">
             <a:avLst/>
@@ -16864,7 +17334,7 @@
           <a:lstStyle/>
           <a:p>
             <a:pPr algn="ctr">
-              <a:defRPr sz="2000" b="1">
+              <a:defRPr sz="1400" b="1">
                 <a:solidFill>
                   <a:srgbClr val="002B5C"/>
                 </a:solidFill>
@@ -16879,14 +17349,14 @@
       </p:sp>
       <p:sp>
         <p:nvSpPr>
-          <p:cNvPr id="18" name="TextBox 17"/>
+          <p:cNvPr id="32" name="TextBox 31"/>
           <p:cNvSpPr txBox="1"/>
           <p:nvPr/>
         </p:nvSpPr>
         <p:spPr>
           <a:xfrm>
-            <a:off x="9326880" y="5349240"/>
-            <a:ext cx="274320" cy="365760"/>
+            <a:off x="6309360" y="4572000"/>
+            <a:ext cx="5486400" cy="228600"/>
           </a:xfrm>
           <a:prstGeom prst="rect">
             <a:avLst/>
@@ -16899,30 +17369,30 @@
           </a:bodyPr>
           <a:lstStyle/>
           <a:p>
-            <a:pPr algn="ctr">
-              <a:defRPr sz="2000" b="1">
-                <a:solidFill>
-                  <a:srgbClr val="002B5C"/>
-                </a:solidFill>
-                <a:latin typeface="Segoe UI"/>
-              </a:defRPr>
-            </a:pPr>
-            <a:r>
-              <a:t>→</a:t>
-            </a:r>
-          </a:p>
-        </p:txBody>
-      </p:sp>
-      <p:sp>
-        <p:nvSpPr>
-          <p:cNvPr id="19" name="TextBox 18"/>
+            <a:pPr algn="l">
+              <a:defRPr sz="1100" b="1">
+                <a:solidFill>
+                  <a:srgbClr val="107C10"/>
+                </a:solidFill>
+                <a:latin typeface="Segoe UI"/>
+              </a:defRPr>
+            </a:pPr>
+            <a:r>
+              <a:t>✅ Pros</a:t>
+            </a:r>
+          </a:p>
+        </p:txBody>
+      </p:sp>
+      <p:sp>
+        <p:nvSpPr>
+          <p:cNvPr id="33" name="TextBox 32"/>
           <p:cNvSpPr txBox="1"/>
           <p:nvPr/>
         </p:nvSpPr>
         <p:spPr>
           <a:xfrm>
-            <a:off x="457200" y="6217920"/>
-            <a:ext cx="10972800" cy="274320"/>
+            <a:off x="6446520" y="4800600"/>
+            <a:ext cx="5303520" cy="182880"/>
           </a:xfrm>
           <a:prstGeom prst="rect">
             <a:avLst/>
@@ -16936,15 +17406,321 @@
           <a:lstStyle/>
           <a:p>
             <a:pPr algn="l">
+              <a:defRPr sz="900" b="0">
+                <a:solidFill>
+                  <a:srgbClr val="000000"/>
+                </a:solidFill>
+                <a:latin typeface="Segoe UI"/>
+              </a:defRPr>
+            </a:pPr>
+            <a:r>
+              <a:t>• Eliminates both Oracle AND Longview licensing</a:t>
+            </a:r>
+          </a:p>
+        </p:txBody>
+      </p:sp>
+      <p:sp>
+        <p:nvSpPr>
+          <p:cNvPr id="34" name="TextBox 33"/>
+          <p:cNvSpPr txBox="1"/>
+          <p:nvPr/>
+        </p:nvSpPr>
+        <p:spPr>
+          <a:xfrm>
+            <a:off x="6446520" y="4965192"/>
+            <a:ext cx="5303520" cy="182880"/>
+          </a:xfrm>
+          <a:prstGeom prst="rect">
+            <a:avLst/>
+          </a:prstGeom>
+          <a:noFill/>
+        </p:spPr>
+        <p:txBody>
+          <a:bodyPr wrap="square">
+            <a:spAutoFit/>
+          </a:bodyPr>
+          <a:lstStyle/>
+          <a:p>
+            <a:pPr algn="l">
+              <a:defRPr sz="900" b="0">
+                <a:solidFill>
+                  <a:srgbClr val="000000"/>
+                </a:solidFill>
+                <a:latin typeface="Segoe UI"/>
+              </a:defRPr>
+            </a:pPr>
+            <a:r>
+              <a:t>• Single platform (Microsoft stack end-to-end)</a:t>
+            </a:r>
+          </a:p>
+        </p:txBody>
+      </p:sp>
+      <p:sp>
+        <p:nvSpPr>
+          <p:cNvPr id="35" name="TextBox 34"/>
+          <p:cNvSpPr txBox="1"/>
+          <p:nvPr/>
+        </p:nvSpPr>
+        <p:spPr>
+          <a:xfrm>
+            <a:off x="6446520" y="5129784"/>
+            <a:ext cx="5303520" cy="182880"/>
+          </a:xfrm>
+          <a:prstGeom prst="rect">
+            <a:avLst/>
+          </a:prstGeom>
+          <a:noFill/>
+        </p:spPr>
+        <p:txBody>
+          <a:bodyPr wrap="square">
+            <a:spAutoFit/>
+          </a:bodyPr>
+          <a:lstStyle/>
+          <a:p>
+            <a:pPr algn="l">
+              <a:defRPr sz="900" b="0">
+                <a:solidFill>
+                  <a:srgbClr val="000000"/>
+                </a:solidFill>
+                <a:latin typeface="Segoe UI"/>
+              </a:defRPr>
+            </a:pPr>
+            <a:r>
+              <a:t>• Power Apps forms for budget input (modern UX)</a:t>
+            </a:r>
+          </a:p>
+        </p:txBody>
+      </p:sp>
+      <p:sp>
+        <p:nvSpPr>
+          <p:cNvPr id="36" name="TextBox 35"/>
+          <p:cNvSpPr txBox="1"/>
+          <p:nvPr/>
+        </p:nvSpPr>
+        <p:spPr>
+          <a:xfrm>
+            <a:off x="6446520" y="5294376"/>
+            <a:ext cx="5303520" cy="182880"/>
+          </a:xfrm>
+          <a:prstGeom prst="rect">
+            <a:avLst/>
+          </a:prstGeom>
+          <a:noFill/>
+        </p:spPr>
+        <p:txBody>
+          <a:bodyPr wrap="square">
+            <a:spAutoFit/>
+          </a:bodyPr>
+          <a:lstStyle/>
+          <a:p>
+            <a:pPr algn="l">
+              <a:defRPr sz="900" b="0">
+                <a:solidFill>
+                  <a:srgbClr val="000000"/>
+                </a:solidFill>
+                <a:latin typeface="Segoe UI"/>
+              </a:defRPr>
+            </a:pPr>
+            <a:r>
+              <a:t>• Lower total cost of ownership long-term</a:t>
+            </a:r>
+          </a:p>
+        </p:txBody>
+      </p:sp>
+      <p:sp>
+        <p:nvSpPr>
+          <p:cNvPr id="37" name="TextBox 36"/>
+          <p:cNvSpPr txBox="1"/>
+          <p:nvPr/>
+        </p:nvSpPr>
+        <p:spPr>
+          <a:xfrm>
+            <a:off x="6309360" y="5504688"/>
+            <a:ext cx="5486400" cy="228600"/>
+          </a:xfrm>
+          <a:prstGeom prst="rect">
+            <a:avLst/>
+          </a:prstGeom>
+          <a:noFill/>
+        </p:spPr>
+        <p:txBody>
+          <a:bodyPr wrap="square">
+            <a:spAutoFit/>
+          </a:bodyPr>
+          <a:lstStyle/>
+          <a:p>
+            <a:pPr algn="l">
               <a:defRPr sz="1100" b="1">
                 <a:solidFill>
-                  <a:srgbClr val="002B5C"/>
-                </a:solidFill>
-                <a:latin typeface="Segoe UI"/>
-              </a:defRPr>
-            </a:pPr>
-            <a:r>
-              <a:t>✓ Zero Longview code changes   •   ✓ Eliminates Oracle licensing   •   ✓ 40 automated tests   •   ✓ Audit trail built-in   •   ✓ Power BI reporting on same data</a:t>
+                  <a:srgbClr val="FF8C00"/>
+                </a:solidFill>
+                <a:latin typeface="Segoe UI"/>
+              </a:defRPr>
+            </a:pPr>
+            <a:r>
+              <a:t>⚠️ Cons</a:t>
+            </a:r>
+          </a:p>
+        </p:txBody>
+      </p:sp>
+      <p:sp>
+        <p:nvSpPr>
+          <p:cNvPr id="38" name="TextBox 37"/>
+          <p:cNvSpPr txBox="1"/>
+          <p:nvPr/>
+        </p:nvSpPr>
+        <p:spPr>
+          <a:xfrm>
+            <a:off x="6446520" y="5715000"/>
+            <a:ext cx="5303520" cy="182880"/>
+          </a:xfrm>
+          <a:prstGeom prst="rect">
+            <a:avLst/>
+          </a:prstGeom>
+          <a:noFill/>
+        </p:spPr>
+        <p:txBody>
+          <a:bodyPr wrap="square">
+            <a:spAutoFit/>
+          </a:bodyPr>
+          <a:lstStyle/>
+          <a:p>
+            <a:pPr algn="l">
+              <a:defRPr sz="900" b="0">
+                <a:solidFill>
+                  <a:srgbClr val="000000"/>
+                </a:solidFill>
+                <a:latin typeface="Segoe UI"/>
+              </a:defRPr>
+            </a:pPr>
+            <a:r>
+              <a:t>• Longview forms/workflows must be rebuilt in Power Apps</a:t>
+            </a:r>
+          </a:p>
+        </p:txBody>
+      </p:sp>
+      <p:sp>
+        <p:nvSpPr>
+          <p:cNvPr id="39" name="TextBox 38"/>
+          <p:cNvSpPr txBox="1"/>
+          <p:nvPr/>
+        </p:nvSpPr>
+        <p:spPr>
+          <a:xfrm>
+            <a:off x="6446520" y="5879592"/>
+            <a:ext cx="5303520" cy="182880"/>
+          </a:xfrm>
+          <a:prstGeom prst="rect">
+            <a:avLst/>
+          </a:prstGeom>
+          <a:noFill/>
+        </p:spPr>
+        <p:txBody>
+          <a:bodyPr wrap="square">
+            <a:spAutoFit/>
+          </a:bodyPr>
+          <a:lstStyle/>
+          <a:p>
+            <a:pPr algn="l">
+              <a:defRPr sz="900" b="0">
+                <a:solidFill>
+                  <a:srgbClr val="000000"/>
+                </a:solidFill>
+                <a:latin typeface="Segoe UI"/>
+              </a:defRPr>
+            </a:pPr>
+            <a:r>
+              <a:t>• Longer migration (6–10 weeks)</a:t>
+            </a:r>
+          </a:p>
+        </p:txBody>
+      </p:sp>
+      <p:sp>
+        <p:nvSpPr>
+          <p:cNvPr id="40" name="TextBox 39"/>
+          <p:cNvSpPr txBox="1"/>
+          <p:nvPr/>
+        </p:nvSpPr>
+        <p:spPr>
+          <a:xfrm>
+            <a:off x="6446520" y="6044184"/>
+            <a:ext cx="5303520" cy="182880"/>
+          </a:xfrm>
+          <a:prstGeom prst="rect">
+            <a:avLst/>
+          </a:prstGeom>
+          <a:noFill/>
+        </p:spPr>
+        <p:txBody>
+          <a:bodyPr wrap="square">
+            <a:spAutoFit/>
+          </a:bodyPr>
+          <a:lstStyle/>
+          <a:p>
+            <a:pPr algn="l">
+              <a:defRPr sz="900" b="0">
+                <a:solidFill>
+                  <a:srgbClr val="000000"/>
+                </a:solidFill>
+                <a:latin typeface="Segoe UI"/>
+              </a:defRPr>
+            </a:pPr>
+            <a:r>
+              <a:t>• User retraining required</a:t>
+            </a:r>
+          </a:p>
+        </p:txBody>
+      </p:sp>
+      <p:sp>
+        <p:nvSpPr>
+          <p:cNvPr id="41" name="Rounded Rectangle 40"/>
+          <p:cNvSpPr/>
+          <p:nvPr/>
+        </p:nvSpPr>
+        <p:spPr>
+          <a:xfrm>
+            <a:off x="274320" y="6355080"/>
+            <a:ext cx="11612880" cy="411480"/>
+          </a:xfrm>
+          <a:prstGeom prst="roundRect">
+            <a:avLst/>
+          </a:prstGeom>
+          <a:solidFill>
+            <a:srgbClr val="002B5C"/>
+          </a:solidFill>
+          <a:ln>
+            <a:noFill/>
+          </a:ln>
+          <a:effectLst/>
+        </p:spPr>
+        <p:style>
+          <a:lnRef idx="1">
+            <a:schemeClr val="accent1"/>
+          </a:lnRef>
+          <a:fillRef idx="3">
+            <a:schemeClr val="accent1"/>
+          </a:fillRef>
+          <a:effectRef idx="2">
+            <a:schemeClr val="accent1"/>
+          </a:effectRef>
+          <a:fontRef idx="minor">
+            <a:schemeClr val="lt1"/>
+          </a:fontRef>
+        </p:style>
+        <p:txBody>
+          <a:bodyPr rtlCol="0" anchor="ctr"/>
+          <a:lstStyle/>
+          <a:p>
+            <a:pPr algn="ctr">
+              <a:defRPr sz="1100" b="1">
+                <a:solidFill>
+                  <a:srgbClr val="FFFFFF"/>
+                </a:solidFill>
+                <a:latin typeface="Segoe UI"/>
+              </a:defRPr>
+            </a:pPr>
+            <a:r>
+              <a:t>💡 Recommendation:  Option A for quick wins (keep Longview, swap Essbase in weeks)  →  Option B as a phased follow-up (retire Longview, consolidate on Power BI)</a:t>
             </a:r>
           </a:p>
         </p:txBody>

</xml_diff>